<commit_message>
Add same-K with/without EKI comparison (Monte Carlo) to FCN weekly
Co-Authored-By: Claude Fable 5 <noreply@anthropic.com>
Claude-Session: https://claude.ai/code/session_01GD397krbJR1Gef3zPEk8sc
</commit_message>
<xml_diff>
--- a/_draft_fcn_weekly_2026-07-03.pptx
+++ b/_draft_fcn_weekly_2026-07-03.pptx
@@ -13,6 +13,7 @@
     <p:sldId id="261" r:id="rId12"/>
     <p:sldId id="262" r:id="rId13"/>
     <p:sldId id="263" r:id="rId14"/>
+    <p:sldId id="264" r:id="rId15"/>
   </p:sldIdLst>
   <p:sldSz cx="12191695" cy="6858000" type="screen4x3"/>
   <p:notesSz cx="6858000" cy="9144000"/>
@@ -9837,6 +9838,1435 @@
                 </a:solidFill>
                 <a:latin typeface="微軟正黑體"/>
               </a:rPr>
+              <a:t>四之二  同 K 對照 — 加 EKI 的前後差異</a:t>
+            </a:r>
+            <a:r>
+              <a:rPr sz="1200" b="0">
+                <a:solidFill>
+                  <a:srgbClr val="555555"/>
+                </a:solidFill>
+                <a:latin typeface="微軟正黑體"/>
+              </a:rPr>
+              <a:t>   Monte Carlo · σ=40% · 6M · EKI 65% 到期觀察 · 非年化</a:t>
+            </a:r>
+          </a:p>
+        </p:txBody>
+      </p:sp>
+      <p:graphicFrame>
+        <p:nvGraphicFramePr>
+          <p:cNvPr id="6" name="Table 5"/>
+          <p:cNvGraphicFramePr>
+            <a:graphicFrameLocks noGrp="1"/>
+          </p:cNvGraphicFramePr>
+          <p:nvPr/>
+        </p:nvGraphicFramePr>
+        <p:xfrm>
+          <a:off x="502920" y="1188720"/>
+          <a:ext cx="6675120" cy="3108960"/>
+        </p:xfrm>
+        <a:graphic>
+          <a:graphicData uri="http://schemas.openxmlformats.org/drawingml/2006/table">
+            <a:tbl>
+              <a:tblPr>
+                <a:tableStyleId>{5C22544A-7EE6-4342-B048-85BDC9FD1C3A}</a:tableStyleId>
+              </a:tblPr>
+              <a:tblGrid>
+                <a:gridCol w="731520"/>
+                <a:gridCol w="1143000"/>
+                <a:gridCol w="1051560"/>
+                <a:gridCol w="1280160"/>
+                <a:gridCol w="1280160"/>
+                <a:gridCol w="1188720"/>
+              </a:tblGrid>
+              <a:tr h="444137">
+                <a:tc>
+                  <a:txBody>
+                    <a:bodyPr/>
+                    <a:lstStyle/>
+                    <a:p>
+                      <a:pPr algn="r"/>
+                      <a:r>
+                        <a:rPr sz="1050" b="1">
+                          <a:solidFill>
+                            <a:srgbClr val="FFFFFF"/>
+                          </a:solidFill>
+                          <a:latin typeface="微軟正黑體"/>
+                        </a:rPr>
+                        <a:t>K</a:t>
+                      </a:r>
+                    </a:p>
+                  </a:txBody>
+                  <a:tcPr marL="45720" marR="45720" marT="18288" marB="18288">
+                    <a:solidFill>
+                      <a:srgbClr val="00295C"/>
+                    </a:solidFill>
+                  </a:tcPr>
+                </a:tc>
+                <a:tc>
+                  <a:txBody>
+                    <a:bodyPr/>
+                    <a:lstStyle/>
+                    <a:p>
+                      <a:pPr algn="l"/>
+                      <a:r>
+                        <a:rPr sz="1050" b="1">
+                          <a:solidFill>
+                            <a:srgbClr val="FFFFFF"/>
+                          </a:solidFill>
+                          <a:latin typeface="微軟正黑體"/>
+                        </a:rPr>
+                        <a:t>結構</a:t>
+                      </a:r>
+                    </a:p>
+                  </a:txBody>
+                  <a:tcPr marL="45720" marR="45720" marT="18288" marB="18288">
+                    <a:solidFill>
+                      <a:srgbClr val="00295C"/>
+                    </a:solidFill>
+                  </a:tcPr>
+                </a:tc>
+                <a:tc>
+                  <a:txBody>
+                    <a:bodyPr/>
+                    <a:lstStyle/>
+                    <a:p>
+                      <a:pPr algn="r"/>
+                      <a:r>
+                        <a:rPr sz="1050" b="1">
+                          <a:solidFill>
+                            <a:srgbClr val="FFFFFF"/>
+                          </a:solidFill>
+                          <a:latin typeface="微軟正黑體"/>
+                        </a:rPr>
+                        <a:t>轉換機率</a:t>
+                      </a:r>
+                    </a:p>
+                  </a:txBody>
+                  <a:tcPr marL="45720" marR="45720" marT="18288" marB="18288">
+                    <a:solidFill>
+                      <a:srgbClr val="00295C"/>
+                    </a:solidFill>
+                  </a:tcPr>
+                </a:tc>
+                <a:tc>
+                  <a:txBody>
+                    <a:bodyPr/>
+                    <a:lstStyle/>
+                    <a:p>
+                      <a:pPr algn="r"/>
+                      <a:r>
+                        <a:rPr sz="1050" b="1">
+                          <a:solidFill>
+                            <a:srgbClr val="FFFFFF"/>
+                          </a:solidFill>
+                          <a:latin typeface="微軟正黑體"/>
+                        </a:rPr>
+                        <a:t>轉換時平均損失</a:t>
+                      </a:r>
+                    </a:p>
+                  </a:txBody>
+                  <a:tcPr marL="45720" marR="45720" marT="18288" marB="18288">
+                    <a:solidFill>
+                      <a:srgbClr val="00295C"/>
+                    </a:solidFill>
+                  </a:tcPr>
+                </a:tc>
+                <a:tc>
+                  <a:txBody>
+                    <a:bodyPr/>
+                    <a:lstStyle/>
+                    <a:p>
+                      <a:pPr algn="r"/>
+                      <a:r>
+                        <a:rPr sz="1050" b="1">
+                          <a:solidFill>
+                            <a:srgbClr val="FFFFFF"/>
+                          </a:solidFill>
+                          <a:latin typeface="微軟正黑體"/>
+                        </a:rPr>
+                        <a:t>轉換時最低損失</a:t>
+                      </a:r>
+                    </a:p>
+                  </a:txBody>
+                  <a:tcPr marL="45720" marR="45720" marT="18288" marB="18288">
+                    <a:solidFill>
+                      <a:srgbClr val="00295C"/>
+                    </a:solidFill>
+                  </a:tcPr>
+                </a:tc>
+                <a:tc>
+                  <a:txBody>
+                    <a:bodyPr/>
+                    <a:lstStyle/>
+                    <a:p>
+                      <a:pPr algn="r"/>
+                      <a:r>
+                        <a:rPr sz="1050" b="1">
+                          <a:solidFill>
+                            <a:srgbClr val="FFFFFF"/>
+                          </a:solidFill>
+                          <a:latin typeface="微軟正黑體"/>
+                        </a:rPr>
+                        <a:t>期望損失(=票息原料)</a:t>
+                      </a:r>
+                    </a:p>
+                  </a:txBody>
+                  <a:tcPr marL="45720" marR="45720" marT="18288" marB="18288">
+                    <a:solidFill>
+                      <a:srgbClr val="00295C"/>
+                    </a:solidFill>
+                  </a:tcPr>
+                </a:tc>
+              </a:tr>
+              <a:tr h="444137">
+                <a:tc>
+                  <a:txBody>
+                    <a:bodyPr/>
+                    <a:lstStyle/>
+                    <a:p>
+                      <a:pPr algn="r"/>
+                      <a:r>
+                        <a:rPr sz="1100" b="1">
+                          <a:solidFill>
+                            <a:srgbClr val="2A2A2A"/>
+                          </a:solidFill>
+                          <a:latin typeface="微軟正黑體"/>
+                        </a:rPr>
+                        <a:t>80%</a:t>
+                      </a:r>
+                    </a:p>
+                  </a:txBody>
+                  <a:tcPr marL="45720" marR="45720" marT="18288" marB="18288">
+                    <a:solidFill>
+                      <a:srgbClr val="FFFFFF"/>
+                    </a:solidFill>
+                  </a:tcPr>
+                </a:tc>
+                <a:tc>
+                  <a:txBody>
+                    <a:bodyPr/>
+                    <a:lstStyle/>
+                    <a:p>
+                      <a:pPr algn="l"/>
+                      <a:r>
+                        <a:rPr sz="1100" b="0">
+                          <a:solidFill>
+                            <a:srgbClr val="2A2A2A"/>
+                          </a:solidFill>
+                          <a:latin typeface="微軟正黑體"/>
+                        </a:rPr>
+                        <a:t>無 KI</a:t>
+                      </a:r>
+                    </a:p>
+                  </a:txBody>
+                  <a:tcPr marL="45720" marR="45720" marT="18288" marB="18288">
+                    <a:solidFill>
+                      <a:srgbClr val="FFFFFF"/>
+                    </a:solidFill>
+                  </a:tcPr>
+                </a:tc>
+                <a:tc>
+                  <a:txBody>
+                    <a:bodyPr/>
+                    <a:lstStyle/>
+                    <a:p>
+                      <a:pPr algn="r"/>
+                      <a:r>
+                        <a:rPr sz="1100" b="0">
+                          <a:solidFill>
+                            <a:srgbClr val="2A2A2A"/>
+                          </a:solidFill>
+                          <a:latin typeface="微軟正黑體"/>
+                        </a:rPr>
+                        <a:t>23.6%</a:t>
+                      </a:r>
+                    </a:p>
+                  </a:txBody>
+                  <a:tcPr marL="45720" marR="45720" marT="18288" marB="18288">
+                    <a:solidFill>
+                      <a:srgbClr val="FFFFFF"/>
+                    </a:solidFill>
+                  </a:tcPr>
+                </a:tc>
+                <a:tc>
+                  <a:txBody>
+                    <a:bodyPr/>
+                    <a:lstStyle/>
+                    <a:p>
+                      <a:pPr algn="r"/>
+                      <a:r>
+                        <a:rPr sz="1100" b="0">
+                          <a:solidFill>
+                            <a:srgbClr val="2A2A2A"/>
+                          </a:solidFill>
+                          <a:latin typeface="微軟正黑體"/>
+                        </a:rPr>
+                        <a:t>11.6%</a:t>
+                      </a:r>
+                    </a:p>
+                  </a:txBody>
+                  <a:tcPr marL="45720" marR="45720" marT="18288" marB="18288">
+                    <a:solidFill>
+                      <a:srgbClr val="FFFFFF"/>
+                    </a:solidFill>
+                  </a:tcPr>
+                </a:tc>
+                <a:tc>
+                  <a:txBody>
+                    <a:bodyPr/>
+                    <a:lstStyle/>
+                    <a:p>
+                      <a:pPr algn="r"/>
+                      <a:r>
+                        <a:rPr sz="1100" b="0">
+                          <a:solidFill>
+                            <a:srgbClr val="2A2A2A"/>
+                          </a:solidFill>
+                          <a:latin typeface="微軟正黑體"/>
+                        </a:rPr>
+                        <a:t>~0%</a:t>
+                      </a:r>
+                    </a:p>
+                  </a:txBody>
+                  <a:tcPr marL="45720" marR="45720" marT="18288" marB="18288">
+                    <a:solidFill>
+                      <a:srgbClr val="FFFFFF"/>
+                    </a:solidFill>
+                  </a:tcPr>
+                </a:tc>
+                <a:tc>
+                  <a:txBody>
+                    <a:bodyPr/>
+                    <a:lstStyle/>
+                    <a:p>
+                      <a:pPr algn="r"/>
+                      <a:r>
+                        <a:rPr sz="1100" b="0">
+                          <a:solidFill>
+                            <a:srgbClr val="2A2A2A"/>
+                          </a:solidFill>
+                          <a:latin typeface="微軟正黑體"/>
+                        </a:rPr>
+                        <a:t>2.69%</a:t>
+                      </a:r>
+                    </a:p>
+                  </a:txBody>
+                  <a:tcPr marL="45720" marR="45720" marT="18288" marB="18288">
+                    <a:solidFill>
+                      <a:srgbClr val="FFFFFF"/>
+                    </a:solidFill>
+                  </a:tcPr>
+                </a:tc>
+              </a:tr>
+              <a:tr h="444137">
+                <a:tc>
+                  <a:txBody>
+                    <a:bodyPr/>
+                    <a:lstStyle/>
+                    <a:p>
+                      <a:pPr algn="r"/>
+                      <a:r>
+                        <a:rPr sz="1100" b="1">
+                          <a:solidFill>
+                            <a:srgbClr val="2A2A2A"/>
+                          </a:solidFill>
+                          <a:latin typeface="微軟正黑體"/>
+                        </a:rPr>
+                        <a:t>80%</a:t>
+                      </a:r>
+                    </a:p>
+                  </a:txBody>
+                  <a:tcPr marL="45720" marR="45720" marT="18288" marB="18288">
+                    <a:solidFill>
+                      <a:srgbClr val="F5F5F5"/>
+                    </a:solidFill>
+                  </a:tcPr>
+                </a:tc>
+                <a:tc>
+                  <a:txBody>
+                    <a:bodyPr/>
+                    <a:lstStyle/>
+                    <a:p>
+                      <a:pPr algn="l"/>
+                      <a:r>
+                        <a:rPr sz="1100" b="0">
+                          <a:solidFill>
+                            <a:srgbClr val="2A2A2A"/>
+                          </a:solidFill>
+                          <a:latin typeface="微軟正黑體"/>
+                        </a:rPr>
+                        <a:t>EKI 65%</a:t>
+                      </a:r>
+                    </a:p>
+                  </a:txBody>
+                  <a:tcPr marL="45720" marR="45720" marT="18288" marB="18288">
+                    <a:solidFill>
+                      <a:srgbClr val="F5F5F5"/>
+                    </a:solidFill>
+                  </a:tcPr>
+                </a:tc>
+                <a:tc>
+                  <a:txBody>
+                    <a:bodyPr/>
+                    <a:lstStyle/>
+                    <a:p>
+                      <a:pPr algn="r"/>
+                      <a:r>
+                        <a:rPr sz="1100" b="0">
+                          <a:solidFill>
+                            <a:srgbClr val="2A2A2A"/>
+                          </a:solidFill>
+                          <a:latin typeface="微軟正黑體"/>
+                        </a:rPr>
+                        <a:t>7.3%</a:t>
+                      </a:r>
+                    </a:p>
+                  </a:txBody>
+                  <a:tcPr marL="45720" marR="45720" marT="18288" marB="18288">
+                    <a:solidFill>
+                      <a:srgbClr val="F5F5F5"/>
+                    </a:solidFill>
+                  </a:tcPr>
+                </a:tc>
+                <a:tc>
+                  <a:txBody>
+                    <a:bodyPr/>
+                    <a:lstStyle/>
+                    <a:p>
+                      <a:pPr algn="r"/>
+                      <a:r>
+                        <a:rPr sz="1100" b="0">
+                          <a:solidFill>
+                            <a:srgbClr val="2A2A2A"/>
+                          </a:solidFill>
+                          <a:latin typeface="微軟正黑體"/>
+                        </a:rPr>
+                        <a:t>22.4%</a:t>
+                      </a:r>
+                    </a:p>
+                  </a:txBody>
+                  <a:tcPr marL="45720" marR="45720" marT="18288" marB="18288">
+                    <a:solidFill>
+                      <a:srgbClr val="F5F5F5"/>
+                    </a:solidFill>
+                  </a:tcPr>
+                </a:tc>
+                <a:tc>
+                  <a:txBody>
+                    <a:bodyPr/>
+                    <a:lstStyle/>
+                    <a:p>
+                      <a:pPr algn="r"/>
+                      <a:r>
+                        <a:rPr sz="1100" b="0">
+                          <a:solidFill>
+                            <a:srgbClr val="2A2A2A"/>
+                          </a:solidFill>
+                          <a:latin typeface="微軟正黑體"/>
+                        </a:rPr>
+                        <a:t>15.0%</a:t>
+                      </a:r>
+                    </a:p>
+                  </a:txBody>
+                  <a:tcPr marL="45720" marR="45720" marT="18288" marB="18288">
+                    <a:solidFill>
+                      <a:srgbClr val="F5F5F5"/>
+                    </a:solidFill>
+                  </a:tcPr>
+                </a:tc>
+                <a:tc>
+                  <a:txBody>
+                    <a:bodyPr/>
+                    <a:lstStyle/>
+                    <a:p>
+                      <a:pPr algn="r"/>
+                      <a:r>
+                        <a:rPr sz="1100" b="0">
+                          <a:solidFill>
+                            <a:srgbClr val="2A2A2A"/>
+                          </a:solidFill>
+                          <a:latin typeface="微軟正黑體"/>
+                        </a:rPr>
+                        <a:t>1.60%</a:t>
+                      </a:r>
+                    </a:p>
+                  </a:txBody>
+                  <a:tcPr marL="45720" marR="45720" marT="18288" marB="18288">
+                    <a:solidFill>
+                      <a:srgbClr val="F5F5F5"/>
+                    </a:solidFill>
+                  </a:tcPr>
+                </a:tc>
+              </a:tr>
+              <a:tr h="444137">
+                <a:tc>
+                  <a:txBody>
+                    <a:bodyPr/>
+                    <a:lstStyle/>
+                    <a:p>
+                      <a:pPr algn="r"/>
+                      <a:r>
+                        <a:rPr sz="1100" b="1">
+                          <a:solidFill>
+                            <a:srgbClr val="2A2A2A"/>
+                          </a:solidFill>
+                          <a:latin typeface="微軟正黑體"/>
+                        </a:rPr>
+                        <a:t>90%</a:t>
+                      </a:r>
+                    </a:p>
+                  </a:txBody>
+                  <a:tcPr marL="45720" marR="45720" marT="18288" marB="18288">
+                    <a:solidFill>
+                      <a:srgbClr val="FFFFFF"/>
+                    </a:solidFill>
+                  </a:tcPr>
+                </a:tc>
+                <a:tc>
+                  <a:txBody>
+                    <a:bodyPr/>
+                    <a:lstStyle/>
+                    <a:p>
+                      <a:pPr algn="l"/>
+                      <a:r>
+                        <a:rPr sz="1100" b="0">
+                          <a:solidFill>
+                            <a:srgbClr val="2A2A2A"/>
+                          </a:solidFill>
+                          <a:latin typeface="微軟正黑體"/>
+                        </a:rPr>
+                        <a:t>無 KI</a:t>
+                      </a:r>
+                    </a:p>
+                  </a:txBody>
+                  <a:tcPr marL="45720" marR="45720" marT="18288" marB="18288">
+                    <a:solidFill>
+                      <a:srgbClr val="FFFFFF"/>
+                    </a:solidFill>
+                  </a:tcPr>
+                </a:tc>
+                <a:tc>
+                  <a:txBody>
+                    <a:bodyPr/>
+                    <a:lstStyle/>
+                    <a:p>
+                      <a:pPr algn="r"/>
+                      <a:r>
+                        <a:rPr sz="1100" b="0">
+                          <a:solidFill>
+                            <a:srgbClr val="2A2A2A"/>
+                          </a:solidFill>
+                          <a:latin typeface="微軟正黑體"/>
+                        </a:rPr>
+                        <a:t>38.1%</a:t>
+                      </a:r>
+                    </a:p>
+                  </a:txBody>
+                  <a:tcPr marL="45720" marR="45720" marT="18288" marB="18288">
+                    <a:solidFill>
+                      <a:srgbClr val="FFFFFF"/>
+                    </a:solidFill>
+                  </a:tcPr>
+                </a:tc>
+                <a:tc>
+                  <a:txBody>
+                    <a:bodyPr/>
+                    <a:lstStyle/>
+                    <a:p>
+                      <a:pPr algn="r"/>
+                      <a:r>
+                        <a:rPr sz="1100" b="0">
+                          <a:solidFill>
+                            <a:srgbClr val="2A2A2A"/>
+                          </a:solidFill>
+                          <a:latin typeface="微軟正黑體"/>
+                        </a:rPr>
+                        <a:t>15.2%</a:t>
+                      </a:r>
+                    </a:p>
+                  </a:txBody>
+                  <a:tcPr marL="45720" marR="45720" marT="18288" marB="18288">
+                    <a:solidFill>
+                      <a:srgbClr val="FFFFFF"/>
+                    </a:solidFill>
+                  </a:tcPr>
+                </a:tc>
+                <a:tc>
+                  <a:txBody>
+                    <a:bodyPr/>
+                    <a:lstStyle/>
+                    <a:p>
+                      <a:pPr algn="r"/>
+                      <a:r>
+                        <a:rPr sz="1100" b="0">
+                          <a:solidFill>
+                            <a:srgbClr val="2A2A2A"/>
+                          </a:solidFill>
+                          <a:latin typeface="微軟正黑體"/>
+                        </a:rPr>
+                        <a:t>~0%</a:t>
+                      </a:r>
+                    </a:p>
+                  </a:txBody>
+                  <a:tcPr marL="45720" marR="45720" marT="18288" marB="18288">
+                    <a:solidFill>
+                      <a:srgbClr val="FFFFFF"/>
+                    </a:solidFill>
+                  </a:tcPr>
+                </a:tc>
+                <a:tc>
+                  <a:txBody>
+                    <a:bodyPr/>
+                    <a:lstStyle/>
+                    <a:p>
+                      <a:pPr algn="r"/>
+                      <a:r>
+                        <a:rPr sz="1100" b="0">
+                          <a:solidFill>
+                            <a:srgbClr val="2A2A2A"/>
+                          </a:solidFill>
+                          <a:latin typeface="微軟正黑體"/>
+                        </a:rPr>
+                        <a:t>5.70%</a:t>
+                      </a:r>
+                    </a:p>
+                  </a:txBody>
+                  <a:tcPr marL="45720" marR="45720" marT="18288" marB="18288">
+                    <a:solidFill>
+                      <a:srgbClr val="FFFFFF"/>
+                    </a:solidFill>
+                  </a:tcPr>
+                </a:tc>
+              </a:tr>
+              <a:tr h="444137">
+                <a:tc>
+                  <a:txBody>
+                    <a:bodyPr/>
+                    <a:lstStyle/>
+                    <a:p>
+                      <a:pPr algn="r"/>
+                      <a:r>
+                        <a:rPr sz="1100" b="1">
+                          <a:solidFill>
+                            <a:srgbClr val="2A2A2A"/>
+                          </a:solidFill>
+                          <a:latin typeface="微軟正黑體"/>
+                        </a:rPr>
+                        <a:t>90%</a:t>
+                      </a:r>
+                    </a:p>
+                  </a:txBody>
+                  <a:tcPr marL="45720" marR="45720" marT="18288" marB="18288">
+                    <a:solidFill>
+                      <a:srgbClr val="F5F5F5"/>
+                    </a:solidFill>
+                  </a:tcPr>
+                </a:tc>
+                <a:tc>
+                  <a:txBody>
+                    <a:bodyPr/>
+                    <a:lstStyle/>
+                    <a:p>
+                      <a:pPr algn="l"/>
+                      <a:r>
+                        <a:rPr sz="1100" b="0">
+                          <a:solidFill>
+                            <a:srgbClr val="2A2A2A"/>
+                          </a:solidFill>
+                          <a:latin typeface="微軟正黑體"/>
+                        </a:rPr>
+                        <a:t>EKI 65%</a:t>
+                      </a:r>
+                    </a:p>
+                  </a:txBody>
+                  <a:tcPr marL="45720" marR="45720" marT="18288" marB="18288">
+                    <a:solidFill>
+                      <a:srgbClr val="F5F5F5"/>
+                    </a:solidFill>
+                  </a:tcPr>
+                </a:tc>
+                <a:tc>
+                  <a:txBody>
+                    <a:bodyPr/>
+                    <a:lstStyle/>
+                    <a:p>
+                      <a:pPr algn="r"/>
+                      <a:r>
+                        <a:rPr sz="1100" b="0">
+                          <a:solidFill>
+                            <a:srgbClr val="2A2A2A"/>
+                          </a:solidFill>
+                          <a:latin typeface="微軟正黑體"/>
+                        </a:rPr>
+                        <a:t>7.3%</a:t>
+                      </a:r>
+                    </a:p>
+                  </a:txBody>
+                  <a:tcPr marL="45720" marR="45720" marT="18288" marB="18288">
+                    <a:solidFill>
+                      <a:srgbClr val="F5F5F5"/>
+                    </a:solidFill>
+                  </a:tcPr>
+                </a:tc>
+                <a:tc>
+                  <a:txBody>
+                    <a:bodyPr/>
+                    <a:lstStyle/>
+                    <a:p>
+                      <a:pPr algn="r"/>
+                      <a:r>
+                        <a:rPr sz="1100" b="0">
+                          <a:solidFill>
+                            <a:srgbClr val="2A2A2A"/>
+                          </a:solidFill>
+                          <a:latin typeface="微軟正黑體"/>
+                        </a:rPr>
+                        <a:t>32.4%</a:t>
+                      </a:r>
+                    </a:p>
+                  </a:txBody>
+                  <a:tcPr marL="45720" marR="45720" marT="18288" marB="18288">
+                    <a:solidFill>
+                      <a:srgbClr val="F5F5F5"/>
+                    </a:solidFill>
+                  </a:tcPr>
+                </a:tc>
+                <a:tc>
+                  <a:txBody>
+                    <a:bodyPr/>
+                    <a:lstStyle/>
+                    <a:p>
+                      <a:pPr algn="r"/>
+                      <a:r>
+                        <a:rPr sz="1100" b="0">
+                          <a:solidFill>
+                            <a:srgbClr val="2A2A2A"/>
+                          </a:solidFill>
+                          <a:latin typeface="微軟正黑體"/>
+                        </a:rPr>
+                        <a:t>25.0%</a:t>
+                      </a:r>
+                    </a:p>
+                  </a:txBody>
+                  <a:tcPr marL="45720" marR="45720" marT="18288" marB="18288">
+                    <a:solidFill>
+                      <a:srgbClr val="F5F5F5"/>
+                    </a:solidFill>
+                  </a:tcPr>
+                </a:tc>
+                <a:tc>
+                  <a:txBody>
+                    <a:bodyPr/>
+                    <a:lstStyle/>
+                    <a:p>
+                      <a:pPr algn="r"/>
+                      <a:r>
+                        <a:rPr sz="1100" b="0">
+                          <a:solidFill>
+                            <a:srgbClr val="2A2A2A"/>
+                          </a:solidFill>
+                          <a:latin typeface="微軟正黑體"/>
+                        </a:rPr>
+                        <a:t>2.32%</a:t>
+                      </a:r>
+                    </a:p>
+                  </a:txBody>
+                  <a:tcPr marL="45720" marR="45720" marT="18288" marB="18288">
+                    <a:solidFill>
+                      <a:srgbClr val="F5F5F5"/>
+                    </a:solidFill>
+                  </a:tcPr>
+                </a:tc>
+              </a:tr>
+              <a:tr h="444137">
+                <a:tc>
+                  <a:txBody>
+                    <a:bodyPr/>
+                    <a:lstStyle/>
+                    <a:p>
+                      <a:pPr algn="r"/>
+                      <a:r>
+                        <a:rPr sz="1100" b="1">
+                          <a:solidFill>
+                            <a:srgbClr val="2A2A2A"/>
+                          </a:solidFill>
+                          <a:latin typeface="微軟正黑體"/>
+                        </a:rPr>
+                        <a:t>100%</a:t>
+                      </a:r>
+                    </a:p>
+                  </a:txBody>
+                  <a:tcPr marL="45720" marR="45720" marT="18288" marB="18288">
+                    <a:solidFill>
+                      <a:srgbClr val="FFFFFF"/>
+                    </a:solidFill>
+                  </a:tcPr>
+                </a:tc>
+                <a:tc>
+                  <a:txBody>
+                    <a:bodyPr/>
+                    <a:lstStyle/>
+                    <a:p>
+                      <a:pPr algn="l"/>
+                      <a:r>
+                        <a:rPr sz="1100" b="0">
+                          <a:solidFill>
+                            <a:srgbClr val="2A2A2A"/>
+                          </a:solidFill>
+                          <a:latin typeface="微軟正黑體"/>
+                        </a:rPr>
+                        <a:t>無 KI</a:t>
+                      </a:r>
+                    </a:p>
+                  </a:txBody>
+                  <a:tcPr marL="45720" marR="45720" marT="18288" marB="18288">
+                    <a:solidFill>
+                      <a:srgbClr val="FFFFFF"/>
+                    </a:solidFill>
+                  </a:tcPr>
+                </a:tc>
+                <a:tc>
+                  <a:txBody>
+                    <a:bodyPr/>
+                    <a:lstStyle/>
+                    <a:p>
+                      <a:pPr algn="r"/>
+                      <a:r>
+                        <a:rPr sz="1100" b="0">
+                          <a:solidFill>
+                            <a:srgbClr val="2A2A2A"/>
+                          </a:solidFill>
+                          <a:latin typeface="微軟正黑體"/>
+                        </a:rPr>
+                        <a:t>52.8%</a:t>
+                      </a:r>
+                    </a:p>
+                  </a:txBody>
+                  <a:tcPr marL="45720" marR="45720" marT="18288" marB="18288">
+                    <a:solidFill>
+                      <a:srgbClr val="FFFFFF"/>
+                    </a:solidFill>
+                  </a:tcPr>
+                </a:tc>
+                <a:tc>
+                  <a:txBody>
+                    <a:bodyPr/>
+                    <a:lstStyle/>
+                    <a:p>
+                      <a:pPr algn="r"/>
+                      <a:r>
+                        <a:rPr sz="1100" b="0">
+                          <a:solidFill>
+                            <a:srgbClr val="2A2A2A"/>
+                          </a:solidFill>
+                          <a:latin typeface="微軟正黑體"/>
+                        </a:rPr>
+                        <a:t>19.6%</a:t>
+                      </a:r>
+                    </a:p>
+                  </a:txBody>
+                  <a:tcPr marL="45720" marR="45720" marT="18288" marB="18288">
+                    <a:solidFill>
+                      <a:srgbClr val="FFFFFF"/>
+                    </a:solidFill>
+                  </a:tcPr>
+                </a:tc>
+                <a:tc>
+                  <a:txBody>
+                    <a:bodyPr/>
+                    <a:lstStyle/>
+                    <a:p>
+                      <a:pPr algn="r"/>
+                      <a:r>
+                        <a:rPr sz="1100" b="0">
+                          <a:solidFill>
+                            <a:srgbClr val="2A2A2A"/>
+                          </a:solidFill>
+                          <a:latin typeface="微軟正黑體"/>
+                        </a:rPr>
+                        <a:t>~0%</a:t>
+                      </a:r>
+                    </a:p>
+                  </a:txBody>
+                  <a:tcPr marL="45720" marR="45720" marT="18288" marB="18288">
+                    <a:solidFill>
+                      <a:srgbClr val="FFFFFF"/>
+                    </a:solidFill>
+                  </a:tcPr>
+                </a:tc>
+                <a:tc>
+                  <a:txBody>
+                    <a:bodyPr/>
+                    <a:lstStyle/>
+                    <a:p>
+                      <a:pPr algn="r"/>
+                      <a:r>
+                        <a:rPr sz="1100" b="0">
+                          <a:solidFill>
+                            <a:srgbClr val="2A2A2A"/>
+                          </a:solidFill>
+                          <a:latin typeface="微軟正黑體"/>
+                        </a:rPr>
+                        <a:t>10.16%</a:t>
+                      </a:r>
+                    </a:p>
+                  </a:txBody>
+                  <a:tcPr marL="45720" marR="45720" marT="18288" marB="18288">
+                    <a:solidFill>
+                      <a:srgbClr val="FFFFFF"/>
+                    </a:solidFill>
+                  </a:tcPr>
+                </a:tc>
+              </a:tr>
+              <a:tr h="444138">
+                <a:tc>
+                  <a:txBody>
+                    <a:bodyPr/>
+                    <a:lstStyle/>
+                    <a:p>
+                      <a:pPr algn="r"/>
+                      <a:r>
+                        <a:rPr sz="1100" b="1">
+                          <a:solidFill>
+                            <a:srgbClr val="2A2A2A"/>
+                          </a:solidFill>
+                          <a:latin typeface="微軟正黑體"/>
+                        </a:rPr>
+                        <a:t>100%</a:t>
+                      </a:r>
+                    </a:p>
+                  </a:txBody>
+                  <a:tcPr marL="45720" marR="45720" marT="18288" marB="18288">
+                    <a:solidFill>
+                      <a:srgbClr val="F5F5F5"/>
+                    </a:solidFill>
+                  </a:tcPr>
+                </a:tc>
+                <a:tc>
+                  <a:txBody>
+                    <a:bodyPr/>
+                    <a:lstStyle/>
+                    <a:p>
+                      <a:pPr algn="l"/>
+                      <a:r>
+                        <a:rPr sz="1100" b="0">
+                          <a:solidFill>
+                            <a:srgbClr val="2A2A2A"/>
+                          </a:solidFill>
+                          <a:latin typeface="微軟正黑體"/>
+                        </a:rPr>
+                        <a:t>EKI 65%</a:t>
+                      </a:r>
+                    </a:p>
+                  </a:txBody>
+                  <a:tcPr marL="45720" marR="45720" marT="18288" marB="18288">
+                    <a:solidFill>
+                      <a:srgbClr val="F5F5F5"/>
+                    </a:solidFill>
+                  </a:tcPr>
+                </a:tc>
+                <a:tc>
+                  <a:txBody>
+                    <a:bodyPr/>
+                    <a:lstStyle/>
+                    <a:p>
+                      <a:pPr algn="r"/>
+                      <a:r>
+                        <a:rPr sz="1100" b="0">
+                          <a:solidFill>
+                            <a:srgbClr val="2A2A2A"/>
+                          </a:solidFill>
+                          <a:latin typeface="微軟正黑體"/>
+                        </a:rPr>
+                        <a:t>7.3%</a:t>
+                      </a:r>
+                    </a:p>
+                  </a:txBody>
+                  <a:tcPr marL="45720" marR="45720" marT="18288" marB="18288">
+                    <a:solidFill>
+                      <a:srgbClr val="F5F5F5"/>
+                    </a:solidFill>
+                  </a:tcPr>
+                </a:tc>
+                <a:tc>
+                  <a:txBody>
+                    <a:bodyPr/>
+                    <a:lstStyle/>
+                    <a:p>
+                      <a:pPr algn="r"/>
+                      <a:r>
+                        <a:rPr sz="1100" b="0">
+                          <a:solidFill>
+                            <a:srgbClr val="2A2A2A"/>
+                          </a:solidFill>
+                          <a:latin typeface="微軟正黑體"/>
+                        </a:rPr>
+                        <a:t>42.4%</a:t>
+                      </a:r>
+                    </a:p>
+                  </a:txBody>
+                  <a:tcPr marL="45720" marR="45720" marT="18288" marB="18288">
+                    <a:solidFill>
+                      <a:srgbClr val="F5F5F5"/>
+                    </a:solidFill>
+                  </a:tcPr>
+                </a:tc>
+                <a:tc>
+                  <a:txBody>
+                    <a:bodyPr/>
+                    <a:lstStyle/>
+                    <a:p>
+                      <a:pPr algn="r"/>
+                      <a:r>
+                        <a:rPr sz="1100" b="0">
+                          <a:solidFill>
+                            <a:srgbClr val="2A2A2A"/>
+                          </a:solidFill>
+                          <a:latin typeface="微軟正黑體"/>
+                        </a:rPr>
+                        <a:t>35.0%</a:t>
+                      </a:r>
+                    </a:p>
+                  </a:txBody>
+                  <a:tcPr marL="45720" marR="45720" marT="18288" marB="18288">
+                    <a:solidFill>
+                      <a:srgbClr val="F5F5F5"/>
+                    </a:solidFill>
+                  </a:tcPr>
+                </a:tc>
+                <a:tc>
+                  <a:txBody>
+                    <a:bodyPr/>
+                    <a:lstStyle/>
+                    <a:p>
+                      <a:pPr algn="r"/>
+                      <a:r>
+                        <a:rPr sz="1100" b="0">
+                          <a:solidFill>
+                            <a:srgbClr val="2A2A2A"/>
+                          </a:solidFill>
+                          <a:latin typeface="微軟正黑體"/>
+                        </a:rPr>
+                        <a:t>3.04%</a:t>
+                      </a:r>
+                    </a:p>
+                  </a:txBody>
+                  <a:tcPr marL="45720" marR="45720" marT="18288" marB="18288">
+                    <a:solidFill>
+                      <a:srgbClr val="F5F5F5"/>
+                    </a:solidFill>
+                  </a:tcPr>
+                </a:tc>
+              </a:tr>
+            </a:tbl>
+          </a:graphicData>
+        </a:graphic>
+      </p:graphicFrame>
+      <p:sp>
+        <p:nvSpPr>
+          <p:cNvPr id="7" name="TextBox 6"/>
+          <p:cNvSpPr txBox="1"/>
+          <p:nvPr/>
+        </p:nvSpPr>
+        <p:spPr>
+          <a:xfrm>
+            <a:off x="7452360" y="1234440"/>
+            <a:ext cx="4206240" cy="4572000"/>
+          </a:xfrm>
+          <a:prstGeom prst="rect">
+            <a:avLst/>
+          </a:prstGeom>
+          <a:noFill/>
+        </p:spPr>
+        <p:txBody>
+          <a:bodyPr wrap="square" anchor="t" lIns="0" rIns="0" tIns="0" bIns="0">
+            <a:spAutoFit/>
+          </a:bodyPr>
+          <a:lstStyle/>
+          <a:p>
+            <a:pPr algn="l">
+              <a:lnSpc>
+                <a:spcPct val="125000"/>
+              </a:lnSpc>
+            </a:pPr>
+            <a:r>
+              <a:rPr sz="1200" b="1">
+                <a:solidFill>
+                  <a:srgbClr val="00295C"/>
+                </a:solidFill>
+                <a:latin typeface="微軟正黑體"/>
+              </a:rPr>
+              <a:t>1. EKI 刪掉的全是淺層轉換</a:t>
+            </a:r>
+          </a:p>
+          <a:p>
+            <a:pPr algn="l">
+              <a:lnSpc>
+                <a:spcPct val="125000"/>
+              </a:lnSpc>
+            </a:pPr>
+            <a:r>
+              <a:rPr sz="1050" b="0">
+                <a:solidFill>
+                  <a:srgbClr val="2A2A2A"/>
+                </a:solidFill>
+                <a:latin typeface="微軟正黑體"/>
+              </a:rPr>
+              <a:t>深層情境（S&lt;65%）有無 EKI 損益相同 — 免小傷、不免大傷；留下的轉換全是深的（條件損失 11.6%→22.4%）</a:t>
+            </a:r>
+          </a:p>
+          <a:p>
+            <a:pPr algn="l">
+              <a:lnSpc>
+                <a:spcPct val="125000"/>
+              </a:lnSpc>
+            </a:pPr>
+            <a:r>
+              <a:rPr sz="1200" b="1">
+                <a:solidFill>
+                  <a:srgbClr val="00295C"/>
+                </a:solidFill>
+                <a:latin typeface="微軟正黑體"/>
+              </a:rPr>
+              <a:t>2. 轉換機率與 K 脫鉤</a:t>
+            </a:r>
+          </a:p>
+          <a:p>
+            <a:pPr algn="l">
+              <a:lnSpc>
+                <a:spcPct val="125000"/>
+              </a:lnSpc>
+            </a:pPr>
+            <a:r>
+              <a:rPr sz="1050" b="0">
+                <a:solidFill>
+                  <a:srgbClr val="2A2A2A"/>
+                </a:solidFill>
+                <a:latin typeface="微軟正黑體"/>
+              </a:rPr>
+              <a:t>三檔 K 全是 7.3% = P(S&lt;KI)。K 只決定轉換深度，最低損失 = K−KI — 這就是「EKI 讓 K 可以積極」的機制，代價是純 severity</a:t>
+            </a:r>
+          </a:p>
+          <a:p>
+            <a:pPr algn="l">
+              <a:lnSpc>
+                <a:spcPct val="125000"/>
+              </a:lnSpc>
+            </a:pPr>
+            <a:r>
+              <a:rPr sz="1200" b="1">
+                <a:solidFill>
+                  <a:srgbClr val="00295C"/>
+                </a:solidFill>
+                <a:latin typeface="微軟正黑體"/>
+              </a:rPr>
+              <a:t>3. 票息讓渡 = 被刪中段的價值</a:t>
+            </a:r>
+          </a:p>
+          <a:p>
+            <a:pPr algn="l">
+              <a:lnSpc>
+                <a:spcPct val="125000"/>
+              </a:lnSpc>
+            </a:pPr>
+            <a:r>
+              <a:rPr sz="1050" b="0">
+                <a:solidFill>
+                  <a:srgbClr val="2A2A2A"/>
+                </a:solidFill>
+                <a:latin typeface="微軟正黑體"/>
+              </a:rPr>
+              <a:t>K=100%：放棄 7.13pp 換轉換機率 −45.5pp；EKI 下 K 80→100% 票息只 +1.44pp、懸崖 +20pp</a:t>
+            </a:r>
+          </a:p>
+          <a:p>
+            <a:pPr algn="l">
+              <a:lnSpc>
+                <a:spcPct val="125000"/>
+              </a:lnSpc>
+            </a:pPr>
+            <a:r>
+              <a:rPr sz="1200" b="1">
+                <a:solidFill>
+                  <a:srgbClr val="00295C"/>
+                </a:solidFill>
+                <a:latin typeface="微軟正黑體"/>
+              </a:rPr>
+              <a:t>4. 觀察頻率是隱藏參數</a:t>
+            </a:r>
+          </a:p>
+          <a:p>
+            <a:pPr algn="l">
+              <a:lnSpc>
+                <a:spcPct val="125000"/>
+              </a:lnSpc>
+            </a:pPr>
+            <a:r>
+              <a:rPr sz="1050" b="0">
+                <a:solidFill>
+                  <a:srgbClr val="2A2A2A"/>
+                </a:solidFill>
+                <a:latin typeface="微軟正黑體"/>
+              </a:rPr>
+              <a:t>KI 65% 改每日觀察觸發率 7.3%→~12.9%，且模型未含跳空（MU 單週 −13%）</a:t>
+            </a:r>
+          </a:p>
+        </p:txBody>
+      </p:sp>
+      <p:sp>
+        <p:nvSpPr>
+          <p:cNvPr id="8" name="Rectangle 7"/>
+          <p:cNvSpPr/>
+          <p:nvPr/>
+        </p:nvSpPr>
+        <p:spPr>
+          <a:xfrm>
+            <a:off x="640080" y="5943600"/>
+            <a:ext cx="10881360" cy="31750"/>
+          </a:xfrm>
+          <a:prstGeom prst="rect">
+            <a:avLst/>
+          </a:prstGeom>
+          <a:solidFill>
+            <a:srgbClr val="FFB81C"/>
+          </a:solidFill>
+          <a:ln>
+            <a:noFill/>
+          </a:ln>
+          <a:effectLst/>
+        </p:spPr>
+        <p:style>
+          <a:lnRef idx="1">
+            <a:schemeClr val="accent1"/>
+          </a:lnRef>
+          <a:fillRef idx="3">
+            <a:schemeClr val="accent1"/>
+          </a:fillRef>
+          <a:effectRef idx="2">
+            <a:schemeClr val="accent1"/>
+          </a:effectRef>
+          <a:fontRef idx="minor">
+            <a:schemeClr val="lt1"/>
+          </a:fontRef>
+        </p:style>
+        <p:txBody>
+          <a:bodyPr rtlCol="0" anchor="ctr"/>
+          <a:lstStyle/>
+          <a:p>
+            <a:pPr algn="ctr"/>
+          </a:p>
+        </p:txBody>
+      </p:sp>
+      <p:sp>
+        <p:nvSpPr>
+          <p:cNvPr id="9" name="TextBox 8"/>
+          <p:cNvSpPr txBox="1"/>
+          <p:nvPr/>
+        </p:nvSpPr>
+        <p:spPr>
+          <a:xfrm>
+            <a:off x="640080" y="6007100"/>
+            <a:ext cx="10881360" cy="502920"/>
+          </a:xfrm>
+          <a:prstGeom prst="rect">
+            <a:avLst/>
+          </a:prstGeom>
+          <a:noFill/>
+        </p:spPr>
+        <p:txBody>
+          <a:bodyPr wrap="square" anchor="t" lIns="0" rIns="0" tIns="0" bIns="0">
+            <a:spAutoFit/>
+          </a:bodyPr>
+          <a:lstStyle/>
+          <a:p>
+            <a:pPr algn="l">
+              <a:lnSpc>
+                <a:spcPct val="105000"/>
+              </a:lnSpc>
+            </a:pPr>
+            <a:r>
+              <a:rPr sz="1050" b="1">
+                <a:solidFill>
+                  <a:srgbClr val="C88E10"/>
+                </a:solidFill>
+                <a:latin typeface="微軟正黑體"/>
+              </a:rPr>
+              <a:t>BOTTOM LINE  </a:t>
+            </a:r>
+            <a:r>
+              <a:rPr sz="1050" b="1">
+                <a:solidFill>
+                  <a:srgbClr val="2A2A2A"/>
+                </a:solidFill>
+                <a:latin typeface="微軟正黑體"/>
+              </a:rPr>
+              <a:t>同 K 對照才看得到：EKI 買掉的是頻率、留下的是嚴重度 — 「高執行價+低轉換機率」的賣相由票息讓渡與懸崖加深支付。</a:t>
+            </a:r>
+          </a:p>
+        </p:txBody>
+      </p:sp>
+    </p:spTree>
+  </p:cSld>
+  <p:clrMapOvr>
+    <a:masterClrMapping/>
+  </p:clrMapOvr>
+</p:sld>
+</file>
+
+<file path=ppt/slides/slide8.xml><?xml version="1.0" encoding="utf-8"?>
+<p:sld xmlns:a="http://schemas.openxmlformats.org/drawingml/2006/main" xmlns:p="http://schemas.openxmlformats.org/presentationml/2006/main" xmlns:r="http://schemas.openxmlformats.org/officeDocument/2006/relationships">
+  <p:cSld>
+    <p:spTree>
+      <p:nvGrpSpPr>
+        <p:cNvPr id="1" name=""/>
+        <p:cNvGrpSpPr/>
+        <p:nvPr/>
+      </p:nvGrpSpPr>
+      <p:grpSpPr/>
+      <p:sp>
+        <p:nvSpPr>
+          <p:cNvPr id="2" name="Rectangle 1"/>
+          <p:cNvSpPr/>
+          <p:nvPr/>
+        </p:nvSpPr>
+        <p:spPr>
+          <a:xfrm>
+            <a:off x="0" y="0"/>
+            <a:ext cx="12191695" cy="320040"/>
+          </a:xfrm>
+          <a:prstGeom prst="rect">
+            <a:avLst/>
+          </a:prstGeom>
+          <a:solidFill>
+            <a:srgbClr val="00295C"/>
+          </a:solidFill>
+          <a:ln>
+            <a:noFill/>
+          </a:ln>
+          <a:effectLst/>
+        </p:spPr>
+        <p:style>
+          <a:lnRef idx="1">
+            <a:schemeClr val="accent1"/>
+          </a:lnRef>
+          <a:fillRef idx="3">
+            <a:schemeClr val="accent1"/>
+          </a:fillRef>
+          <a:effectRef idx="2">
+            <a:schemeClr val="accent1"/>
+          </a:effectRef>
+          <a:fontRef idx="minor">
+            <a:schemeClr val="lt1"/>
+          </a:fontRef>
+        </p:style>
+        <p:txBody>
+          <a:bodyPr rtlCol="0" anchor="ctr"/>
+          <a:lstStyle/>
+          <a:p>
+            <a:pPr algn="ctr"/>
+          </a:p>
+        </p:txBody>
+      </p:sp>
+      <p:sp>
+        <p:nvSpPr>
+          <p:cNvPr id="3" name="TextBox 2"/>
+          <p:cNvSpPr txBox="1"/>
+          <p:nvPr/>
+        </p:nvSpPr>
+        <p:spPr>
+          <a:xfrm>
+            <a:off x="320040" y="36576"/>
+            <a:ext cx="8229600" cy="256032"/>
+          </a:xfrm>
+          <a:prstGeom prst="rect">
+            <a:avLst/>
+          </a:prstGeom>
+          <a:noFill/>
+        </p:spPr>
+        <p:txBody>
+          <a:bodyPr wrap="square" anchor="ctr" lIns="0" rIns="0" tIns="0" bIns="0">
+            <a:spAutoFit/>
+          </a:bodyPr>
+          <a:lstStyle/>
+          <a:p>
+            <a:pPr algn="l"/>
+            <a:r>
+              <a:rPr sz="1100" b="1">
+                <a:solidFill>
+                  <a:srgbClr val="FFFFFF"/>
+                </a:solidFill>
+                <a:latin typeface="微軟正黑體"/>
+              </a:rPr>
+              <a:t>STRUCTURED PRODUCTS  |  FCN WEEKLY | KI/KO EXPECTED VALUE</a:t>
+            </a:r>
+          </a:p>
+        </p:txBody>
+      </p:sp>
+      <p:sp>
+        <p:nvSpPr>
+          <p:cNvPr id="4" name="TextBox 3"/>
+          <p:cNvSpPr txBox="1"/>
+          <p:nvPr/>
+        </p:nvSpPr>
+        <p:spPr>
+          <a:xfrm>
+            <a:off x="11247120" y="36576"/>
+            <a:ext cx="640080" cy="256032"/>
+          </a:xfrm>
+          <a:prstGeom prst="rect">
+            <a:avLst/>
+          </a:prstGeom>
+          <a:noFill/>
+        </p:spPr>
+        <p:txBody>
+          <a:bodyPr wrap="square" anchor="ctr" lIns="0" rIns="0" tIns="0" bIns="0">
+            <a:spAutoFit/>
+          </a:bodyPr>
+          <a:lstStyle/>
+          <a:p>
+            <a:pPr algn="r"/>
+            <a:r>
+              <a:rPr sz="1100" b="1">
+                <a:solidFill>
+                  <a:srgbClr val="FFB81C"/>
+                </a:solidFill>
+                <a:latin typeface="微軟正黑體"/>
+              </a:rPr>
+              <a:t>8</a:t>
+            </a:r>
+          </a:p>
+        </p:txBody>
+      </p:sp>
+      <p:sp>
+        <p:nvSpPr>
+          <p:cNvPr id="5" name="TextBox 4"/>
+          <p:cNvSpPr txBox="1"/>
+          <p:nvPr/>
+        </p:nvSpPr>
+        <p:spPr>
+          <a:xfrm>
+            <a:off x="640080" y="502920"/>
+            <a:ext cx="10972800" cy="457200"/>
+          </a:xfrm>
+          <a:prstGeom prst="rect">
+            <a:avLst/>
+          </a:prstGeom>
+          <a:noFill/>
+        </p:spPr>
+        <p:txBody>
+          <a:bodyPr wrap="square" anchor="t" lIns="0" rIns="0" tIns="0" bIns="0">
+            <a:spAutoFit/>
+          </a:bodyPr>
+          <a:lstStyle/>
+          <a:p>
+            <a:pPr algn="l"/>
+            <a:r>
+              <a:rPr sz="2400" b="1">
+                <a:solidFill>
+                  <a:srgbClr val="101010"/>
+                </a:solidFill>
+                <a:latin typeface="微軟正黑體"/>
+              </a:rPr>
               <a:t>五  Monday 待決策</a:t>
             </a:r>
           </a:p>
@@ -10589,7 +12019,7 @@
 </p:sld>
 </file>
 
-<file path=ppt/slides/slide8.xml><?xml version="1.0" encoding="utf-8"?>
+<file path=ppt/slides/slide9.xml><?xml version="1.0" encoding="utf-8"?>
 <p:sld xmlns:a="http://schemas.openxmlformats.org/drawingml/2006/main" xmlns:p="http://schemas.openxmlformats.org/presentationml/2006/main" xmlns:r="http://schemas.openxmlformats.org/officeDocument/2006/relationships">
   <p:cSld>
     <p:spTree>

</xml_diff>

<commit_message>
Refocus EKI comparison on conversion probability vs expected loss
Co-Authored-By: Claude Fable 5 <noreply@anthropic.com>
Claude-Session: https://claude.ai/code/session_01GD397krbJR1Gef3zPEk8sc
</commit_message>
<xml_diff>
--- a/_draft_fcn_weekly_2026-07-03.pptx
+++ b/_draft_fcn_weekly_2026-07-03.pptx
@@ -9838,7 +9838,7 @@
                 </a:solidFill>
                 <a:latin typeface="微軟正黑體"/>
               </a:rPr>
-              <a:t>四之二  同 K 對照 — 加 EKI 的前後差異</a:t>
+              <a:t>四之二  同 K 對照 — 轉換機率 vs 預期損失</a:t>
             </a:r>
             <a:r>
               <a:rPr sz="1200" b="0">
@@ -9861,8 +9861,8 @@
           <p:nvPr/>
         </p:nvGraphicFramePr>
         <p:xfrm>
-          <a:off x="502920" y="1188720"/>
-          <a:ext cx="6675120" cy="3108960"/>
+          <a:off x="502920" y="1234440"/>
+          <a:ext cx="6675120" cy="1737360"/>
         </p:xfrm>
         <a:graphic>
           <a:graphicData uri="http://schemas.openxmlformats.org/drawingml/2006/table">
@@ -9871,14 +9871,13 @@
                 <a:tableStyleId>{5C22544A-7EE6-4342-B048-85BDC9FD1C3A}</a:tableStyleId>
               </a:tblPr>
               <a:tblGrid>
-                <a:gridCol w="731520"/>
-                <a:gridCol w="1143000"/>
-                <a:gridCol w="1051560"/>
-                <a:gridCol w="1280160"/>
-                <a:gridCol w="1280160"/>
-                <a:gridCol w="1188720"/>
+                <a:gridCol w="685800"/>
+                <a:gridCol w="2286000"/>
+                <a:gridCol w="822960"/>
+                <a:gridCol w="2286000"/>
+                <a:gridCol w="594360"/>
               </a:tblGrid>
-              <a:tr h="444137">
+              <a:tr h="434340">
                 <a:tc>
                   <a:txBody>
                     <a:bodyPr/>
@@ -9907,7 +9906,7 @@
                     <a:bodyPr/>
                     <a:lstStyle/>
                     <a:p>
-                      <a:pPr algn="l"/>
+                      <a:pPr algn="ctr"/>
                       <a:r>
                         <a:rPr sz="1050" b="1">
                           <a:solidFill>
@@ -9915,7 +9914,7 @@
                           </a:solidFill>
                           <a:latin typeface="微軟正黑體"/>
                         </a:rPr>
-                        <a:t>結構</a:t>
+                        <a:t>轉換機率  無KI → EKI 65%</a:t>
                       </a:r>
                     </a:p>
                   </a:txBody>
@@ -9938,7 +9937,7 @@
                           </a:solidFill>
                           <a:latin typeface="微軟正黑體"/>
                         </a:rPr>
-                        <a:t>轉換機率</a:t>
+                        <a:t>降幅</a:t>
                       </a:r>
                     </a:p>
                   </a:txBody>
@@ -9953,6 +9952,29 @@
                     <a:bodyPr/>
                     <a:lstStyle/>
                     <a:p>
+                      <a:pPr algn="ctr"/>
+                      <a:r>
+                        <a:rPr sz="1050" b="1">
+                          <a:solidFill>
+                            <a:srgbClr val="FFFFFF"/>
+                          </a:solidFill>
+                          <a:latin typeface="微軟正黑體"/>
+                        </a:rPr>
+                        <a:t>預期損失  無KI → EKI 65%</a:t>
+                      </a:r>
+                    </a:p>
+                  </a:txBody>
+                  <a:tcPr marL="45720" marR="45720" marT="18288" marB="18288">
+                    <a:solidFill>
+                      <a:srgbClr val="00295C"/>
+                    </a:solidFill>
+                  </a:tcPr>
+                </a:tc>
+                <a:tc>
+                  <a:txBody>
+                    <a:bodyPr/>
+                    <a:lstStyle/>
+                    <a:p>
                       <a:pPr algn="r"/>
                       <a:r>
                         <a:rPr sz="1050" b="1">
@@ -9961,7 +9983,7 @@
                           </a:solidFill>
                           <a:latin typeface="微軟正黑體"/>
                         </a:rPr>
-                        <a:t>轉換時平均損失</a:t>
+                        <a:t>降幅</a:t>
                       </a:r>
                     </a:p>
                   </a:txBody>
@@ -9971,6 +9993,8 @@
                     </a:solidFill>
                   </a:tcPr>
                 </a:tc>
+              </a:tr>
+              <a:tr h="434340">
                 <a:tc>
                   <a:txBody>
                     <a:bodyPr/>
@@ -9978,19 +10002,42 @@
                     <a:p>
                       <a:pPr algn="r"/>
                       <a:r>
-                        <a:rPr sz="1050" b="1">
-                          <a:solidFill>
-                            <a:srgbClr val="FFFFFF"/>
-                          </a:solidFill>
-                          <a:latin typeface="微軟正黑體"/>
-                        </a:rPr>
-                        <a:t>轉換時最低損失</a:t>
-                      </a:r>
-                    </a:p>
-                  </a:txBody>
-                  <a:tcPr marL="45720" marR="45720" marT="18288" marB="18288">
-                    <a:solidFill>
-                      <a:srgbClr val="00295C"/>
+                        <a:rPr sz="1200" b="1">
+                          <a:solidFill>
+                            <a:srgbClr val="2A2A2A"/>
+                          </a:solidFill>
+                          <a:latin typeface="微軟正黑體"/>
+                        </a:rPr>
+                        <a:t>80%</a:t>
+                      </a:r>
+                    </a:p>
+                  </a:txBody>
+                  <a:tcPr marL="45720" marR="45720" marT="18288" marB="18288">
+                    <a:solidFill>
+                      <a:srgbClr val="FFFFFF"/>
+                    </a:solidFill>
+                  </a:tcPr>
+                </a:tc>
+                <a:tc>
+                  <a:txBody>
+                    <a:bodyPr/>
+                    <a:lstStyle/>
+                    <a:p>
+                      <a:pPr algn="ctr"/>
+                      <a:r>
+                        <a:rPr sz="1200" b="0">
+                          <a:solidFill>
+                            <a:srgbClr val="2A2A2A"/>
+                          </a:solidFill>
+                          <a:latin typeface="微軟正黑體"/>
+                        </a:rPr>
+                        <a:t>23.6% → 7.3%</a:t>
+                      </a:r>
+                    </a:p>
+                  </a:txBody>
+                  <a:tcPr marL="45720" marR="45720" marT="18288" marB="18288">
+                    <a:solidFill>
+                      <a:srgbClr val="FFFFFF"/>
                     </a:solidFill>
                   </a:tcPr>
                 </a:tc>
@@ -10001,24 +10048,70 @@
                     <a:p>
                       <a:pPr algn="r"/>
                       <a:r>
-                        <a:rPr sz="1050" b="1">
-                          <a:solidFill>
-                            <a:srgbClr val="FFFFFF"/>
-                          </a:solidFill>
-                          <a:latin typeface="微軟正黑體"/>
-                        </a:rPr>
-                        <a:t>期望損失(=票息原料)</a:t>
-                      </a:r>
-                    </a:p>
-                  </a:txBody>
-                  <a:tcPr marL="45720" marR="45720" marT="18288" marB="18288">
-                    <a:solidFill>
-                      <a:srgbClr val="00295C"/>
+                        <a:rPr sz="1200" b="0">
+                          <a:solidFill>
+                            <a:srgbClr val="2A2A2A"/>
+                          </a:solidFill>
+                          <a:latin typeface="微軟正黑體"/>
+                        </a:rPr>
+                        <a:t>−69%</a:t>
+                      </a:r>
+                    </a:p>
+                  </a:txBody>
+                  <a:tcPr marL="45720" marR="45720" marT="18288" marB="18288">
+                    <a:solidFill>
+                      <a:srgbClr val="FFFFFF"/>
+                    </a:solidFill>
+                  </a:tcPr>
+                </a:tc>
+                <a:tc>
+                  <a:txBody>
+                    <a:bodyPr/>
+                    <a:lstStyle/>
+                    <a:p>
+                      <a:pPr algn="ctr"/>
+                      <a:r>
+                        <a:rPr sz="1200" b="0">
+                          <a:solidFill>
+                            <a:srgbClr val="2A2A2A"/>
+                          </a:solidFill>
+                          <a:latin typeface="微軟正黑體"/>
+                        </a:rPr>
+                        <a:t>2.69% → 1.60%</a:t>
+                      </a:r>
+                    </a:p>
+                  </a:txBody>
+                  <a:tcPr marL="45720" marR="45720" marT="18288" marB="18288">
+                    <a:solidFill>
+                      <a:srgbClr val="FFFFFF"/>
+                    </a:solidFill>
+                  </a:tcPr>
+                </a:tc>
+                <a:tc>
+                  <a:txBody>
+                    <a:bodyPr/>
+                    <a:lstStyle/>
+                    <a:p>
+                      <a:pPr algn="r"/>
+                      <a:r>
+                        <a:rPr sz="1200" b="0">
+                          <a:solidFill>
+                            <a:srgbClr val="2A2A2A"/>
+                          </a:solidFill>
+                          <a:latin typeface="微軟正黑體"/>
+                        </a:rPr>
+                        <a:t>−41%</a:t>
+                      </a:r>
+                    </a:p>
+                  </a:txBody>
+                  <a:tcPr marL="45720" marR="45720" marT="18288" marB="18288">
+                    <a:solidFill>
+                      <a:srgbClr val="FFFFFF"/>
                     </a:solidFill>
                   </a:tcPr>
                 </a:tc>
               </a:tr>
-              <a:tr h="444137">
+              <a:tr h="434340">
                 <a:tc>
                   <a:txBody>
                     <a:bodyPr/>
@@ -10026,13 +10119,130 @@
                     <a:p>
                       <a:pPr algn="r"/>
                       <a:r>
-                        <a:rPr sz="1100" b="1">
+                        <a:rPr sz="1200" b="1">
                           <a:solidFill>
                             <a:srgbClr val="2A2A2A"/>
                           </a:solidFill>
                           <a:latin typeface="微軟正黑體"/>
                         </a:rPr>
-                        <a:t>80%</a:t>
+                        <a:t>90%</a:t>
+                      </a:r>
+                    </a:p>
+                  </a:txBody>
+                  <a:tcPr marL="45720" marR="45720" marT="18288" marB="18288">
+                    <a:solidFill>
+                      <a:srgbClr val="F5F5F5"/>
+                    </a:solidFill>
+                  </a:tcPr>
+                </a:tc>
+                <a:tc>
+                  <a:txBody>
+                    <a:bodyPr/>
+                    <a:lstStyle/>
+                    <a:p>
+                      <a:pPr algn="ctr"/>
+                      <a:r>
+                        <a:rPr sz="1200" b="0">
+                          <a:solidFill>
+                            <a:srgbClr val="2A2A2A"/>
+                          </a:solidFill>
+                          <a:latin typeface="微軟正黑體"/>
+                        </a:rPr>
+                        <a:t>38.1% → 7.3%</a:t>
+                      </a:r>
+                    </a:p>
+                  </a:txBody>
+                  <a:tcPr marL="45720" marR="45720" marT="18288" marB="18288">
+                    <a:solidFill>
+                      <a:srgbClr val="F5F5F5"/>
+                    </a:solidFill>
+                  </a:tcPr>
+                </a:tc>
+                <a:tc>
+                  <a:txBody>
+                    <a:bodyPr/>
+                    <a:lstStyle/>
+                    <a:p>
+                      <a:pPr algn="r"/>
+                      <a:r>
+                        <a:rPr sz="1200" b="0">
+                          <a:solidFill>
+                            <a:srgbClr val="2A2A2A"/>
+                          </a:solidFill>
+                          <a:latin typeface="微軟正黑體"/>
+                        </a:rPr>
+                        <a:t>−81%</a:t>
+                      </a:r>
+                    </a:p>
+                  </a:txBody>
+                  <a:tcPr marL="45720" marR="45720" marT="18288" marB="18288">
+                    <a:solidFill>
+                      <a:srgbClr val="F5F5F5"/>
+                    </a:solidFill>
+                  </a:tcPr>
+                </a:tc>
+                <a:tc>
+                  <a:txBody>
+                    <a:bodyPr/>
+                    <a:lstStyle/>
+                    <a:p>
+                      <a:pPr algn="ctr"/>
+                      <a:r>
+                        <a:rPr sz="1200" b="0">
+                          <a:solidFill>
+                            <a:srgbClr val="2A2A2A"/>
+                          </a:solidFill>
+                          <a:latin typeface="微軟正黑體"/>
+                        </a:rPr>
+                        <a:t>5.70% → 2.32%</a:t>
+                      </a:r>
+                    </a:p>
+                  </a:txBody>
+                  <a:tcPr marL="45720" marR="45720" marT="18288" marB="18288">
+                    <a:solidFill>
+                      <a:srgbClr val="F5F5F5"/>
+                    </a:solidFill>
+                  </a:tcPr>
+                </a:tc>
+                <a:tc>
+                  <a:txBody>
+                    <a:bodyPr/>
+                    <a:lstStyle/>
+                    <a:p>
+                      <a:pPr algn="r"/>
+                      <a:r>
+                        <a:rPr sz="1200" b="0">
+                          <a:solidFill>
+                            <a:srgbClr val="2A2A2A"/>
+                          </a:solidFill>
+                          <a:latin typeface="微軟正黑體"/>
+                        </a:rPr>
+                        <a:t>−59%</a:t>
+                      </a:r>
+                    </a:p>
+                  </a:txBody>
+                  <a:tcPr marL="45720" marR="45720" marT="18288" marB="18288">
+                    <a:solidFill>
+                      <a:srgbClr val="F5F5F5"/>
+                    </a:solidFill>
+                  </a:tcPr>
+                </a:tc>
+              </a:tr>
+              <a:tr h="434340">
+                <a:tc>
+                  <a:txBody>
+                    <a:bodyPr/>
+                    <a:lstStyle/>
+                    <a:p>
+                      <a:pPr algn="r"/>
+                      <a:r>
+                        <a:rPr sz="1200" b="1">
+                          <a:solidFill>
+                            <a:srgbClr val="2A2A2A"/>
+                          </a:solidFill>
+                          <a:latin typeface="微軟正黑體"/>
+                        </a:rPr>
+                        <a:t>100%</a:t>
                       </a:r>
                     </a:p>
                   </a:txBody>
@@ -10047,15 +10257,15 @@
                     <a:bodyPr/>
                     <a:lstStyle/>
                     <a:p>
-                      <a:pPr algn="l"/>
-                      <a:r>
-                        <a:rPr sz="1100" b="0">
+                      <a:pPr algn="ctr"/>
+                      <a:r>
+                        <a:rPr sz="1200" b="0">
                           <a:solidFill>
                             <a:srgbClr val="2A2A2A"/>
                           </a:solidFill>
                           <a:latin typeface="微軟正黑體"/>
                         </a:rPr>
-                        <a:t>無 KI</a:t>
+                        <a:t>52.8% → 7.3%</a:t>
                       </a:r>
                     </a:p>
                   </a:txBody>
@@ -10072,13 +10282,13 @@
                     <a:p>
                       <a:pPr algn="r"/>
                       <a:r>
-                        <a:rPr sz="1100" b="0">
+                        <a:rPr sz="1200" b="0">
                           <a:solidFill>
                             <a:srgbClr val="2A2A2A"/>
                           </a:solidFill>
                           <a:latin typeface="微軟正黑體"/>
                         </a:rPr>
-                        <a:t>23.6%</a:t>
+                        <a:t>−86%</a:t>
                       </a:r>
                     </a:p>
                   </a:txBody>
@@ -10093,767 +10303,44 @@
                     <a:bodyPr/>
                     <a:lstStyle/>
                     <a:p>
+                      <a:pPr algn="ctr"/>
+                      <a:r>
+                        <a:rPr sz="1200" b="0">
+                          <a:solidFill>
+                            <a:srgbClr val="2A2A2A"/>
+                          </a:solidFill>
+                          <a:latin typeface="微軟正黑體"/>
+                        </a:rPr>
+                        <a:t>10.16% → 3.04%</a:t>
+                      </a:r>
+                    </a:p>
+                  </a:txBody>
+                  <a:tcPr marL="45720" marR="45720" marT="18288" marB="18288">
+                    <a:solidFill>
+                      <a:srgbClr val="FFFFFF"/>
+                    </a:solidFill>
+                  </a:tcPr>
+                </a:tc>
+                <a:tc>
+                  <a:txBody>
+                    <a:bodyPr/>
+                    <a:lstStyle/>
+                    <a:p>
                       <a:pPr algn="r"/>
                       <a:r>
-                        <a:rPr sz="1100" b="0">
+                        <a:rPr sz="1200" b="0">
                           <a:solidFill>
                             <a:srgbClr val="2A2A2A"/>
                           </a:solidFill>
                           <a:latin typeface="微軟正黑體"/>
                         </a:rPr>
-                        <a:t>11.6%</a:t>
+                        <a:t>−70%</a:t>
                       </a:r>
                     </a:p>
                   </a:txBody>
                   <a:tcPr marL="45720" marR="45720" marT="18288" marB="18288">
                     <a:solidFill>
                       <a:srgbClr val="FFFFFF"/>
-                    </a:solidFill>
-                  </a:tcPr>
-                </a:tc>
-                <a:tc>
-                  <a:txBody>
-                    <a:bodyPr/>
-                    <a:lstStyle/>
-                    <a:p>
-                      <a:pPr algn="r"/>
-                      <a:r>
-                        <a:rPr sz="1100" b="0">
-                          <a:solidFill>
-                            <a:srgbClr val="2A2A2A"/>
-                          </a:solidFill>
-                          <a:latin typeface="微軟正黑體"/>
-                        </a:rPr>
-                        <a:t>~0%</a:t>
-                      </a:r>
-                    </a:p>
-                  </a:txBody>
-                  <a:tcPr marL="45720" marR="45720" marT="18288" marB="18288">
-                    <a:solidFill>
-                      <a:srgbClr val="FFFFFF"/>
-                    </a:solidFill>
-                  </a:tcPr>
-                </a:tc>
-                <a:tc>
-                  <a:txBody>
-                    <a:bodyPr/>
-                    <a:lstStyle/>
-                    <a:p>
-                      <a:pPr algn="r"/>
-                      <a:r>
-                        <a:rPr sz="1100" b="0">
-                          <a:solidFill>
-                            <a:srgbClr val="2A2A2A"/>
-                          </a:solidFill>
-                          <a:latin typeface="微軟正黑體"/>
-                        </a:rPr>
-                        <a:t>2.69%</a:t>
-                      </a:r>
-                    </a:p>
-                  </a:txBody>
-                  <a:tcPr marL="45720" marR="45720" marT="18288" marB="18288">
-                    <a:solidFill>
-                      <a:srgbClr val="FFFFFF"/>
-                    </a:solidFill>
-                  </a:tcPr>
-                </a:tc>
-              </a:tr>
-              <a:tr h="444137">
-                <a:tc>
-                  <a:txBody>
-                    <a:bodyPr/>
-                    <a:lstStyle/>
-                    <a:p>
-                      <a:pPr algn="r"/>
-                      <a:r>
-                        <a:rPr sz="1100" b="1">
-                          <a:solidFill>
-                            <a:srgbClr val="2A2A2A"/>
-                          </a:solidFill>
-                          <a:latin typeface="微軟正黑體"/>
-                        </a:rPr>
-                        <a:t>80%</a:t>
-                      </a:r>
-                    </a:p>
-                  </a:txBody>
-                  <a:tcPr marL="45720" marR="45720" marT="18288" marB="18288">
-                    <a:solidFill>
-                      <a:srgbClr val="F5F5F5"/>
-                    </a:solidFill>
-                  </a:tcPr>
-                </a:tc>
-                <a:tc>
-                  <a:txBody>
-                    <a:bodyPr/>
-                    <a:lstStyle/>
-                    <a:p>
-                      <a:pPr algn="l"/>
-                      <a:r>
-                        <a:rPr sz="1100" b="0">
-                          <a:solidFill>
-                            <a:srgbClr val="2A2A2A"/>
-                          </a:solidFill>
-                          <a:latin typeface="微軟正黑體"/>
-                        </a:rPr>
-                        <a:t>EKI 65%</a:t>
-                      </a:r>
-                    </a:p>
-                  </a:txBody>
-                  <a:tcPr marL="45720" marR="45720" marT="18288" marB="18288">
-                    <a:solidFill>
-                      <a:srgbClr val="F5F5F5"/>
-                    </a:solidFill>
-                  </a:tcPr>
-                </a:tc>
-                <a:tc>
-                  <a:txBody>
-                    <a:bodyPr/>
-                    <a:lstStyle/>
-                    <a:p>
-                      <a:pPr algn="r"/>
-                      <a:r>
-                        <a:rPr sz="1100" b="0">
-                          <a:solidFill>
-                            <a:srgbClr val="2A2A2A"/>
-                          </a:solidFill>
-                          <a:latin typeface="微軟正黑體"/>
-                        </a:rPr>
-                        <a:t>7.3%</a:t>
-                      </a:r>
-                    </a:p>
-                  </a:txBody>
-                  <a:tcPr marL="45720" marR="45720" marT="18288" marB="18288">
-                    <a:solidFill>
-                      <a:srgbClr val="F5F5F5"/>
-                    </a:solidFill>
-                  </a:tcPr>
-                </a:tc>
-                <a:tc>
-                  <a:txBody>
-                    <a:bodyPr/>
-                    <a:lstStyle/>
-                    <a:p>
-                      <a:pPr algn="r"/>
-                      <a:r>
-                        <a:rPr sz="1100" b="0">
-                          <a:solidFill>
-                            <a:srgbClr val="2A2A2A"/>
-                          </a:solidFill>
-                          <a:latin typeface="微軟正黑體"/>
-                        </a:rPr>
-                        <a:t>22.4%</a:t>
-                      </a:r>
-                    </a:p>
-                  </a:txBody>
-                  <a:tcPr marL="45720" marR="45720" marT="18288" marB="18288">
-                    <a:solidFill>
-                      <a:srgbClr val="F5F5F5"/>
-                    </a:solidFill>
-                  </a:tcPr>
-                </a:tc>
-                <a:tc>
-                  <a:txBody>
-                    <a:bodyPr/>
-                    <a:lstStyle/>
-                    <a:p>
-                      <a:pPr algn="r"/>
-                      <a:r>
-                        <a:rPr sz="1100" b="0">
-                          <a:solidFill>
-                            <a:srgbClr val="2A2A2A"/>
-                          </a:solidFill>
-                          <a:latin typeface="微軟正黑體"/>
-                        </a:rPr>
-                        <a:t>15.0%</a:t>
-                      </a:r>
-                    </a:p>
-                  </a:txBody>
-                  <a:tcPr marL="45720" marR="45720" marT="18288" marB="18288">
-                    <a:solidFill>
-                      <a:srgbClr val="F5F5F5"/>
-                    </a:solidFill>
-                  </a:tcPr>
-                </a:tc>
-                <a:tc>
-                  <a:txBody>
-                    <a:bodyPr/>
-                    <a:lstStyle/>
-                    <a:p>
-                      <a:pPr algn="r"/>
-                      <a:r>
-                        <a:rPr sz="1100" b="0">
-                          <a:solidFill>
-                            <a:srgbClr val="2A2A2A"/>
-                          </a:solidFill>
-                          <a:latin typeface="微軟正黑體"/>
-                        </a:rPr>
-                        <a:t>1.60%</a:t>
-                      </a:r>
-                    </a:p>
-                  </a:txBody>
-                  <a:tcPr marL="45720" marR="45720" marT="18288" marB="18288">
-                    <a:solidFill>
-                      <a:srgbClr val="F5F5F5"/>
-                    </a:solidFill>
-                  </a:tcPr>
-                </a:tc>
-              </a:tr>
-              <a:tr h="444137">
-                <a:tc>
-                  <a:txBody>
-                    <a:bodyPr/>
-                    <a:lstStyle/>
-                    <a:p>
-                      <a:pPr algn="r"/>
-                      <a:r>
-                        <a:rPr sz="1100" b="1">
-                          <a:solidFill>
-                            <a:srgbClr val="2A2A2A"/>
-                          </a:solidFill>
-                          <a:latin typeface="微軟正黑體"/>
-                        </a:rPr>
-                        <a:t>90%</a:t>
-                      </a:r>
-                    </a:p>
-                  </a:txBody>
-                  <a:tcPr marL="45720" marR="45720" marT="18288" marB="18288">
-                    <a:solidFill>
-                      <a:srgbClr val="FFFFFF"/>
-                    </a:solidFill>
-                  </a:tcPr>
-                </a:tc>
-                <a:tc>
-                  <a:txBody>
-                    <a:bodyPr/>
-                    <a:lstStyle/>
-                    <a:p>
-                      <a:pPr algn="l"/>
-                      <a:r>
-                        <a:rPr sz="1100" b="0">
-                          <a:solidFill>
-                            <a:srgbClr val="2A2A2A"/>
-                          </a:solidFill>
-                          <a:latin typeface="微軟正黑體"/>
-                        </a:rPr>
-                        <a:t>無 KI</a:t>
-                      </a:r>
-                    </a:p>
-                  </a:txBody>
-                  <a:tcPr marL="45720" marR="45720" marT="18288" marB="18288">
-                    <a:solidFill>
-                      <a:srgbClr val="FFFFFF"/>
-                    </a:solidFill>
-                  </a:tcPr>
-                </a:tc>
-                <a:tc>
-                  <a:txBody>
-                    <a:bodyPr/>
-                    <a:lstStyle/>
-                    <a:p>
-                      <a:pPr algn="r"/>
-                      <a:r>
-                        <a:rPr sz="1100" b="0">
-                          <a:solidFill>
-                            <a:srgbClr val="2A2A2A"/>
-                          </a:solidFill>
-                          <a:latin typeface="微軟正黑體"/>
-                        </a:rPr>
-                        <a:t>38.1%</a:t>
-                      </a:r>
-                    </a:p>
-                  </a:txBody>
-                  <a:tcPr marL="45720" marR="45720" marT="18288" marB="18288">
-                    <a:solidFill>
-                      <a:srgbClr val="FFFFFF"/>
-                    </a:solidFill>
-                  </a:tcPr>
-                </a:tc>
-                <a:tc>
-                  <a:txBody>
-                    <a:bodyPr/>
-                    <a:lstStyle/>
-                    <a:p>
-                      <a:pPr algn="r"/>
-                      <a:r>
-                        <a:rPr sz="1100" b="0">
-                          <a:solidFill>
-                            <a:srgbClr val="2A2A2A"/>
-                          </a:solidFill>
-                          <a:latin typeface="微軟正黑體"/>
-                        </a:rPr>
-                        <a:t>15.2%</a:t>
-                      </a:r>
-                    </a:p>
-                  </a:txBody>
-                  <a:tcPr marL="45720" marR="45720" marT="18288" marB="18288">
-                    <a:solidFill>
-                      <a:srgbClr val="FFFFFF"/>
-                    </a:solidFill>
-                  </a:tcPr>
-                </a:tc>
-                <a:tc>
-                  <a:txBody>
-                    <a:bodyPr/>
-                    <a:lstStyle/>
-                    <a:p>
-                      <a:pPr algn="r"/>
-                      <a:r>
-                        <a:rPr sz="1100" b="0">
-                          <a:solidFill>
-                            <a:srgbClr val="2A2A2A"/>
-                          </a:solidFill>
-                          <a:latin typeface="微軟正黑體"/>
-                        </a:rPr>
-                        <a:t>~0%</a:t>
-                      </a:r>
-                    </a:p>
-                  </a:txBody>
-                  <a:tcPr marL="45720" marR="45720" marT="18288" marB="18288">
-                    <a:solidFill>
-                      <a:srgbClr val="FFFFFF"/>
-                    </a:solidFill>
-                  </a:tcPr>
-                </a:tc>
-                <a:tc>
-                  <a:txBody>
-                    <a:bodyPr/>
-                    <a:lstStyle/>
-                    <a:p>
-                      <a:pPr algn="r"/>
-                      <a:r>
-                        <a:rPr sz="1100" b="0">
-                          <a:solidFill>
-                            <a:srgbClr val="2A2A2A"/>
-                          </a:solidFill>
-                          <a:latin typeface="微軟正黑體"/>
-                        </a:rPr>
-                        <a:t>5.70%</a:t>
-                      </a:r>
-                    </a:p>
-                  </a:txBody>
-                  <a:tcPr marL="45720" marR="45720" marT="18288" marB="18288">
-                    <a:solidFill>
-                      <a:srgbClr val="FFFFFF"/>
-                    </a:solidFill>
-                  </a:tcPr>
-                </a:tc>
-              </a:tr>
-              <a:tr h="444137">
-                <a:tc>
-                  <a:txBody>
-                    <a:bodyPr/>
-                    <a:lstStyle/>
-                    <a:p>
-                      <a:pPr algn="r"/>
-                      <a:r>
-                        <a:rPr sz="1100" b="1">
-                          <a:solidFill>
-                            <a:srgbClr val="2A2A2A"/>
-                          </a:solidFill>
-                          <a:latin typeface="微軟正黑體"/>
-                        </a:rPr>
-                        <a:t>90%</a:t>
-                      </a:r>
-                    </a:p>
-                  </a:txBody>
-                  <a:tcPr marL="45720" marR="45720" marT="18288" marB="18288">
-                    <a:solidFill>
-                      <a:srgbClr val="F5F5F5"/>
-                    </a:solidFill>
-                  </a:tcPr>
-                </a:tc>
-                <a:tc>
-                  <a:txBody>
-                    <a:bodyPr/>
-                    <a:lstStyle/>
-                    <a:p>
-                      <a:pPr algn="l"/>
-                      <a:r>
-                        <a:rPr sz="1100" b="0">
-                          <a:solidFill>
-                            <a:srgbClr val="2A2A2A"/>
-                          </a:solidFill>
-                          <a:latin typeface="微軟正黑體"/>
-                        </a:rPr>
-                        <a:t>EKI 65%</a:t>
-                      </a:r>
-                    </a:p>
-                  </a:txBody>
-                  <a:tcPr marL="45720" marR="45720" marT="18288" marB="18288">
-                    <a:solidFill>
-                      <a:srgbClr val="F5F5F5"/>
-                    </a:solidFill>
-                  </a:tcPr>
-                </a:tc>
-                <a:tc>
-                  <a:txBody>
-                    <a:bodyPr/>
-                    <a:lstStyle/>
-                    <a:p>
-                      <a:pPr algn="r"/>
-                      <a:r>
-                        <a:rPr sz="1100" b="0">
-                          <a:solidFill>
-                            <a:srgbClr val="2A2A2A"/>
-                          </a:solidFill>
-                          <a:latin typeface="微軟正黑體"/>
-                        </a:rPr>
-                        <a:t>7.3%</a:t>
-                      </a:r>
-                    </a:p>
-                  </a:txBody>
-                  <a:tcPr marL="45720" marR="45720" marT="18288" marB="18288">
-                    <a:solidFill>
-                      <a:srgbClr val="F5F5F5"/>
-                    </a:solidFill>
-                  </a:tcPr>
-                </a:tc>
-                <a:tc>
-                  <a:txBody>
-                    <a:bodyPr/>
-                    <a:lstStyle/>
-                    <a:p>
-                      <a:pPr algn="r"/>
-                      <a:r>
-                        <a:rPr sz="1100" b="0">
-                          <a:solidFill>
-                            <a:srgbClr val="2A2A2A"/>
-                          </a:solidFill>
-                          <a:latin typeface="微軟正黑體"/>
-                        </a:rPr>
-                        <a:t>32.4%</a:t>
-                      </a:r>
-                    </a:p>
-                  </a:txBody>
-                  <a:tcPr marL="45720" marR="45720" marT="18288" marB="18288">
-                    <a:solidFill>
-                      <a:srgbClr val="F5F5F5"/>
-                    </a:solidFill>
-                  </a:tcPr>
-                </a:tc>
-                <a:tc>
-                  <a:txBody>
-                    <a:bodyPr/>
-                    <a:lstStyle/>
-                    <a:p>
-                      <a:pPr algn="r"/>
-                      <a:r>
-                        <a:rPr sz="1100" b="0">
-                          <a:solidFill>
-                            <a:srgbClr val="2A2A2A"/>
-                          </a:solidFill>
-                          <a:latin typeface="微軟正黑體"/>
-                        </a:rPr>
-                        <a:t>25.0%</a:t>
-                      </a:r>
-                    </a:p>
-                  </a:txBody>
-                  <a:tcPr marL="45720" marR="45720" marT="18288" marB="18288">
-                    <a:solidFill>
-                      <a:srgbClr val="F5F5F5"/>
-                    </a:solidFill>
-                  </a:tcPr>
-                </a:tc>
-                <a:tc>
-                  <a:txBody>
-                    <a:bodyPr/>
-                    <a:lstStyle/>
-                    <a:p>
-                      <a:pPr algn="r"/>
-                      <a:r>
-                        <a:rPr sz="1100" b="0">
-                          <a:solidFill>
-                            <a:srgbClr val="2A2A2A"/>
-                          </a:solidFill>
-                          <a:latin typeface="微軟正黑體"/>
-                        </a:rPr>
-                        <a:t>2.32%</a:t>
-                      </a:r>
-                    </a:p>
-                  </a:txBody>
-                  <a:tcPr marL="45720" marR="45720" marT="18288" marB="18288">
-                    <a:solidFill>
-                      <a:srgbClr val="F5F5F5"/>
-                    </a:solidFill>
-                  </a:tcPr>
-                </a:tc>
-              </a:tr>
-              <a:tr h="444137">
-                <a:tc>
-                  <a:txBody>
-                    <a:bodyPr/>
-                    <a:lstStyle/>
-                    <a:p>
-                      <a:pPr algn="r"/>
-                      <a:r>
-                        <a:rPr sz="1100" b="1">
-                          <a:solidFill>
-                            <a:srgbClr val="2A2A2A"/>
-                          </a:solidFill>
-                          <a:latin typeface="微軟正黑體"/>
-                        </a:rPr>
-                        <a:t>100%</a:t>
-                      </a:r>
-                    </a:p>
-                  </a:txBody>
-                  <a:tcPr marL="45720" marR="45720" marT="18288" marB="18288">
-                    <a:solidFill>
-                      <a:srgbClr val="FFFFFF"/>
-                    </a:solidFill>
-                  </a:tcPr>
-                </a:tc>
-                <a:tc>
-                  <a:txBody>
-                    <a:bodyPr/>
-                    <a:lstStyle/>
-                    <a:p>
-                      <a:pPr algn="l"/>
-                      <a:r>
-                        <a:rPr sz="1100" b="0">
-                          <a:solidFill>
-                            <a:srgbClr val="2A2A2A"/>
-                          </a:solidFill>
-                          <a:latin typeface="微軟正黑體"/>
-                        </a:rPr>
-                        <a:t>無 KI</a:t>
-                      </a:r>
-                    </a:p>
-                  </a:txBody>
-                  <a:tcPr marL="45720" marR="45720" marT="18288" marB="18288">
-                    <a:solidFill>
-                      <a:srgbClr val="FFFFFF"/>
-                    </a:solidFill>
-                  </a:tcPr>
-                </a:tc>
-                <a:tc>
-                  <a:txBody>
-                    <a:bodyPr/>
-                    <a:lstStyle/>
-                    <a:p>
-                      <a:pPr algn="r"/>
-                      <a:r>
-                        <a:rPr sz="1100" b="0">
-                          <a:solidFill>
-                            <a:srgbClr val="2A2A2A"/>
-                          </a:solidFill>
-                          <a:latin typeface="微軟正黑體"/>
-                        </a:rPr>
-                        <a:t>52.8%</a:t>
-                      </a:r>
-                    </a:p>
-                  </a:txBody>
-                  <a:tcPr marL="45720" marR="45720" marT="18288" marB="18288">
-                    <a:solidFill>
-                      <a:srgbClr val="FFFFFF"/>
-                    </a:solidFill>
-                  </a:tcPr>
-                </a:tc>
-                <a:tc>
-                  <a:txBody>
-                    <a:bodyPr/>
-                    <a:lstStyle/>
-                    <a:p>
-                      <a:pPr algn="r"/>
-                      <a:r>
-                        <a:rPr sz="1100" b="0">
-                          <a:solidFill>
-                            <a:srgbClr val="2A2A2A"/>
-                          </a:solidFill>
-                          <a:latin typeface="微軟正黑體"/>
-                        </a:rPr>
-                        <a:t>19.6%</a:t>
-                      </a:r>
-                    </a:p>
-                  </a:txBody>
-                  <a:tcPr marL="45720" marR="45720" marT="18288" marB="18288">
-                    <a:solidFill>
-                      <a:srgbClr val="FFFFFF"/>
-                    </a:solidFill>
-                  </a:tcPr>
-                </a:tc>
-                <a:tc>
-                  <a:txBody>
-                    <a:bodyPr/>
-                    <a:lstStyle/>
-                    <a:p>
-                      <a:pPr algn="r"/>
-                      <a:r>
-                        <a:rPr sz="1100" b="0">
-                          <a:solidFill>
-                            <a:srgbClr val="2A2A2A"/>
-                          </a:solidFill>
-                          <a:latin typeface="微軟正黑體"/>
-                        </a:rPr>
-                        <a:t>~0%</a:t>
-                      </a:r>
-                    </a:p>
-                  </a:txBody>
-                  <a:tcPr marL="45720" marR="45720" marT="18288" marB="18288">
-                    <a:solidFill>
-                      <a:srgbClr val="FFFFFF"/>
-                    </a:solidFill>
-                  </a:tcPr>
-                </a:tc>
-                <a:tc>
-                  <a:txBody>
-                    <a:bodyPr/>
-                    <a:lstStyle/>
-                    <a:p>
-                      <a:pPr algn="r"/>
-                      <a:r>
-                        <a:rPr sz="1100" b="0">
-                          <a:solidFill>
-                            <a:srgbClr val="2A2A2A"/>
-                          </a:solidFill>
-                          <a:latin typeface="微軟正黑體"/>
-                        </a:rPr>
-                        <a:t>10.16%</a:t>
-                      </a:r>
-                    </a:p>
-                  </a:txBody>
-                  <a:tcPr marL="45720" marR="45720" marT="18288" marB="18288">
-                    <a:solidFill>
-                      <a:srgbClr val="FFFFFF"/>
-                    </a:solidFill>
-                  </a:tcPr>
-                </a:tc>
-              </a:tr>
-              <a:tr h="444138">
-                <a:tc>
-                  <a:txBody>
-                    <a:bodyPr/>
-                    <a:lstStyle/>
-                    <a:p>
-                      <a:pPr algn="r"/>
-                      <a:r>
-                        <a:rPr sz="1100" b="1">
-                          <a:solidFill>
-                            <a:srgbClr val="2A2A2A"/>
-                          </a:solidFill>
-                          <a:latin typeface="微軟正黑體"/>
-                        </a:rPr>
-                        <a:t>100%</a:t>
-                      </a:r>
-                    </a:p>
-                  </a:txBody>
-                  <a:tcPr marL="45720" marR="45720" marT="18288" marB="18288">
-                    <a:solidFill>
-                      <a:srgbClr val="F5F5F5"/>
-                    </a:solidFill>
-                  </a:tcPr>
-                </a:tc>
-                <a:tc>
-                  <a:txBody>
-                    <a:bodyPr/>
-                    <a:lstStyle/>
-                    <a:p>
-                      <a:pPr algn="l"/>
-                      <a:r>
-                        <a:rPr sz="1100" b="0">
-                          <a:solidFill>
-                            <a:srgbClr val="2A2A2A"/>
-                          </a:solidFill>
-                          <a:latin typeface="微軟正黑體"/>
-                        </a:rPr>
-                        <a:t>EKI 65%</a:t>
-                      </a:r>
-                    </a:p>
-                  </a:txBody>
-                  <a:tcPr marL="45720" marR="45720" marT="18288" marB="18288">
-                    <a:solidFill>
-                      <a:srgbClr val="F5F5F5"/>
-                    </a:solidFill>
-                  </a:tcPr>
-                </a:tc>
-                <a:tc>
-                  <a:txBody>
-                    <a:bodyPr/>
-                    <a:lstStyle/>
-                    <a:p>
-                      <a:pPr algn="r"/>
-                      <a:r>
-                        <a:rPr sz="1100" b="0">
-                          <a:solidFill>
-                            <a:srgbClr val="2A2A2A"/>
-                          </a:solidFill>
-                          <a:latin typeface="微軟正黑體"/>
-                        </a:rPr>
-                        <a:t>7.3%</a:t>
-                      </a:r>
-                    </a:p>
-                  </a:txBody>
-                  <a:tcPr marL="45720" marR="45720" marT="18288" marB="18288">
-                    <a:solidFill>
-                      <a:srgbClr val="F5F5F5"/>
-                    </a:solidFill>
-                  </a:tcPr>
-                </a:tc>
-                <a:tc>
-                  <a:txBody>
-                    <a:bodyPr/>
-                    <a:lstStyle/>
-                    <a:p>
-                      <a:pPr algn="r"/>
-                      <a:r>
-                        <a:rPr sz="1100" b="0">
-                          <a:solidFill>
-                            <a:srgbClr val="2A2A2A"/>
-                          </a:solidFill>
-                          <a:latin typeface="微軟正黑體"/>
-                        </a:rPr>
-                        <a:t>42.4%</a:t>
-                      </a:r>
-                    </a:p>
-                  </a:txBody>
-                  <a:tcPr marL="45720" marR="45720" marT="18288" marB="18288">
-                    <a:solidFill>
-                      <a:srgbClr val="F5F5F5"/>
-                    </a:solidFill>
-                  </a:tcPr>
-                </a:tc>
-                <a:tc>
-                  <a:txBody>
-                    <a:bodyPr/>
-                    <a:lstStyle/>
-                    <a:p>
-                      <a:pPr algn="r"/>
-                      <a:r>
-                        <a:rPr sz="1100" b="0">
-                          <a:solidFill>
-                            <a:srgbClr val="2A2A2A"/>
-                          </a:solidFill>
-                          <a:latin typeface="微軟正黑體"/>
-                        </a:rPr>
-                        <a:t>35.0%</a:t>
-                      </a:r>
-                    </a:p>
-                  </a:txBody>
-                  <a:tcPr marL="45720" marR="45720" marT="18288" marB="18288">
-                    <a:solidFill>
-                      <a:srgbClr val="F5F5F5"/>
-                    </a:solidFill>
-                  </a:tcPr>
-                </a:tc>
-                <a:tc>
-                  <a:txBody>
-                    <a:bodyPr/>
-                    <a:lstStyle/>
-                    <a:p>
-                      <a:pPr algn="r"/>
-                      <a:r>
-                        <a:rPr sz="1100" b="0">
-                          <a:solidFill>
-                            <a:srgbClr val="2A2A2A"/>
-                          </a:solidFill>
-                          <a:latin typeface="微軟正黑體"/>
-                        </a:rPr>
-                        <a:t>3.04%</a:t>
-                      </a:r>
-                    </a:p>
-                  </a:txBody>
-                  <a:tcPr marL="45720" marR="45720" marT="18288" marB="18288">
-                    <a:solidFill>
-                      <a:srgbClr val="F5F5F5"/>
                     </a:solidFill>
                   </a:tcPr>
                 </a:tc>
@@ -10870,6 +10357,93 @@
         </p:nvSpPr>
         <p:spPr>
           <a:xfrm>
+            <a:off x="502920" y="3246120"/>
+            <a:ext cx="6675120" cy="2560320"/>
+          </a:xfrm>
+          <a:prstGeom prst="rect">
+            <a:avLst/>
+          </a:prstGeom>
+          <a:noFill/>
+        </p:spPr>
+        <p:txBody>
+          <a:bodyPr wrap="square" anchor="t" lIns="0" rIns="0" tIns="0" bIns="0">
+            <a:spAutoFit/>
+          </a:bodyPr>
+          <a:lstStyle/>
+          <a:p>
+            <a:pPr algn="l">
+              <a:lnSpc>
+                <a:spcPct val="130000"/>
+              </a:lnSpc>
+            </a:pPr>
+            <a:r>
+              <a:rPr sz="1300" b="1">
+                <a:solidFill>
+                  <a:srgbClr val="00295C"/>
+                </a:solidFill>
+                <a:latin typeface="微軟正黑體"/>
+              </a:rPr>
+              <a:t>機率降幅永遠 &gt; 預期損失降幅（差 16~28pp）</a:t>
+            </a:r>
+          </a:p>
+          <a:p>
+            <a:pPr algn="l">
+              <a:lnSpc>
+                <a:spcPct val="130000"/>
+              </a:lnSpc>
+            </a:pPr>
+            <a:r>
+              <a:rPr sz="1100" b="0">
+                <a:solidFill>
+                  <a:srgbClr val="2A2A2A"/>
+                </a:solidFill>
+                <a:latin typeface="微軟正黑體"/>
+              </a:rPr>
+              <a:t>EKI 刪掉的是高頻低損的淺層轉換（65%&lt;S&lt;K）：「次數」掉得快、「錢」掉得慢；深層情境（S&lt;65%）有無 EKI 損益完全相同 — 免小傷、不免大傷。</a:t>
+            </a:r>
+          </a:p>
+          <a:p>
+            <a:pPr algn="l">
+              <a:lnSpc>
+                <a:spcPct val="130000"/>
+              </a:lnSpc>
+            </a:pPr>
+            <a:r>
+              <a:rPr sz="1300" b="1">
+                <a:solidFill>
+                  <a:srgbClr val="00295C"/>
+                </a:solidFill>
+                <a:latin typeface="微軟正黑體"/>
+              </a:rPr>
+              <a:t>兩個降幅的差距 = severity 濃縮</a:t>
+            </a:r>
+          </a:p>
+          <a:p>
+            <a:pPr algn="l">
+              <a:lnSpc>
+                <a:spcPct val="130000"/>
+              </a:lnSpc>
+            </a:pPr>
+            <a:r>
+              <a:rPr sz="1100" b="0">
+                <a:solidFill>
+                  <a:srgbClr val="2A2A2A"/>
+                </a:solidFill>
+                <a:latin typeface="微軟正黑體"/>
+              </a:rPr>
+              <a:t>每 1% 轉換機率攜帶的預期損失上升：K=100% 時 19.6% → 42.4%，最低損失自 ~0% 跳到 K−KI = 35%。</a:t>
+            </a:r>
+          </a:p>
+        </p:txBody>
+      </p:sp>
+      <p:sp>
+        <p:nvSpPr>
+          <p:cNvPr id="8" name="TextBox 7"/>
+          <p:cNvSpPr txBox="1"/>
+          <p:nvPr/>
+        </p:nvSpPr>
+        <p:spPr>
+          <a:xfrm>
             <a:off x="7452360" y="1234440"/>
             <a:ext cx="4206240" cy="4572000"/>
           </a:xfrm>
@@ -10896,7 +10470,7 @@
                 </a:solidFill>
                 <a:latin typeface="微軟正黑體"/>
               </a:rPr>
-              <a:t>1. EKI 刪掉的全是淺層轉換</a:t>
+              <a:t>轉換機率與 K 脫鉤</a:t>
             </a:r>
           </a:p>
           <a:p>
@@ -10912,7 +10486,7 @@
                 </a:solidFill>
                 <a:latin typeface="微軟正黑體"/>
               </a:rPr>
-              <a:t>深層情境（S&lt;65%）有無 EKI 損益相同 — 免小傷、不免大傷；留下的轉換全是深的（條件損失 11.6%→22.4%）</a:t>
+              <a:t>EKI 後三檔 K 都是 7.3% = P(S&lt;KI)。K 只剩「決定轉換深度」— EKI 讓 K 可以積極的機制；但 K 80→100% 預期損失僅 +1.44pp、懸崖 +20pp，對客戶是純 severity</a:t>
             </a:r>
           </a:p>
           <a:p>
@@ -10928,7 +10502,7 @@
                 </a:solidFill>
                 <a:latin typeface="微軟正黑體"/>
               </a:rPr>
-              <a:t>2. 轉換機率與 K 脫鉤</a:t>
+              <a:t>溝通與比價各取一欄</a:t>
             </a:r>
           </a:p>
           <a:p>
@@ -10944,7 +10518,7 @@
                 </a:solidFill>
                 <a:latin typeface="微軟正黑體"/>
               </a:rPr>
-              <a:t>三檔 K 全是 7.3% = P(S&lt;KI)。K 只決定轉換深度，最低損失 = K−KI — 這就是「EKI 讓 K 可以積極」的機制，代價是純 severity</a:t>
+              <a:t>「轉換機率 −86%」是賣點話術欄；「預期損失只 −70%、剩餘轉換深度翻倍」是完整敘述欄。預期損失欄 = 公平票息讓渡上限：票息差 &lt; 預期損失差 → 客戶在補貼發行端</a:t>
             </a:r>
           </a:p>
           <a:p>
@@ -10960,7 +10534,7 @@
                 </a:solidFill>
                 <a:latin typeface="微軟正黑體"/>
               </a:rPr>
-              <a:t>3. 票息讓渡 = 被刪中段的價值</a:t>
+              <a:t>觀察頻率是隱藏參數</a:t>
             </a:r>
           </a:p>
           <a:p>
@@ -10976,38 +10550,6 @@
                 </a:solidFill>
                 <a:latin typeface="微軟正黑體"/>
               </a:rPr>
-              <a:t>K=100%：放棄 7.13pp 換轉換機率 −45.5pp；EKI 下 K 80→100% 票息只 +1.44pp、懸崖 +20pp</a:t>
-            </a:r>
-          </a:p>
-          <a:p>
-            <a:pPr algn="l">
-              <a:lnSpc>
-                <a:spcPct val="125000"/>
-              </a:lnSpc>
-            </a:pPr>
-            <a:r>
-              <a:rPr sz="1200" b="1">
-                <a:solidFill>
-                  <a:srgbClr val="00295C"/>
-                </a:solidFill>
-                <a:latin typeface="微軟正黑體"/>
-              </a:rPr>
-              <a:t>4. 觀察頻率是隱藏參數</a:t>
-            </a:r>
-          </a:p>
-          <a:p>
-            <a:pPr algn="l">
-              <a:lnSpc>
-                <a:spcPct val="125000"/>
-              </a:lnSpc>
-            </a:pPr>
-            <a:r>
-              <a:rPr sz="1050" b="0">
-                <a:solidFill>
-                  <a:srgbClr val="2A2A2A"/>
-                </a:solidFill>
-                <a:latin typeface="微軟正黑體"/>
-              </a:rPr>
               <a:t>KI 65% 改每日觀察觸發率 7.3%→~12.9%，且模型未含跳空（MU 單週 −13%）</a:t>
             </a:r>
           </a:p>
@@ -11015,7 +10557,7 @@
       </p:sp>
       <p:sp>
         <p:nvSpPr>
-          <p:cNvPr id="8" name="Rectangle 7"/>
+          <p:cNvPr id="9" name="Rectangle 8"/>
           <p:cNvSpPr/>
           <p:nvPr/>
         </p:nvSpPr>
@@ -11059,7 +10601,7 @@
       </p:sp>
       <p:sp>
         <p:nvSpPr>
-          <p:cNvPr id="9" name="TextBox 8"/>
+          <p:cNvPr id="10" name="TextBox 9"/>
           <p:cNvSpPr txBox="1"/>
           <p:nvPr/>
         </p:nvSpPr>
@@ -11100,7 +10642,7 @@
                 </a:solidFill>
                 <a:latin typeface="微軟正黑體"/>
               </a:rPr>
-              <a:t>同 K 對照才看得到：EKI 買掉的是頻率、留下的是嚴重度 — 「高執行價+低轉換機率」的賣相由票息讓渡與懸崖加深支付。</a:t>
+              <a:t>EKI 買掉的是頻率、留下的是嚴重度：機率降幅與預期損失降幅之間的楔子，就是客戶承接的尾部。</a:t>
             </a:r>
           </a:p>
         </p:txBody>

</xml_diff>

<commit_message>
Add decision considerations for each K x EKI combination
Co-Authored-By: Claude Fable 5 <noreply@anthropic.com>
Claude-Session: https://claude.ai/code/session_01GD397krbJR1Gef3zPEk8sc
</commit_message>
<xml_diff>
--- a/_draft_fcn_weekly_2026-07-03.pptx
+++ b/_draft_fcn_weekly_2026-07-03.pptx
@@ -14,6 +14,7 @@
     <p:sldId id="262" r:id="rId13"/>
     <p:sldId id="263" r:id="rId14"/>
     <p:sldId id="264" r:id="rId15"/>
+    <p:sldId id="265" r:id="rId16"/>
   </p:sldIdLst>
   <p:sldSz cx="12191695" cy="6858000" type="screen4x3"/>
   <p:notesSz cx="6858000" cy="9144000"/>
@@ -3763,6 +3764,183 @@
 </p:sld>
 </file>
 
+<file path=ppt/slides/slide10.xml><?xml version="1.0" encoding="utf-8"?>
+<p:sld xmlns:a="http://schemas.openxmlformats.org/drawingml/2006/main" xmlns:p="http://schemas.openxmlformats.org/presentationml/2006/main" xmlns:r="http://schemas.openxmlformats.org/officeDocument/2006/relationships">
+  <p:cSld>
+    <p:spTree>
+      <p:nvGrpSpPr>
+        <p:cNvPr id="1" name=""/>
+        <p:cNvGrpSpPr/>
+        <p:nvPr/>
+      </p:nvGrpSpPr>
+      <p:grpSpPr/>
+      <p:sp>
+        <p:nvSpPr>
+          <p:cNvPr id="2" name="Rectangle 1"/>
+          <p:cNvSpPr/>
+          <p:nvPr/>
+        </p:nvSpPr>
+        <p:spPr>
+          <a:xfrm>
+            <a:off x="0" y="0"/>
+            <a:ext cx="12191695" cy="6858000"/>
+          </a:xfrm>
+          <a:prstGeom prst="rect">
+            <a:avLst/>
+          </a:prstGeom>
+          <a:solidFill>
+            <a:srgbClr val="101010"/>
+          </a:solidFill>
+          <a:ln>
+            <a:noFill/>
+          </a:ln>
+          <a:effectLst/>
+        </p:spPr>
+        <p:style>
+          <a:lnRef idx="1">
+            <a:schemeClr val="accent1"/>
+          </a:lnRef>
+          <a:fillRef idx="3">
+            <a:schemeClr val="accent1"/>
+          </a:fillRef>
+          <a:effectRef idx="2">
+            <a:schemeClr val="accent1"/>
+          </a:effectRef>
+          <a:fontRef idx="minor">
+            <a:schemeClr val="lt1"/>
+          </a:fontRef>
+        </p:style>
+        <p:txBody>
+          <a:bodyPr rtlCol="0" anchor="ctr"/>
+          <a:lstStyle/>
+          <a:p>
+            <a:pPr algn="ctr"/>
+          </a:p>
+        </p:txBody>
+      </p:sp>
+      <p:sp>
+        <p:nvSpPr>
+          <p:cNvPr id="3" name="Rectangle 2"/>
+          <p:cNvSpPr/>
+          <p:nvPr/>
+        </p:nvSpPr>
+        <p:spPr>
+          <a:xfrm>
+            <a:off x="640080" y="3017520"/>
+            <a:ext cx="2011680" cy="38100"/>
+          </a:xfrm>
+          <a:prstGeom prst="rect">
+            <a:avLst/>
+          </a:prstGeom>
+          <a:solidFill>
+            <a:srgbClr val="FFB81C"/>
+          </a:solidFill>
+          <a:ln>
+            <a:noFill/>
+          </a:ln>
+          <a:effectLst/>
+        </p:spPr>
+        <p:style>
+          <a:lnRef idx="1">
+            <a:schemeClr val="accent1"/>
+          </a:lnRef>
+          <a:fillRef idx="3">
+            <a:schemeClr val="accent1"/>
+          </a:fillRef>
+          <a:effectRef idx="2">
+            <a:schemeClr val="accent1"/>
+          </a:effectRef>
+          <a:fontRef idx="minor">
+            <a:schemeClr val="lt1"/>
+          </a:fontRef>
+        </p:style>
+        <p:txBody>
+          <a:bodyPr rtlCol="0" anchor="ctr"/>
+          <a:lstStyle/>
+          <a:p>
+            <a:pPr algn="ctr"/>
+          </a:p>
+        </p:txBody>
+      </p:sp>
+      <p:sp>
+        <p:nvSpPr>
+          <p:cNvPr id="4" name="TextBox 3"/>
+          <p:cNvSpPr txBox="1"/>
+          <p:nvPr/>
+        </p:nvSpPr>
+        <p:spPr>
+          <a:xfrm>
+            <a:off x="640080" y="3246120"/>
+            <a:ext cx="10881360" cy="1463040"/>
+          </a:xfrm>
+          <a:prstGeom prst="rect">
+            <a:avLst/>
+          </a:prstGeom>
+          <a:noFill/>
+        </p:spPr>
+        <p:txBody>
+          <a:bodyPr wrap="square" anchor="t" lIns="0" rIns="0" tIns="0" bIns="0">
+            <a:spAutoFit/>
+          </a:bodyPr>
+          <a:lstStyle/>
+          <a:p>
+            <a:pPr algn="l">
+              <a:lnSpc>
+                <a:spcPct val="150000"/>
+              </a:lnSpc>
+            </a:pPr>
+            <a:r>
+              <a:rPr sz="3000" b="1">
+                <a:solidFill>
+                  <a:srgbClr val="FFFFFF"/>
+                </a:solidFill>
+                <a:latin typeface="微軟正黑體"/>
+              </a:rPr>
+              <a:t>FCN Weekly — KI/KO 期望值週報</a:t>
+            </a:r>
+          </a:p>
+          <a:p>
+            <a:pPr algn="l">
+              <a:lnSpc>
+                <a:spcPct val="150000"/>
+              </a:lnSpc>
+            </a:pPr>
+            <a:r>
+              <a:rPr sz="1400" b="0">
+                <a:solidFill>
+                  <a:srgbClr val="FFB81C"/>
+                </a:solidFill>
+                <a:latin typeface="微軟正黑體"/>
+              </a:rPr>
+              <a:t>20260706 期  |  v0 partial scan  |  Monday 校正後定稿</a:t>
+            </a:r>
+          </a:p>
+          <a:p>
+            <a:pPr algn="l">
+              <a:lnSpc>
+                <a:spcPct val="150000"/>
+              </a:lnSpc>
+            </a:pPr>
+            <a:r>
+              <a:rPr sz="1100" b="0">
+                <a:solidFill>
+                  <a:srgbClr val="E8E8E8"/>
+                </a:solidFill>
+                <a:latin typeface="微軟正黑體"/>
+              </a:rPr>
+              <a:t>本簡報之票息與條款均為示意，非報價；投資決策以正式產品文件為準。</a:t>
+            </a:r>
+          </a:p>
+        </p:txBody>
+      </p:sp>
+    </p:spTree>
+  </p:cSld>
+  <p:clrMapOvr>
+    <a:masterClrMapping/>
+  </p:clrMapOvr>
+</p:sld>
+</file>
+
 <file path=ppt/slides/slide2.xml><?xml version="1.0" encoding="utf-8"?>
 <p:sld xmlns:a="http://schemas.openxmlformats.org/drawingml/2006/main" xmlns:p="http://schemas.openxmlformats.org/presentationml/2006/main" xmlns:r="http://schemas.openxmlformats.org/officeDocument/2006/relationships">
   <p:cSld>
@@ -10787,7 +10965,7 @@
         </p:nvSpPr>
         <p:spPr>
           <a:xfrm>
-            <a:off x="640080" y="502920"/>
+            <a:off x="640080" y="457200"/>
             <a:ext cx="10972800" cy="457200"/>
           </a:xfrm>
           <a:prstGeom prst="rect">
@@ -10809,23 +10987,657 @@
                 </a:solidFill>
                 <a:latin typeface="微軟正黑體"/>
               </a:rPr>
-              <a:t>五  Monday 待決策</a:t>
-            </a:r>
-          </a:p>
-        </p:txBody>
-      </p:sp>
-      <p:sp>
-        <p:nvSpPr>
-          <p:cNvPr id="6" name="Oval 5"/>
+              <a:t>四之三  六種組合的決策考量</a:t>
+            </a:r>
+            <a:r>
+              <a:rPr sz="1200" b="0">
+                <a:solidFill>
+                  <a:srgbClr val="555555"/>
+                </a:solidFill>
+                <a:latin typeface="微軟正黑體"/>
+              </a:rPr>
+              <a:t>   列 = 有無 EKI · 欄 = K 檔位 · 票息為 6M 期望損失</a:t>
+            </a:r>
+          </a:p>
+        </p:txBody>
+      </p:sp>
+      <p:sp>
+        <p:nvSpPr>
+          <p:cNvPr id="6" name="Rectangle 5"/>
           <p:cNvSpPr/>
           <p:nvPr/>
         </p:nvSpPr>
         <p:spPr>
           <a:xfrm>
-            <a:off x="731520" y="1325880"/>
-            <a:ext cx="384048" cy="384048"/>
-          </a:xfrm>
-          <a:prstGeom prst="ellipse">
+            <a:off x="502920" y="1143000"/>
+            <a:ext cx="3703320" cy="1920240"/>
+          </a:xfrm>
+          <a:prstGeom prst="rect">
+            <a:avLst/>
+          </a:prstGeom>
+          <a:solidFill>
+            <a:srgbClr val="FFFFFF"/>
+          </a:solidFill>
+          <a:ln w="12700">
+            <a:solidFill>
+              <a:srgbClr val="C8C8C8"/>
+            </a:solidFill>
+          </a:ln>
+          <a:effectLst/>
+        </p:spPr>
+        <p:style>
+          <a:lnRef idx="1">
+            <a:schemeClr val="accent1"/>
+          </a:lnRef>
+          <a:fillRef idx="3">
+            <a:schemeClr val="accent1"/>
+          </a:fillRef>
+          <a:effectRef idx="2">
+            <a:schemeClr val="accent1"/>
+          </a:effectRef>
+          <a:fontRef idx="minor">
+            <a:schemeClr val="lt1"/>
+          </a:fontRef>
+        </p:style>
+        <p:txBody>
+          <a:bodyPr rtlCol="0" anchor="ctr"/>
+          <a:lstStyle/>
+          <a:p>
+            <a:pPr algn="ctr"/>
+          </a:p>
+        </p:txBody>
+      </p:sp>
+      <p:sp>
+        <p:nvSpPr>
+          <p:cNvPr id="7" name="Rectangle 6"/>
+          <p:cNvSpPr/>
+          <p:nvPr/>
+        </p:nvSpPr>
+        <p:spPr>
+          <a:xfrm>
+            <a:off x="502920" y="1143000"/>
+            <a:ext cx="3703320" cy="31750"/>
+          </a:xfrm>
+          <a:prstGeom prst="rect">
+            <a:avLst/>
+          </a:prstGeom>
+          <a:solidFill>
+            <a:srgbClr val="00295C"/>
+          </a:solidFill>
+          <a:ln>
+            <a:noFill/>
+          </a:ln>
+          <a:effectLst/>
+        </p:spPr>
+        <p:style>
+          <a:lnRef idx="1">
+            <a:schemeClr val="accent1"/>
+          </a:lnRef>
+          <a:fillRef idx="3">
+            <a:schemeClr val="accent1"/>
+          </a:fillRef>
+          <a:effectRef idx="2">
+            <a:schemeClr val="accent1"/>
+          </a:effectRef>
+          <a:fontRef idx="minor">
+            <a:schemeClr val="lt1"/>
+          </a:fontRef>
+        </p:style>
+        <p:txBody>
+          <a:bodyPr rtlCol="0" anchor="ctr"/>
+          <a:lstStyle/>
+          <a:p>
+            <a:pPr algn="ctr"/>
+          </a:p>
+        </p:txBody>
+      </p:sp>
+      <p:sp>
+        <p:nvSpPr>
+          <p:cNvPr id="8" name="TextBox 7"/>
+          <p:cNvSpPr txBox="1"/>
+          <p:nvPr/>
+        </p:nvSpPr>
+        <p:spPr>
+          <a:xfrm>
+            <a:off x="640080" y="1234440"/>
+            <a:ext cx="3429000" cy="502920"/>
+          </a:xfrm>
+          <a:prstGeom prst="rect">
+            <a:avLst/>
+          </a:prstGeom>
+          <a:noFill/>
+        </p:spPr>
+        <p:txBody>
+          <a:bodyPr wrap="square" anchor="t" lIns="0" rIns="0" tIns="0" bIns="0">
+            <a:spAutoFit/>
+          </a:bodyPr>
+          <a:lstStyle/>
+          <a:p>
+            <a:pPr algn="l">
+              <a:lnSpc>
+                <a:spcPct val="110000"/>
+              </a:lnSpc>
+            </a:pPr>
+            <a:r>
+              <a:rPr sz="1300" b="1">
+                <a:solidFill>
+                  <a:srgbClr val="101010"/>
+                </a:solidFill>
+                <a:latin typeface="微軟正黑體"/>
+              </a:rPr>
+              <a:t>K=80% 無KI</a:t>
+            </a:r>
+            <a:r>
+              <a:rPr sz="1200" b="1">
+                <a:solidFill>
+                  <a:srgbClr val="C88E10"/>
+                </a:solidFill>
+                <a:latin typeface="微軟正黑體"/>
+              </a:rPr>
+              <a:t>   2.69%</a:t>
+            </a:r>
+          </a:p>
+          <a:p>
+            <a:pPr algn="l">
+              <a:lnSpc>
+                <a:spcPct val="110000"/>
+              </a:lnSpc>
+            </a:pPr>
+            <a:r>
+              <a:rPr sz="1000" b="1">
+                <a:solidFill>
+                  <a:srgbClr val="00295C"/>
+                </a:solidFill>
+                <a:latin typeface="微軟正黑體"/>
+              </a:rPr>
+              <a:t>中頻淺損 · 折價接股型</a:t>
+            </a:r>
+          </a:p>
+        </p:txBody>
+      </p:sp>
+      <p:sp>
+        <p:nvSpPr>
+          <p:cNvPr id="9" name="TextBox 8"/>
+          <p:cNvSpPr txBox="1"/>
+          <p:nvPr/>
+        </p:nvSpPr>
+        <p:spPr>
+          <a:xfrm>
+            <a:off x="640080" y="1801368"/>
+            <a:ext cx="3429000" cy="1188720"/>
+          </a:xfrm>
+          <a:prstGeom prst="rect">
+            <a:avLst/>
+          </a:prstGeom>
+          <a:noFill/>
+        </p:spPr>
+        <p:txBody>
+          <a:bodyPr wrap="square" anchor="t" lIns="0" rIns="0" tIns="0" bIns="0">
+            <a:spAutoFit/>
+          </a:bodyPr>
+          <a:lstStyle/>
+          <a:p>
+            <a:pPr algn="l">
+              <a:lnSpc>
+                <a:spcPct val="115000"/>
+              </a:lnSpc>
+            </a:pPr>
+            <a:r>
+              <a:rPr sz="950" b="0">
+                <a:solidFill>
+                  <a:srgbClr val="2A2A2A"/>
+                </a:solidFill>
+                <a:latin typeface="微軟正黑體"/>
+              </a:rPr>
+              <a:t>客戶願意在 80% 接這檔股票嗎？轉換是進場不是災難 — 標的選願意長抱的（TSM 型）；票息偏薄需跑贏直債</a:t>
+            </a:r>
+          </a:p>
+        </p:txBody>
+      </p:sp>
+      <p:sp>
+        <p:nvSpPr>
+          <p:cNvPr id="10" name="Rectangle 9"/>
+          <p:cNvSpPr/>
+          <p:nvPr/>
+        </p:nvSpPr>
+        <p:spPr>
+          <a:xfrm>
+            <a:off x="4361688" y="1143000"/>
+            <a:ext cx="3703320" cy="1920240"/>
+          </a:xfrm>
+          <a:prstGeom prst="rect">
+            <a:avLst/>
+          </a:prstGeom>
+          <a:solidFill>
+            <a:srgbClr val="FFFFFF"/>
+          </a:solidFill>
+          <a:ln w="12700">
+            <a:solidFill>
+              <a:srgbClr val="C8C8C8"/>
+            </a:solidFill>
+          </a:ln>
+          <a:effectLst/>
+        </p:spPr>
+        <p:style>
+          <a:lnRef idx="1">
+            <a:schemeClr val="accent1"/>
+          </a:lnRef>
+          <a:fillRef idx="3">
+            <a:schemeClr val="accent1"/>
+          </a:fillRef>
+          <a:effectRef idx="2">
+            <a:schemeClr val="accent1"/>
+          </a:effectRef>
+          <a:fontRef idx="minor">
+            <a:schemeClr val="lt1"/>
+          </a:fontRef>
+        </p:style>
+        <p:txBody>
+          <a:bodyPr rtlCol="0" anchor="ctr"/>
+          <a:lstStyle/>
+          <a:p>
+            <a:pPr algn="ctr"/>
+          </a:p>
+        </p:txBody>
+      </p:sp>
+      <p:sp>
+        <p:nvSpPr>
+          <p:cNvPr id="11" name="Rectangle 10"/>
+          <p:cNvSpPr/>
+          <p:nvPr/>
+        </p:nvSpPr>
+        <p:spPr>
+          <a:xfrm>
+            <a:off x="4361688" y="1143000"/>
+            <a:ext cx="3703320" cy="31750"/>
+          </a:xfrm>
+          <a:prstGeom prst="rect">
+            <a:avLst/>
+          </a:prstGeom>
+          <a:solidFill>
+            <a:srgbClr val="00295C"/>
+          </a:solidFill>
+          <a:ln>
+            <a:noFill/>
+          </a:ln>
+          <a:effectLst/>
+        </p:spPr>
+        <p:style>
+          <a:lnRef idx="1">
+            <a:schemeClr val="accent1"/>
+          </a:lnRef>
+          <a:fillRef idx="3">
+            <a:schemeClr val="accent1"/>
+          </a:fillRef>
+          <a:effectRef idx="2">
+            <a:schemeClr val="accent1"/>
+          </a:effectRef>
+          <a:fontRef idx="minor">
+            <a:schemeClr val="lt1"/>
+          </a:fontRef>
+        </p:style>
+        <p:txBody>
+          <a:bodyPr rtlCol="0" anchor="ctr"/>
+          <a:lstStyle/>
+          <a:p>
+            <a:pPr algn="ctr"/>
+          </a:p>
+        </p:txBody>
+      </p:sp>
+      <p:sp>
+        <p:nvSpPr>
+          <p:cNvPr id="12" name="TextBox 11"/>
+          <p:cNvSpPr txBox="1"/>
+          <p:nvPr/>
+        </p:nvSpPr>
+        <p:spPr>
+          <a:xfrm>
+            <a:off x="4498848" y="1234440"/>
+            <a:ext cx="3429000" cy="502920"/>
+          </a:xfrm>
+          <a:prstGeom prst="rect">
+            <a:avLst/>
+          </a:prstGeom>
+          <a:noFill/>
+        </p:spPr>
+        <p:txBody>
+          <a:bodyPr wrap="square" anchor="t" lIns="0" rIns="0" tIns="0" bIns="0">
+            <a:spAutoFit/>
+          </a:bodyPr>
+          <a:lstStyle/>
+          <a:p>
+            <a:pPr algn="l">
+              <a:lnSpc>
+                <a:spcPct val="110000"/>
+              </a:lnSpc>
+            </a:pPr>
+            <a:r>
+              <a:rPr sz="1300" b="1">
+                <a:solidFill>
+                  <a:srgbClr val="101010"/>
+                </a:solidFill>
+                <a:latin typeface="微軟正黑體"/>
+              </a:rPr>
+              <a:t>K=90% 無KI</a:t>
+            </a:r>
+            <a:r>
+              <a:rPr sz="1200" b="1">
+                <a:solidFill>
+                  <a:srgbClr val="C88E10"/>
+                </a:solidFill>
+                <a:latin typeface="微軟正黑體"/>
+              </a:rPr>
+              <a:t>   5.70%</a:t>
+            </a:r>
+          </a:p>
+          <a:p>
+            <a:pPr algn="l">
+              <a:lnSpc>
+                <a:spcPct val="110000"/>
+              </a:lnSpc>
+            </a:pPr>
+            <a:r>
+              <a:rPr sz="1000" b="1">
+                <a:solidFill>
+                  <a:srgbClr val="00295C"/>
+                </a:solidFill>
+                <a:latin typeface="微軟正黑體"/>
+              </a:rPr>
+              <a:t>高頻中損 · 持股替代型</a:t>
+            </a:r>
+          </a:p>
+        </p:txBody>
+      </p:sp>
+      <p:sp>
+        <p:nvSpPr>
+          <p:cNvPr id="13" name="TextBox 12"/>
+          <p:cNvSpPr txBox="1"/>
+          <p:nvPr/>
+        </p:nvSpPr>
+        <p:spPr>
+          <a:xfrm>
+            <a:off x="4498848" y="1801368"/>
+            <a:ext cx="3429000" cy="1188720"/>
+          </a:xfrm>
+          <a:prstGeom prst="rect">
+            <a:avLst/>
+          </a:prstGeom>
+          <a:noFill/>
+        </p:spPr>
+        <p:txBody>
+          <a:bodyPr wrap="square" anchor="t" lIns="0" rIns="0" tIns="0" bIns="0">
+            <a:spAutoFit/>
+          </a:bodyPr>
+          <a:lstStyle/>
+          <a:p>
+            <a:pPr algn="l">
+              <a:lnSpc>
+                <a:spcPct val="115000"/>
+              </a:lnSpc>
+            </a:pPr>
+            <a:r>
+              <a:rPr sz="950" b="0">
+                <a:solidFill>
+                  <a:srgbClr val="2A2A2A"/>
+                </a:solidFill>
+                <a:latin typeface="微軟正黑體"/>
+              </a:rPr>
+              <a:t>轉換近四成 = 一年被轉換數次：接股後處置紀律與運營承受度？適合把 FCN 當持股策略的專業戶</a:t>
+            </a:r>
+          </a:p>
+        </p:txBody>
+      </p:sp>
+      <p:sp>
+        <p:nvSpPr>
+          <p:cNvPr id="14" name="Rectangle 13"/>
+          <p:cNvSpPr/>
+          <p:nvPr/>
+        </p:nvSpPr>
+        <p:spPr>
+          <a:xfrm>
+            <a:off x="8220456" y="1143000"/>
+            <a:ext cx="3703320" cy="1920240"/>
+          </a:xfrm>
+          <a:prstGeom prst="rect">
+            <a:avLst/>
+          </a:prstGeom>
+          <a:solidFill>
+            <a:srgbClr val="FFFFFF"/>
+          </a:solidFill>
+          <a:ln w="12700">
+            <a:solidFill>
+              <a:srgbClr val="C8C8C8"/>
+            </a:solidFill>
+          </a:ln>
+          <a:effectLst/>
+        </p:spPr>
+        <p:style>
+          <a:lnRef idx="1">
+            <a:schemeClr val="accent1"/>
+          </a:lnRef>
+          <a:fillRef idx="3">
+            <a:schemeClr val="accent1"/>
+          </a:fillRef>
+          <a:effectRef idx="2">
+            <a:schemeClr val="accent1"/>
+          </a:effectRef>
+          <a:fontRef idx="minor">
+            <a:schemeClr val="lt1"/>
+          </a:fontRef>
+        </p:style>
+        <p:txBody>
+          <a:bodyPr rtlCol="0" anchor="ctr"/>
+          <a:lstStyle/>
+          <a:p>
+            <a:pPr algn="ctr"/>
+          </a:p>
+        </p:txBody>
+      </p:sp>
+      <p:sp>
+        <p:nvSpPr>
+          <p:cNvPr id="15" name="Rectangle 14"/>
+          <p:cNvSpPr/>
+          <p:nvPr/>
+        </p:nvSpPr>
+        <p:spPr>
+          <a:xfrm>
+            <a:off x="8220456" y="1143000"/>
+            <a:ext cx="3703320" cy="31750"/>
+          </a:xfrm>
+          <a:prstGeom prst="rect">
+            <a:avLst/>
+          </a:prstGeom>
+          <a:solidFill>
+            <a:srgbClr val="00295C"/>
+          </a:solidFill>
+          <a:ln>
+            <a:noFill/>
+          </a:ln>
+          <a:effectLst/>
+        </p:spPr>
+        <p:style>
+          <a:lnRef idx="1">
+            <a:schemeClr val="accent1"/>
+          </a:lnRef>
+          <a:fillRef idx="3">
+            <a:schemeClr val="accent1"/>
+          </a:fillRef>
+          <a:effectRef idx="2">
+            <a:schemeClr val="accent1"/>
+          </a:effectRef>
+          <a:fontRef idx="minor">
+            <a:schemeClr val="lt1"/>
+          </a:fontRef>
+        </p:style>
+        <p:txBody>
+          <a:bodyPr rtlCol="0" anchor="ctr"/>
+          <a:lstStyle/>
+          <a:p>
+            <a:pPr algn="ctr"/>
+          </a:p>
+        </p:txBody>
+      </p:sp>
+      <p:sp>
+        <p:nvSpPr>
+          <p:cNvPr id="16" name="TextBox 15"/>
+          <p:cNvSpPr txBox="1"/>
+          <p:nvPr/>
+        </p:nvSpPr>
+        <p:spPr>
+          <a:xfrm>
+            <a:off x="8357616" y="1234440"/>
+            <a:ext cx="3429000" cy="502920"/>
+          </a:xfrm>
+          <a:prstGeom prst="rect">
+            <a:avLst/>
+          </a:prstGeom>
+          <a:noFill/>
+        </p:spPr>
+        <p:txBody>
+          <a:bodyPr wrap="square" anchor="t" lIns="0" rIns="0" tIns="0" bIns="0">
+            <a:spAutoFit/>
+          </a:bodyPr>
+          <a:lstStyle/>
+          <a:p>
+            <a:pPr algn="l">
+              <a:lnSpc>
+                <a:spcPct val="110000"/>
+              </a:lnSpc>
+            </a:pPr>
+            <a:r>
+              <a:rPr sz="1300" b="1">
+                <a:solidFill>
+                  <a:srgbClr val="101010"/>
+                </a:solidFill>
+                <a:latin typeface="微軟正黑體"/>
+              </a:rPr>
+              <a:t>K=100% 無KI</a:t>
+            </a:r>
+            <a:r>
+              <a:rPr sz="1200" b="1">
+                <a:solidFill>
+                  <a:srgbClr val="C88E10"/>
+                </a:solidFill>
+                <a:latin typeface="微軟正黑體"/>
+              </a:rPr>
+              <a:t>   10.16%</a:t>
+            </a:r>
+          </a:p>
+          <a:p>
+            <a:pPr algn="l">
+              <a:lnSpc>
+                <a:spcPct val="110000"/>
+              </a:lnSpc>
+            </a:pPr>
+            <a:r>
+              <a:rPr sz="1000" b="1">
+                <a:solidFill>
+                  <a:srgbClr val="00295C"/>
+                </a:solidFill>
+                <a:latin typeface="微軟正黑體"/>
+              </a:rPr>
+              <a:t>極高頻 · 建倉工具型</a:t>
+            </a:r>
+          </a:p>
+        </p:txBody>
+      </p:sp>
+      <p:sp>
+        <p:nvSpPr>
+          <p:cNvPr id="17" name="TextBox 16"/>
+          <p:cNvSpPr txBox="1"/>
+          <p:nvPr/>
+        </p:nvSpPr>
+        <p:spPr>
+          <a:xfrm>
+            <a:off x="8357616" y="1801368"/>
+            <a:ext cx="3429000" cy="1188720"/>
+          </a:xfrm>
+          <a:prstGeom prst="rect">
+            <a:avLst/>
+          </a:prstGeom>
+          <a:noFill/>
+        </p:spPr>
+        <p:txBody>
+          <a:bodyPr wrap="square" anchor="t" lIns="0" rIns="0" tIns="0" bIns="0">
+            <a:spAutoFit/>
+          </a:bodyPr>
+          <a:lstStyle/>
+          <a:p>
+            <a:pPr algn="l">
+              <a:lnSpc>
+                <a:spcPct val="115000"/>
+              </a:lnSpc>
+            </a:pPr>
+            <a:r>
+              <a:rPr sz="950" b="0">
+                <a:solidFill>
+                  <a:srgbClr val="2A2A2A"/>
+                </a:solidFill>
+                <a:latin typeface="微軟正黑體"/>
+              </a:rPr>
+              <a:t>轉換過半 = 票息補貼的定期建倉；唯一票息真實反映風險的一格。帳戶能否接股？當建倉工具賣、不當收益商品賣</a:t>
+            </a:r>
+          </a:p>
+        </p:txBody>
+      </p:sp>
+      <p:sp>
+        <p:nvSpPr>
+          <p:cNvPr id="18" name="Rectangle 17"/>
+          <p:cNvSpPr/>
+          <p:nvPr/>
+        </p:nvSpPr>
+        <p:spPr>
+          <a:xfrm>
+            <a:off x="502920" y="3200400"/>
+            <a:ext cx="3703320" cy="1920240"/>
+          </a:xfrm>
+          <a:prstGeom prst="rect">
+            <a:avLst/>
+          </a:prstGeom>
+          <a:solidFill>
+            <a:srgbClr val="FFFFFF"/>
+          </a:solidFill>
+          <a:ln w="12700">
+            <a:solidFill>
+              <a:srgbClr val="C8C8C8"/>
+            </a:solidFill>
+          </a:ln>
+          <a:effectLst/>
+        </p:spPr>
+        <p:style>
+          <a:lnRef idx="1">
+            <a:schemeClr val="accent1"/>
+          </a:lnRef>
+          <a:fillRef idx="3">
+            <a:schemeClr val="accent1"/>
+          </a:fillRef>
+          <a:effectRef idx="2">
+            <a:schemeClr val="accent1"/>
+          </a:effectRef>
+          <a:fontRef idx="minor">
+            <a:schemeClr val="lt1"/>
+          </a:fontRef>
+        </p:style>
+        <p:txBody>
+          <a:bodyPr rtlCol="0" anchor="ctr"/>
+          <a:lstStyle/>
+          <a:p>
+            <a:pPr algn="ctr"/>
+          </a:p>
+        </p:txBody>
+      </p:sp>
+      <p:sp>
+        <p:nvSpPr>
+          <p:cNvPr id="19" name="Rectangle 18"/>
+          <p:cNvSpPr/>
+          <p:nvPr/>
+        </p:nvSpPr>
+        <p:spPr>
+          <a:xfrm>
+            <a:off x="502920" y="3200400"/>
+            <a:ext cx="3703320" cy="31750"/>
+          </a:xfrm>
+          <a:prstGeom prst="rect">
             <a:avLst/>
           </a:prstGeom>
           <a:solidFill>
@@ -10851,32 +11663,23 @@
           </a:fontRef>
         </p:style>
         <p:txBody>
-          <a:bodyPr rtlCol="0" anchor="ctr" lIns="0" rIns="0" tIns="0" bIns="0"/>
+          <a:bodyPr rtlCol="0" anchor="ctr"/>
           <a:lstStyle/>
           <a:p>
             <a:pPr algn="ctr"/>
-            <a:r>
-              <a:rPr sz="1400" b="1">
-                <a:solidFill>
-                  <a:srgbClr val="101010"/>
-                </a:solidFill>
-                <a:latin typeface="Calibri"/>
-              </a:rPr>
-              <a:t>1</a:t>
-            </a:r>
-          </a:p>
-        </p:txBody>
-      </p:sp>
-      <p:sp>
-        <p:nvSpPr>
-          <p:cNvPr id="7" name="TextBox 6"/>
+          </a:p>
+        </p:txBody>
+      </p:sp>
+      <p:sp>
+        <p:nvSpPr>
+          <p:cNvPr id="20" name="TextBox 19"/>
           <p:cNvSpPr txBox="1"/>
           <p:nvPr/>
         </p:nvSpPr>
         <p:spPr>
           <a:xfrm>
-            <a:off x="1325880" y="1362456"/>
-            <a:ext cx="10241280" cy="457200"/>
+            <a:off x="640080" y="3291840"/>
+            <a:ext cx="3429000" cy="502920"/>
           </a:xfrm>
           <a:prstGeom prst="rect">
             <a:avLst/>
@@ -10889,31 +11692,145 @@
           </a:bodyPr>
           <a:lstStyle/>
           <a:p>
-            <a:pPr algn="l"/>
-            <a:r>
-              <a:rPr sz="1300" b="0">
+            <a:pPr algn="l">
+              <a:lnSpc>
+                <a:spcPct val="110000"/>
+              </a:lnSpc>
+            </a:pPr>
+            <a:r>
+              <a:rPr sz="1300" b="1">
+                <a:solidFill>
+                  <a:srgbClr val="101010"/>
+                </a:solidFill>
+                <a:latin typeface="微軟正黑體"/>
+              </a:rPr>
+              <a:t>K=80% + EKI 65%</a:t>
+            </a:r>
+            <a:r>
+              <a:rPr sz="1200" b="1">
+                <a:solidFill>
+                  <a:srgbClr val="C88E10"/>
+                </a:solidFill>
+                <a:latin typeface="微軟正黑體"/>
+              </a:rPr>
+              <a:t>   1.60%</a:t>
+            </a:r>
+          </a:p>
+          <a:p>
+            <a:pPr algn="l">
+              <a:lnSpc>
+                <a:spcPct val="110000"/>
+              </a:lnSpc>
+            </a:pPr>
+            <a:r>
+              <a:rPr sz="1000" b="1">
+                <a:solidFill>
+                  <a:srgbClr val="00295C"/>
+                </a:solidFill>
+                <a:latin typeface="微軟正黑體"/>
+              </a:rPr>
+              <a:t>低頻中損 · 過度保護型</a:t>
+            </a:r>
+          </a:p>
+        </p:txBody>
+      </p:sp>
+      <p:sp>
+        <p:nvSpPr>
+          <p:cNvPr id="21" name="TextBox 20"/>
+          <p:cNvSpPr txBox="1"/>
+          <p:nvPr/>
+        </p:nvSpPr>
+        <p:spPr>
+          <a:xfrm>
+            <a:off x="640080" y="3858768"/>
+            <a:ext cx="3429000" cy="1188720"/>
+          </a:xfrm>
+          <a:prstGeom prst="rect">
+            <a:avLst/>
+          </a:prstGeom>
+          <a:noFill/>
+        </p:spPr>
+        <p:txBody>
+          <a:bodyPr wrap="square" anchor="t" lIns="0" rIns="0" tIns="0" bIns="0">
+            <a:spAutoFit/>
+          </a:bodyPr>
+          <a:lstStyle/>
+          <a:p>
+            <a:pPr algn="l">
+              <a:lnSpc>
+                <a:spcPct val="115000"/>
+              </a:lnSpc>
+            </a:pPr>
+            <a:r>
+              <a:rPr sz="950" b="0">
                 <a:solidFill>
                   <a:srgbClr val="2A2A2A"/>
                 </a:solidFill>
                 <a:latin typeface="微軟正黑體"/>
               </a:rPr>
-              <a:t>議題組合確認：1 主 + 2 補充（建議 01 存量健檢 + 05 防禦對照 + 06 TSLA 教材）</a:t>
-            </a:r>
-          </a:p>
-        </p:txBody>
-      </p:sp>
-      <p:sp>
-        <p:nvSpPr>
-          <p:cNvPr id="8" name="Oval 7"/>
+              <a:t>商品成立性：雙重保護後票息可能跑不贏 IG 直債 — 若票息 &lt; 直債+流動性讓渡，該勸客戶直接買債</a:t>
+            </a:r>
+          </a:p>
+        </p:txBody>
+      </p:sp>
+      <p:sp>
+        <p:nvSpPr>
+          <p:cNvPr id="22" name="Rectangle 21"/>
           <p:cNvSpPr/>
           <p:nvPr/>
         </p:nvSpPr>
         <p:spPr>
           <a:xfrm>
-            <a:off x="731520" y="1892808"/>
-            <a:ext cx="384048" cy="384048"/>
-          </a:xfrm>
-          <a:prstGeom prst="ellipse">
+            <a:off x="4361688" y="3200400"/>
+            <a:ext cx="3703320" cy="1920240"/>
+          </a:xfrm>
+          <a:prstGeom prst="rect">
+            <a:avLst/>
+          </a:prstGeom>
+          <a:solidFill>
+            <a:srgbClr val="FFFFFF"/>
+          </a:solidFill>
+          <a:ln w="12700">
+            <a:solidFill>
+              <a:srgbClr val="C8C8C8"/>
+            </a:solidFill>
+          </a:ln>
+          <a:effectLst/>
+        </p:spPr>
+        <p:style>
+          <a:lnRef idx="1">
+            <a:schemeClr val="accent1"/>
+          </a:lnRef>
+          <a:fillRef idx="3">
+            <a:schemeClr val="accent1"/>
+          </a:fillRef>
+          <a:effectRef idx="2">
+            <a:schemeClr val="accent1"/>
+          </a:effectRef>
+          <a:fontRef idx="minor">
+            <a:schemeClr val="lt1"/>
+          </a:fontRef>
+        </p:style>
+        <p:txBody>
+          <a:bodyPr rtlCol="0" anchor="ctr"/>
+          <a:lstStyle/>
+          <a:p>
+            <a:pPr algn="ctr"/>
+          </a:p>
+        </p:txBody>
+      </p:sp>
+      <p:sp>
+        <p:nvSpPr>
+          <p:cNvPr id="23" name="Rectangle 22"/>
+          <p:cNvSpPr/>
+          <p:nvPr/>
+        </p:nvSpPr>
+        <p:spPr>
+          <a:xfrm>
+            <a:off x="4361688" y="3200400"/>
+            <a:ext cx="3703320" cy="31750"/>
+          </a:xfrm>
+          <a:prstGeom prst="rect">
             <a:avLst/>
           </a:prstGeom>
           <a:solidFill>
@@ -10939,32 +11856,23 @@
           </a:fontRef>
         </p:style>
         <p:txBody>
-          <a:bodyPr rtlCol="0" anchor="ctr" lIns="0" rIns="0" tIns="0" bIns="0"/>
+          <a:bodyPr rtlCol="0" anchor="ctr"/>
           <a:lstStyle/>
           <a:p>
             <a:pPr algn="ctr"/>
-            <a:r>
-              <a:rPr sz="1400" b="1">
-                <a:solidFill>
-                  <a:srgbClr val="101010"/>
-                </a:solidFill>
-                <a:latin typeface="Calibri"/>
-              </a:rPr>
-              <a:t>2</a:t>
-            </a:r>
-          </a:p>
-        </p:txBody>
-      </p:sp>
-      <p:sp>
-        <p:nvSpPr>
-          <p:cNvPr id="9" name="TextBox 8"/>
+          </a:p>
+        </p:txBody>
+      </p:sp>
+      <p:sp>
+        <p:nvSpPr>
+          <p:cNvPr id="24" name="TextBox 23"/>
           <p:cNvSpPr txBox="1"/>
           <p:nvPr/>
         </p:nvSpPr>
         <p:spPr>
           <a:xfrm>
-            <a:off x="1325880" y="1929384"/>
-            <a:ext cx="10241280" cy="457200"/>
+            <a:off x="4498848" y="3291840"/>
+            <a:ext cx="3429000" cy="502920"/>
           </a:xfrm>
           <a:prstGeom prst="rect">
             <a:avLst/>
@@ -10977,31 +11885,145 @@
           </a:bodyPr>
           <a:lstStyle/>
           <a:p>
-            <a:pPr algn="l"/>
-            <a:r>
-              <a:rPr sz="1300" b="0">
+            <a:pPr algn="l">
+              <a:lnSpc>
+                <a:spcPct val="110000"/>
+              </a:lnSpc>
+            </a:pPr>
+            <a:r>
+              <a:rPr sz="1300" b="1">
+                <a:solidFill>
+                  <a:srgbClr val="101010"/>
+                </a:solidFill>
+                <a:latin typeface="微軟正黑體"/>
+              </a:rPr>
+              <a:t>K=90% + EKI 65%</a:t>
+            </a:r>
+            <a:r>
+              <a:rPr sz="1200" b="1">
+                <a:solidFill>
+                  <a:srgbClr val="C88E10"/>
+                </a:solidFill>
+                <a:latin typeface="微軟正黑體"/>
+              </a:rPr>
+              <a:t>   2.32%</a:t>
+            </a:r>
+          </a:p>
+          <a:p>
+            <a:pPr algn="l">
+              <a:lnSpc>
+                <a:spcPct val="110000"/>
+              </a:lnSpc>
+            </a:pPr>
+            <a:r>
+              <a:rPr sz="1000" b="1">
+                <a:solidFill>
+                  <a:srgbClr val="00295C"/>
+                </a:solidFill>
+                <a:latin typeface="微軟正黑體"/>
+              </a:rPr>
+              <a:t>低頻深損 · 不上不下型</a:t>
+            </a:r>
+          </a:p>
+        </p:txBody>
+      </p:sp>
+      <p:sp>
+        <p:nvSpPr>
+          <p:cNvPr id="25" name="TextBox 24"/>
+          <p:cNvSpPr txBox="1"/>
+          <p:nvPr/>
+        </p:nvSpPr>
+        <p:spPr>
+          <a:xfrm>
+            <a:off x="4498848" y="3858768"/>
+            <a:ext cx="3429000" cy="1188720"/>
+          </a:xfrm>
+          <a:prstGeom prst="rect">
+            <a:avLst/>
+          </a:prstGeom>
+          <a:noFill/>
+        </p:spPr>
+        <p:txBody>
+          <a:bodyPr wrap="square" anchor="t" lIns="0" rIns="0" tIns="0" bIns="0">
+            <a:spAutoFit/>
+          </a:bodyPr>
+          <a:lstStyle/>
+          <a:p>
+            <a:pPr algn="l">
+              <a:lnSpc>
+                <a:spcPct val="115000"/>
+              </a:lnSpc>
+            </a:pPr>
+            <a:r>
+              <a:rPr sz="950" b="0">
                 <a:solidFill>
                   <a:srgbClr val="2A2A2A"/>
                 </a:solidFill>
                 <a:latin typeface="微軟正黑體"/>
               </a:rPr>
-              <a:t>重抓 yfinance 校正全部 est. 數字（本週 4 交易日已完整）</a:t>
-            </a:r>
-          </a:p>
-        </p:txBody>
-      </p:sp>
-      <p:sp>
-        <p:nvSpPr>
-          <p:cNvPr id="10" name="Oval 9"/>
+              <a:t>存在理由：比左格只多 0.72pp 票息、懸崖加深 10pp — 通常是行銷門檻而非風險最適；先回答為何不是左右兩格</a:t>
+            </a:r>
+          </a:p>
+        </p:txBody>
+      </p:sp>
+      <p:sp>
+        <p:nvSpPr>
+          <p:cNvPr id="26" name="Rectangle 25"/>
           <p:cNvSpPr/>
           <p:nvPr/>
         </p:nvSpPr>
         <p:spPr>
           <a:xfrm>
-            <a:off x="731520" y="2459736"/>
-            <a:ext cx="384048" cy="384048"/>
-          </a:xfrm>
-          <a:prstGeom prst="ellipse">
+            <a:off x="8220456" y="3200400"/>
+            <a:ext cx="3703320" cy="1920240"/>
+          </a:xfrm>
+          <a:prstGeom prst="rect">
+            <a:avLst/>
+          </a:prstGeom>
+          <a:solidFill>
+            <a:srgbClr val="FFFFFF"/>
+          </a:solidFill>
+          <a:ln w="12700">
+            <a:solidFill>
+              <a:srgbClr val="C8C8C8"/>
+            </a:solidFill>
+          </a:ln>
+          <a:effectLst/>
+        </p:spPr>
+        <p:style>
+          <a:lnRef idx="1">
+            <a:schemeClr val="accent1"/>
+          </a:lnRef>
+          <a:fillRef idx="3">
+            <a:schemeClr val="accent1"/>
+          </a:fillRef>
+          <a:effectRef idx="2">
+            <a:schemeClr val="accent1"/>
+          </a:effectRef>
+          <a:fontRef idx="minor">
+            <a:schemeClr val="lt1"/>
+          </a:fontRef>
+        </p:style>
+        <p:txBody>
+          <a:bodyPr rtlCol="0" anchor="ctr"/>
+          <a:lstStyle/>
+          <a:p>
+            <a:pPr algn="ctr"/>
+          </a:p>
+        </p:txBody>
+      </p:sp>
+      <p:sp>
+        <p:nvSpPr>
+          <p:cNvPr id="27" name="Rectangle 26"/>
+          <p:cNvSpPr/>
+          <p:nvPr/>
+        </p:nvSpPr>
+        <p:spPr>
+          <a:xfrm>
+            <a:off x="8220456" y="3200400"/>
+            <a:ext cx="3703320" cy="31750"/>
+          </a:xfrm>
+          <a:prstGeom prst="rect">
             <a:avLst/>
           </a:prstGeom>
           <a:solidFill>
@@ -11027,32 +12049,23 @@
           </a:fontRef>
         </p:style>
         <p:txBody>
-          <a:bodyPr rtlCol="0" anchor="ctr" lIns="0" rIns="0" tIns="0" bIns="0"/>
+          <a:bodyPr rtlCol="0" anchor="ctr"/>
           <a:lstStyle/>
           <a:p>
             <a:pPr algn="ctr"/>
-            <a:r>
-              <a:rPr sz="1400" b="1">
-                <a:solidFill>
-                  <a:srgbClr val="101010"/>
-                </a:solidFill>
-                <a:latin typeface="Calibri"/>
-              </a:rPr>
-              <a:t>3</a:t>
-            </a:r>
-          </a:p>
-        </p:txBody>
-      </p:sp>
-      <p:sp>
-        <p:nvSpPr>
-          <p:cNvPr id="11" name="TextBox 10"/>
+          </a:p>
+        </p:txBody>
+      </p:sp>
+      <p:sp>
+        <p:nvSpPr>
+          <p:cNvPr id="28" name="TextBox 27"/>
           <p:cNvSpPr txBox="1"/>
           <p:nvPr/>
         </p:nvSpPr>
         <p:spPr>
           <a:xfrm>
-            <a:off x="1325880" y="2496312"/>
-            <a:ext cx="10241280" cy="457200"/>
+            <a:off x="8357616" y="3291840"/>
+            <a:ext cx="3429000" cy="502920"/>
           </a:xfrm>
           <a:prstGeom prst="rect">
             <a:avLst/>
@@ -11065,31 +12078,147 @@
           </a:bodyPr>
           <a:lstStyle/>
           <a:p>
-            <a:pPr algn="l"/>
-            <a:r>
-              <a:rPr sz="1300" b="0">
+            <a:pPr algn="l">
+              <a:lnSpc>
+                <a:spcPct val="110000"/>
+              </a:lnSpc>
+            </a:pPr>
+            <a:r>
+              <a:rPr sz="1300" b="1">
+                <a:solidFill>
+                  <a:srgbClr val="101010"/>
+                </a:solidFill>
+                <a:latin typeface="微軟正黑體"/>
+              </a:rPr>
+              <a:t>K=100% + EKI 65%</a:t>
+            </a:r>
+            <a:r>
+              <a:rPr sz="1200" b="1">
+                <a:solidFill>
+                  <a:srgbClr val="C88E10"/>
+                </a:solidFill>
+                <a:latin typeface="微軟正黑體"/>
+              </a:rPr>
+              <a:t>   3.04%</a:t>
+            </a:r>
+          </a:p>
+          <a:p>
+            <a:pPr algn="l">
+              <a:lnSpc>
+                <a:spcPct val="110000"/>
+              </a:lnSpc>
+            </a:pPr>
+            <a:r>
+              <a:rPr sz="1000" b="1">
+                <a:solidFill>
+                  <a:srgbClr val="00295C"/>
+                </a:solidFill>
+                <a:latin typeface="微軟正黑體"/>
+              </a:rPr>
+              <a:t>低頻懸崖 · 賣相款</a:t>
+            </a:r>
+          </a:p>
+        </p:txBody>
+      </p:sp>
+      <p:sp>
+        <p:nvSpPr>
+          <p:cNvPr id="29" name="TextBox 28"/>
+          <p:cNvSpPr txBox="1"/>
+          <p:nvPr/>
+        </p:nvSpPr>
+        <p:spPr>
+          <a:xfrm>
+            <a:off x="8357616" y="3858768"/>
+            <a:ext cx="3429000" cy="1188720"/>
+          </a:xfrm>
+          <a:prstGeom prst="rect">
+            <a:avLst/>
+          </a:prstGeom>
+          <a:noFill/>
+        </p:spPr>
+        <p:txBody>
+          <a:bodyPr wrap="square" anchor="t" lIns="0" rIns="0" tIns="0" bIns="0">
+            <a:spAutoFit/>
+          </a:bodyPr>
+          <a:lstStyle/>
+          <a:p>
+            <a:pPr algn="l">
+              <a:lnSpc>
+                <a:spcPct val="115000"/>
+              </a:lnSpc>
+            </a:pPr>
+            <a:r>
+              <a:rPr sz="950" b="0">
                 <a:solidFill>
                   <a:srgbClr val="2A2A2A"/>
                 </a:solidFill>
                 <a:latin typeface="微軟正黑體"/>
               </a:rPr>
-              <a:t>存續 FCN 部位盤點：半導體單一股 vintage 清單 + 各筆距 KI 緩衝計算</a:t>
-            </a:r>
-          </a:p>
-        </p:txBody>
-      </p:sp>
-      <p:sp>
-        <p:nvSpPr>
-          <p:cNvPr id="12" name="Oval 11"/>
+              <a:t>考慮全在尾部：單一股跳空與財報、同標的結構集中度、KI 真發生時（−35% 起跳）客戶的行為劇本</a:t>
+            </a:r>
+          </a:p>
+        </p:txBody>
+      </p:sp>
+      <p:sp>
+        <p:nvSpPr>
+          <p:cNvPr id="30" name="TextBox 29"/>
+          <p:cNvSpPr txBox="1"/>
+          <p:nvPr/>
+        </p:nvSpPr>
+        <p:spPr>
+          <a:xfrm>
+            <a:off x="640080" y="5349240"/>
+            <a:ext cx="10881360" cy="548640"/>
+          </a:xfrm>
+          <a:prstGeom prst="rect">
+            <a:avLst/>
+          </a:prstGeom>
+          <a:noFill/>
+        </p:spPr>
+        <p:txBody>
+          <a:bodyPr wrap="square" anchor="t" lIns="0" rIns="0" tIns="0" bIns="0">
+            <a:spAutoFit/>
+          </a:bodyPr>
+          <a:lstStyle/>
+          <a:p>
+            <a:pPr algn="l">
+              <a:lnSpc>
+                <a:spcPct val="120000"/>
+              </a:lnSpc>
+            </a:pPr>
+            <a:r>
+              <a:rPr sz="1050" b="1">
+                <a:solidFill>
+                  <a:srgbClr val="00295C"/>
+                </a:solidFill>
+                <a:latin typeface="微軟正黑體"/>
+              </a:rPr>
+              <a:t>五關 checklist：</a:t>
+            </a:r>
+            <a:r>
+              <a:rPr sz="1050" b="0">
+                <a:solidFill>
+                  <a:srgbClr val="2A2A2A"/>
+                </a:solidFill>
+                <a:latin typeface="微軟正黑體"/>
+              </a:rPr>
+              <a:t>① 票息 ≥ 期望損失＋成本  ② 接股後劇本先寫好  ③ 標的×條款交互（MU 型不配深KI＋高K）  ④ 觀察條款（改每日觸發率近 ×2）  ⑤ IV 水位（VIX 16.59 → 六格全面偏薄，等 vol spike）</a:t>
+            </a:r>
+          </a:p>
+        </p:txBody>
+      </p:sp>
+      <p:sp>
+        <p:nvSpPr>
+          <p:cNvPr id="31" name="Rectangle 30"/>
           <p:cNvSpPr/>
           <p:nvPr/>
         </p:nvSpPr>
         <p:spPr>
           <a:xfrm>
-            <a:off x="731520" y="3026664"/>
-            <a:ext cx="384048" cy="384048"/>
-          </a:xfrm>
-          <a:prstGeom prst="ellipse">
+            <a:off x="640080" y="5989320"/>
+            <a:ext cx="10881360" cy="31750"/>
+          </a:xfrm>
+          <a:prstGeom prst="rect">
             <a:avLst/>
           </a:prstGeom>
           <a:solidFill>
@@ -11115,32 +12244,23 @@
           </a:fontRef>
         </p:style>
         <p:txBody>
-          <a:bodyPr rtlCol="0" anchor="ctr" lIns="0" rIns="0" tIns="0" bIns="0"/>
+          <a:bodyPr rtlCol="0" anchor="ctr"/>
           <a:lstStyle/>
           <a:p>
             <a:pPr algn="ctr"/>
-            <a:r>
-              <a:rPr sz="1400" b="1">
-                <a:solidFill>
-                  <a:srgbClr val="101010"/>
-                </a:solidFill>
-                <a:latin typeface="Calibri"/>
-              </a:rPr>
-              <a:t>4</a:t>
-            </a:r>
-          </a:p>
-        </p:txBody>
-      </p:sp>
-      <p:sp>
-        <p:nvSpPr>
-          <p:cNvPr id="13" name="TextBox 12"/>
+          </a:p>
+        </p:txBody>
+      </p:sp>
+      <p:sp>
+        <p:nvSpPr>
+          <p:cNvPr id="32" name="TextBox 31"/>
           <p:cNvSpPr txBox="1"/>
           <p:nvPr/>
         </p:nvSpPr>
         <p:spPr>
           <a:xfrm>
-            <a:off x="1325880" y="3063240"/>
-            <a:ext cx="10241280" cy="457200"/>
+            <a:off x="640080" y="6052820"/>
+            <a:ext cx="10881360" cy="502920"/>
           </a:xfrm>
           <a:prstGeom prst="rect">
             <a:avLst/>
@@ -11153,402 +12273,28 @@
           </a:bodyPr>
           <a:lstStyle/>
           <a:p>
-            <a:pPr algn="l"/>
-            <a:r>
-              <a:rPr sz="1300" b="0">
+            <a:pPr algn="l">
+              <a:lnSpc>
+                <a:spcPct val="105000"/>
+              </a:lnSpc>
+            </a:pPr>
+            <a:r>
+              <a:rPr sz="1050" b="1">
+                <a:solidFill>
+                  <a:srgbClr val="C88E10"/>
+                </a:solidFill>
+                <a:latin typeface="微軟正黑體"/>
+              </a:rPr>
+              <a:t>BOTTOM LINE  </a:t>
+            </a:r>
+            <a:r>
+              <a:rPr sz="1050" b="1">
                 <a:solidFill>
                   <a:srgbClr val="2A2A2A"/>
                 </a:solidFill>
                 <a:latin typeface="微軟正黑體"/>
               </a:rPr>
-              <a:t>向交易台索取 NVDA/MU/TSLA/TSM 6M ATM IV 與 indicative coupon，替換示意值</a:t>
-            </a:r>
-          </a:p>
-        </p:txBody>
-      </p:sp>
-      <p:sp>
-        <p:nvSpPr>
-          <p:cNvPr id="14" name="Oval 13"/>
-          <p:cNvSpPr/>
-          <p:nvPr/>
-        </p:nvSpPr>
-        <p:spPr>
-          <a:xfrm>
-            <a:off x="731520" y="3593592"/>
-            <a:ext cx="384048" cy="384048"/>
-          </a:xfrm>
-          <a:prstGeom prst="ellipse">
-            <a:avLst/>
-          </a:prstGeom>
-          <a:solidFill>
-            <a:srgbClr val="FFB81C"/>
-          </a:solidFill>
-          <a:ln>
-            <a:noFill/>
-          </a:ln>
-          <a:effectLst/>
-        </p:spPr>
-        <p:style>
-          <a:lnRef idx="1">
-            <a:schemeClr val="accent1"/>
-          </a:lnRef>
-          <a:fillRef idx="3">
-            <a:schemeClr val="accent1"/>
-          </a:fillRef>
-          <a:effectRef idx="2">
-            <a:schemeClr val="accent1"/>
-          </a:effectRef>
-          <a:fontRef idx="minor">
-            <a:schemeClr val="lt1"/>
-          </a:fontRef>
-        </p:style>
-        <p:txBody>
-          <a:bodyPr rtlCol="0" anchor="ctr" lIns="0" rIns="0" tIns="0" bIns="0"/>
-          <a:lstStyle/>
-          <a:p>
-            <a:pPr algn="ctr"/>
-            <a:r>
-              <a:rPr sz="1400" b="1">
-                <a:solidFill>
-                  <a:srgbClr val="101010"/>
-                </a:solidFill>
-                <a:latin typeface="Calibri"/>
-              </a:rPr>
-              <a:t>5</a:t>
-            </a:r>
-          </a:p>
-        </p:txBody>
-      </p:sp>
-      <p:sp>
-        <p:nvSpPr>
-          <p:cNvPr id="15" name="TextBox 14"/>
-          <p:cNvSpPr txBox="1"/>
-          <p:nvPr/>
-        </p:nvSpPr>
-        <p:spPr>
-          <a:xfrm>
-            <a:off x="1325880" y="3630168"/>
-            <a:ext cx="10241280" cy="457200"/>
-          </a:xfrm>
-          <a:prstGeom prst="rect">
-            <a:avLst/>
-          </a:prstGeom>
-          <a:noFill/>
-        </p:spPr>
-        <p:txBody>
-          <a:bodyPr wrap="square" anchor="t" lIns="0" rIns="0" tIns="0" bIns="0">
-            <a:spAutoFit/>
-          </a:bodyPr>
-          <a:lstStyle/>
-          <a:p>
-            <a:pPr algn="l"/>
-            <a:r>
-              <a:rPr sz="1300" b="0">
-                <a:solidFill>
-                  <a:srgbClr val="2A2A2A"/>
-                </a:solidFill>
-                <a:latin typeface="微軟正黑體"/>
-              </a:rPr>
-              <a:t>NLM saturation Round 1+ 加 Codex Gate 3 平行驗證</a:t>
-            </a:r>
-          </a:p>
-        </p:txBody>
-      </p:sp>
-      <p:sp>
-        <p:nvSpPr>
-          <p:cNvPr id="16" name="Oval 15"/>
-          <p:cNvSpPr/>
-          <p:nvPr/>
-        </p:nvSpPr>
-        <p:spPr>
-          <a:xfrm>
-            <a:off x="731520" y="4160520"/>
-            <a:ext cx="384048" cy="384048"/>
-          </a:xfrm>
-          <a:prstGeom prst="ellipse">
-            <a:avLst/>
-          </a:prstGeom>
-          <a:solidFill>
-            <a:srgbClr val="FFB81C"/>
-          </a:solidFill>
-          <a:ln>
-            <a:noFill/>
-          </a:ln>
-          <a:effectLst/>
-        </p:spPr>
-        <p:style>
-          <a:lnRef idx="1">
-            <a:schemeClr val="accent1"/>
-          </a:lnRef>
-          <a:fillRef idx="3">
-            <a:schemeClr val="accent1"/>
-          </a:fillRef>
-          <a:effectRef idx="2">
-            <a:schemeClr val="accent1"/>
-          </a:effectRef>
-          <a:fontRef idx="minor">
-            <a:schemeClr val="lt1"/>
-          </a:fontRef>
-        </p:style>
-        <p:txBody>
-          <a:bodyPr rtlCol="0" anchor="ctr" lIns="0" rIns="0" tIns="0" bIns="0"/>
-          <a:lstStyle/>
-          <a:p>
-            <a:pPr algn="ctr"/>
-            <a:r>
-              <a:rPr sz="1400" b="1">
-                <a:solidFill>
-                  <a:srgbClr val="101010"/>
-                </a:solidFill>
-                <a:latin typeface="Calibri"/>
-              </a:rPr>
-              <a:t>6</a:t>
-            </a:r>
-          </a:p>
-        </p:txBody>
-      </p:sp>
-      <p:sp>
-        <p:nvSpPr>
-          <p:cNvPr id="17" name="TextBox 16"/>
-          <p:cNvSpPr txBox="1"/>
-          <p:nvPr/>
-        </p:nvSpPr>
-        <p:spPr>
-          <a:xfrm>
-            <a:off x="1325880" y="4197096"/>
-            <a:ext cx="10241280" cy="457200"/>
-          </a:xfrm>
-          <a:prstGeom prst="rect">
-            <a:avLst/>
-          </a:prstGeom>
-          <a:noFill/>
-        </p:spPr>
-        <p:txBody>
-          <a:bodyPr wrap="square" anchor="t" lIns="0" rIns="0" tIns="0" bIns="0">
-            <a:spAutoFit/>
-          </a:bodyPr>
-          <a:lstStyle/>
-          <a:p>
-            <a:pPr algn="l"/>
-            <a:r>
-              <a:rPr sz="1300" b="0">
-                <a:solidFill>
-                  <a:srgbClr val="2A2A2A"/>
-                </a:solidFill>
-                <a:latin typeface="微軟正黑體"/>
-              </a:rPr>
-              <a:t>寫 reading_map.md + 底稿.md（UWS 12 章節）</a:t>
-            </a:r>
-          </a:p>
-        </p:txBody>
-      </p:sp>
-      <p:sp>
-        <p:nvSpPr>
-          <p:cNvPr id="18" name="Oval 17"/>
-          <p:cNvSpPr/>
-          <p:nvPr/>
-        </p:nvSpPr>
-        <p:spPr>
-          <a:xfrm>
-            <a:off x="731520" y="4727448"/>
-            <a:ext cx="384048" cy="384048"/>
-          </a:xfrm>
-          <a:prstGeom prst="ellipse">
-            <a:avLst/>
-          </a:prstGeom>
-          <a:solidFill>
-            <a:srgbClr val="FFB81C"/>
-          </a:solidFill>
-          <a:ln>
-            <a:noFill/>
-          </a:ln>
-          <a:effectLst/>
-        </p:spPr>
-        <p:style>
-          <a:lnRef idx="1">
-            <a:schemeClr val="accent1"/>
-          </a:lnRef>
-          <a:fillRef idx="3">
-            <a:schemeClr val="accent1"/>
-          </a:fillRef>
-          <a:effectRef idx="2">
-            <a:schemeClr val="accent1"/>
-          </a:effectRef>
-          <a:fontRef idx="minor">
-            <a:schemeClr val="lt1"/>
-          </a:fontRef>
-        </p:style>
-        <p:txBody>
-          <a:bodyPr rtlCol="0" anchor="ctr" lIns="0" rIns="0" tIns="0" bIns="0"/>
-          <a:lstStyle/>
-          <a:p>
-            <a:pPr algn="ctr"/>
-            <a:r>
-              <a:rPr sz="1400" b="1">
-                <a:solidFill>
-                  <a:srgbClr val="101010"/>
-                </a:solidFill>
-                <a:latin typeface="Calibri"/>
-              </a:rPr>
-              <a:t>7</a:t>
-            </a:r>
-          </a:p>
-        </p:txBody>
-      </p:sp>
-      <p:sp>
-        <p:nvSpPr>
-          <p:cNvPr id="19" name="TextBox 18"/>
-          <p:cNvSpPr txBox="1"/>
-          <p:nvPr/>
-        </p:nvSpPr>
-        <p:spPr>
-          <a:xfrm>
-            <a:off x="1325880" y="4764024"/>
-            <a:ext cx="10241280" cy="457200"/>
-          </a:xfrm>
-          <a:prstGeom prst="rect">
-            <a:avLst/>
-          </a:prstGeom>
-          <a:noFill/>
-        </p:spPr>
-        <p:txBody>
-          <a:bodyPr wrap="square" anchor="t" lIns="0" rIns="0" tIns="0" bIns="0">
-            <a:spAutoFit/>
-          </a:bodyPr>
-          <a:lstStyle/>
-          <a:p>
-            <a:pPr algn="l"/>
-            <a:r>
-              <a:rPr sz="1300" b="0">
-                <a:solidFill>
-                  <a:srgbClr val="2A2A2A"/>
-                </a:solidFill>
-                <a:latin typeface="微軟正黑體"/>
-              </a:rPr>
-              <a:t>build pptx/docx + lint_ryan_feedback 12 規則</a:t>
-            </a:r>
-          </a:p>
-        </p:txBody>
-      </p:sp>
-      <p:sp>
-        <p:nvSpPr>
-          <p:cNvPr id="20" name="Oval 19"/>
-          <p:cNvSpPr/>
-          <p:nvPr/>
-        </p:nvSpPr>
-        <p:spPr>
-          <a:xfrm>
-            <a:off x="731520" y="5294376"/>
-            <a:ext cx="384048" cy="384048"/>
-          </a:xfrm>
-          <a:prstGeom prst="ellipse">
-            <a:avLst/>
-          </a:prstGeom>
-          <a:solidFill>
-            <a:srgbClr val="FFB81C"/>
-          </a:solidFill>
-          <a:ln>
-            <a:noFill/>
-          </a:ln>
-          <a:effectLst/>
-        </p:spPr>
-        <p:style>
-          <a:lnRef idx="1">
-            <a:schemeClr val="accent1"/>
-          </a:lnRef>
-          <a:fillRef idx="3">
-            <a:schemeClr val="accent1"/>
-          </a:fillRef>
-          <a:effectRef idx="2">
-            <a:schemeClr val="accent1"/>
-          </a:effectRef>
-          <a:fontRef idx="minor">
-            <a:schemeClr val="lt1"/>
-          </a:fontRef>
-        </p:style>
-        <p:txBody>
-          <a:bodyPr rtlCol="0" anchor="ctr" lIns="0" rIns="0" tIns="0" bIns="0"/>
-          <a:lstStyle/>
-          <a:p>
-            <a:pPr algn="ctr"/>
-            <a:r>
-              <a:rPr sz="1400" b="1">
-                <a:solidFill>
-                  <a:srgbClr val="101010"/>
-                </a:solidFill>
-                <a:latin typeface="Calibri"/>
-              </a:rPr>
-              <a:t>8</a:t>
-            </a:r>
-          </a:p>
-        </p:txBody>
-      </p:sp>
-      <p:sp>
-        <p:nvSpPr>
-          <p:cNvPr id="21" name="TextBox 20"/>
-          <p:cNvSpPr txBox="1"/>
-          <p:nvPr/>
-        </p:nvSpPr>
-        <p:spPr>
-          <a:xfrm>
-            <a:off x="1325880" y="5330952"/>
-            <a:ext cx="10241280" cy="457200"/>
-          </a:xfrm>
-          <a:prstGeom prst="rect">
-            <a:avLst/>
-          </a:prstGeom>
-          <a:noFill/>
-        </p:spPr>
-        <p:txBody>
-          <a:bodyPr wrap="square" anchor="t" lIns="0" rIns="0" tIns="0" bIns="0">
-            <a:spAutoFit/>
-          </a:bodyPr>
-          <a:lstStyle/>
-          <a:p>
-            <a:pPr algn="l"/>
-            <a:r>
-              <a:rPr sz="1300" b="0">
-                <a:solidFill>
-                  <a:srgbClr val="2A2A2A"/>
-                </a:solidFill>
-                <a:latin typeface="微軟正黑體"/>
-              </a:rPr>
-              <a:t>Codex audit + persona pre-screen（法人機構讀者視角）＋ quality_report A++ 簽核</a:t>
-            </a:r>
-          </a:p>
-        </p:txBody>
-      </p:sp>
-      <p:sp>
-        <p:nvSpPr>
-          <p:cNvPr id="22" name="TextBox 21"/>
-          <p:cNvSpPr txBox="1"/>
-          <p:nvPr/>
-        </p:nvSpPr>
-        <p:spPr>
-          <a:xfrm>
-            <a:off x="640080" y="6309360"/>
-            <a:ext cx="10972800" cy="320040"/>
-          </a:xfrm>
-          <a:prstGeom prst="rect">
-            <a:avLst/>
-          </a:prstGeom>
-          <a:noFill/>
-        </p:spPr>
-        <p:txBody>
-          <a:bodyPr wrap="square" anchor="t" lIns="0" rIns="0" tIns="0" bIns="0">
-            <a:spAutoFit/>
-          </a:bodyPr>
-          <a:lstStyle/>
-          <a:p>
-            <a:pPr algn="l"/>
-            <a:r>
-              <a:rPr sz="1050" b="0">
-                <a:solidFill>
-                  <a:srgbClr val="555555"/>
-                </a:solidFill>
-                <a:latin typeface="微軟正黑體"/>
-              </a:rPr>
-              <a:t>Generated 2026-07-03 | 國泰證券法人債券業務部 · 法人業務二處</a:t>
+              <a:t>左欄（無KI）的考慮在「轉換後」、右欄（EKI）的考慮在「尾部」— 加不加 EKI 是選擇管理哪種問題，不是有沒有問題。</a:t>
             </a:r>
           </a:p>
         </p:txBody>
@@ -11580,13 +12326,13 @@
         <p:spPr>
           <a:xfrm>
             <a:off x="0" y="0"/>
-            <a:ext cx="12191695" cy="6858000"/>
+            <a:ext cx="12191695" cy="320040"/>
           </a:xfrm>
           <a:prstGeom prst="rect">
             <a:avLst/>
           </a:prstGeom>
           <a:solidFill>
-            <a:srgbClr val="101010"/>
+            <a:srgbClr val="00295C"/>
           </a:solidFill>
           <a:ln>
             <a:noFill/>
@@ -11617,16 +12363,121 @@
       </p:sp>
       <p:sp>
         <p:nvSpPr>
-          <p:cNvPr id="3" name="Rectangle 2"/>
+          <p:cNvPr id="3" name="TextBox 2"/>
+          <p:cNvSpPr txBox="1"/>
+          <p:nvPr/>
+        </p:nvSpPr>
+        <p:spPr>
+          <a:xfrm>
+            <a:off x="320040" y="36576"/>
+            <a:ext cx="8229600" cy="256032"/>
+          </a:xfrm>
+          <a:prstGeom prst="rect">
+            <a:avLst/>
+          </a:prstGeom>
+          <a:noFill/>
+        </p:spPr>
+        <p:txBody>
+          <a:bodyPr wrap="square" anchor="ctr" lIns="0" rIns="0" tIns="0" bIns="0">
+            <a:spAutoFit/>
+          </a:bodyPr>
+          <a:lstStyle/>
+          <a:p>
+            <a:pPr algn="l"/>
+            <a:r>
+              <a:rPr sz="1100" b="1">
+                <a:solidFill>
+                  <a:srgbClr val="FFFFFF"/>
+                </a:solidFill>
+                <a:latin typeface="微軟正黑體"/>
+              </a:rPr>
+              <a:t>STRUCTURED PRODUCTS  |  FCN WEEKLY | KI/KO EXPECTED VALUE</a:t>
+            </a:r>
+          </a:p>
+        </p:txBody>
+      </p:sp>
+      <p:sp>
+        <p:nvSpPr>
+          <p:cNvPr id="4" name="TextBox 3"/>
+          <p:cNvSpPr txBox="1"/>
+          <p:nvPr/>
+        </p:nvSpPr>
+        <p:spPr>
+          <a:xfrm>
+            <a:off x="11247120" y="36576"/>
+            <a:ext cx="640080" cy="256032"/>
+          </a:xfrm>
+          <a:prstGeom prst="rect">
+            <a:avLst/>
+          </a:prstGeom>
+          <a:noFill/>
+        </p:spPr>
+        <p:txBody>
+          <a:bodyPr wrap="square" anchor="ctr" lIns="0" rIns="0" tIns="0" bIns="0">
+            <a:spAutoFit/>
+          </a:bodyPr>
+          <a:lstStyle/>
+          <a:p>
+            <a:pPr algn="r"/>
+            <a:r>
+              <a:rPr sz="1100" b="1">
+                <a:solidFill>
+                  <a:srgbClr val="FFB81C"/>
+                </a:solidFill>
+                <a:latin typeface="微軟正黑體"/>
+              </a:rPr>
+              <a:t>9</a:t>
+            </a:r>
+          </a:p>
+        </p:txBody>
+      </p:sp>
+      <p:sp>
+        <p:nvSpPr>
+          <p:cNvPr id="5" name="TextBox 4"/>
+          <p:cNvSpPr txBox="1"/>
+          <p:nvPr/>
+        </p:nvSpPr>
+        <p:spPr>
+          <a:xfrm>
+            <a:off x="640080" y="502920"/>
+            <a:ext cx="10972800" cy="457200"/>
+          </a:xfrm>
+          <a:prstGeom prst="rect">
+            <a:avLst/>
+          </a:prstGeom>
+          <a:noFill/>
+        </p:spPr>
+        <p:txBody>
+          <a:bodyPr wrap="square" anchor="t" lIns="0" rIns="0" tIns="0" bIns="0">
+            <a:spAutoFit/>
+          </a:bodyPr>
+          <a:lstStyle/>
+          <a:p>
+            <a:pPr algn="l"/>
+            <a:r>
+              <a:rPr sz="2400" b="1">
+                <a:solidFill>
+                  <a:srgbClr val="101010"/>
+                </a:solidFill>
+                <a:latin typeface="微軟正黑體"/>
+              </a:rPr>
+              <a:t>五  Monday 待決策</a:t>
+            </a:r>
+          </a:p>
+        </p:txBody>
+      </p:sp>
+      <p:sp>
+        <p:nvSpPr>
+          <p:cNvPr id="6" name="Oval 5"/>
           <p:cNvSpPr/>
           <p:nvPr/>
         </p:nvSpPr>
         <p:spPr>
           <a:xfrm>
-            <a:off x="640080" y="3017520"/>
-            <a:ext cx="2011680" cy="38100"/>
-          </a:xfrm>
-          <a:prstGeom prst="rect">
+            <a:off x="731520" y="1325880"/>
+            <a:ext cx="384048" cy="384048"/>
+          </a:xfrm>
+          <a:prstGeom prst="ellipse">
             <a:avLst/>
           </a:prstGeom>
           <a:solidFill>
@@ -11652,23 +12503,32 @@
           </a:fontRef>
         </p:style>
         <p:txBody>
-          <a:bodyPr rtlCol="0" anchor="ctr"/>
+          <a:bodyPr rtlCol="0" anchor="ctr" lIns="0" rIns="0" tIns="0" bIns="0"/>
           <a:lstStyle/>
           <a:p>
             <a:pPr algn="ctr"/>
-          </a:p>
-        </p:txBody>
-      </p:sp>
-      <p:sp>
-        <p:nvSpPr>
-          <p:cNvPr id="4" name="TextBox 3"/>
+            <a:r>
+              <a:rPr sz="1400" b="1">
+                <a:solidFill>
+                  <a:srgbClr val="101010"/>
+                </a:solidFill>
+                <a:latin typeface="Calibri"/>
+              </a:rPr>
+              <a:t>1</a:t>
+            </a:r>
+          </a:p>
+        </p:txBody>
+      </p:sp>
+      <p:sp>
+        <p:nvSpPr>
+          <p:cNvPr id="7" name="TextBox 6"/>
           <p:cNvSpPr txBox="1"/>
           <p:nvPr/>
         </p:nvSpPr>
         <p:spPr>
           <a:xfrm>
-            <a:off x="640080" y="3246120"/>
-            <a:ext cx="10881360" cy="1463040"/>
+            <a:off x="1325880" y="1362456"/>
+            <a:ext cx="10241280" cy="457200"/>
           </a:xfrm>
           <a:prstGeom prst="rect">
             <a:avLst/>
@@ -11681,51 +12541,666 @@
           </a:bodyPr>
           <a:lstStyle/>
           <a:p>
-            <a:pPr algn="l">
-              <a:lnSpc>
-                <a:spcPct val="150000"/>
-              </a:lnSpc>
-            </a:pPr>
-            <a:r>
-              <a:rPr sz="3000" b="1">
-                <a:solidFill>
-                  <a:srgbClr val="FFFFFF"/>
-                </a:solidFill>
-                <a:latin typeface="微軟正黑體"/>
-              </a:rPr>
-              <a:t>FCN Weekly — KI/KO 期望值週報</a:t>
-            </a:r>
-          </a:p>
-          <a:p>
-            <a:pPr algn="l">
-              <a:lnSpc>
-                <a:spcPct val="150000"/>
-              </a:lnSpc>
-            </a:pPr>
-            <a:r>
-              <a:rPr sz="1400" b="0">
-                <a:solidFill>
-                  <a:srgbClr val="FFB81C"/>
-                </a:solidFill>
-                <a:latin typeface="微軟正黑體"/>
-              </a:rPr>
-              <a:t>20260706 期  |  v0 partial scan  |  Monday 校正後定稿</a:t>
-            </a:r>
-          </a:p>
-          <a:p>
-            <a:pPr algn="l">
-              <a:lnSpc>
-                <a:spcPct val="150000"/>
-              </a:lnSpc>
-            </a:pPr>
-            <a:r>
-              <a:rPr sz="1100" b="0">
-                <a:solidFill>
-                  <a:srgbClr val="E8E8E8"/>
-                </a:solidFill>
-                <a:latin typeface="微軟正黑體"/>
-              </a:rPr>
-              <a:t>本簡報之票息與條款均為示意，非報價；投資決策以正式產品文件為準。</a:t>
+            <a:pPr algn="l"/>
+            <a:r>
+              <a:rPr sz="1300" b="0">
+                <a:solidFill>
+                  <a:srgbClr val="2A2A2A"/>
+                </a:solidFill>
+                <a:latin typeface="微軟正黑體"/>
+              </a:rPr>
+              <a:t>議題組合確認：1 主 + 2 補充（建議 01 存量健檢 + 05 防禦對照 + 06 TSLA 教材）</a:t>
+            </a:r>
+          </a:p>
+        </p:txBody>
+      </p:sp>
+      <p:sp>
+        <p:nvSpPr>
+          <p:cNvPr id="8" name="Oval 7"/>
+          <p:cNvSpPr/>
+          <p:nvPr/>
+        </p:nvSpPr>
+        <p:spPr>
+          <a:xfrm>
+            <a:off x="731520" y="1892808"/>
+            <a:ext cx="384048" cy="384048"/>
+          </a:xfrm>
+          <a:prstGeom prst="ellipse">
+            <a:avLst/>
+          </a:prstGeom>
+          <a:solidFill>
+            <a:srgbClr val="FFB81C"/>
+          </a:solidFill>
+          <a:ln>
+            <a:noFill/>
+          </a:ln>
+          <a:effectLst/>
+        </p:spPr>
+        <p:style>
+          <a:lnRef idx="1">
+            <a:schemeClr val="accent1"/>
+          </a:lnRef>
+          <a:fillRef idx="3">
+            <a:schemeClr val="accent1"/>
+          </a:fillRef>
+          <a:effectRef idx="2">
+            <a:schemeClr val="accent1"/>
+          </a:effectRef>
+          <a:fontRef idx="minor">
+            <a:schemeClr val="lt1"/>
+          </a:fontRef>
+        </p:style>
+        <p:txBody>
+          <a:bodyPr rtlCol="0" anchor="ctr" lIns="0" rIns="0" tIns="0" bIns="0"/>
+          <a:lstStyle/>
+          <a:p>
+            <a:pPr algn="ctr"/>
+            <a:r>
+              <a:rPr sz="1400" b="1">
+                <a:solidFill>
+                  <a:srgbClr val="101010"/>
+                </a:solidFill>
+                <a:latin typeface="Calibri"/>
+              </a:rPr>
+              <a:t>2</a:t>
+            </a:r>
+          </a:p>
+        </p:txBody>
+      </p:sp>
+      <p:sp>
+        <p:nvSpPr>
+          <p:cNvPr id="9" name="TextBox 8"/>
+          <p:cNvSpPr txBox="1"/>
+          <p:nvPr/>
+        </p:nvSpPr>
+        <p:spPr>
+          <a:xfrm>
+            <a:off x="1325880" y="1929384"/>
+            <a:ext cx="10241280" cy="457200"/>
+          </a:xfrm>
+          <a:prstGeom prst="rect">
+            <a:avLst/>
+          </a:prstGeom>
+          <a:noFill/>
+        </p:spPr>
+        <p:txBody>
+          <a:bodyPr wrap="square" anchor="t" lIns="0" rIns="0" tIns="0" bIns="0">
+            <a:spAutoFit/>
+          </a:bodyPr>
+          <a:lstStyle/>
+          <a:p>
+            <a:pPr algn="l"/>
+            <a:r>
+              <a:rPr sz="1300" b="0">
+                <a:solidFill>
+                  <a:srgbClr val="2A2A2A"/>
+                </a:solidFill>
+                <a:latin typeface="微軟正黑體"/>
+              </a:rPr>
+              <a:t>重抓 yfinance 校正全部 est. 數字（本週 4 交易日已完整）</a:t>
+            </a:r>
+          </a:p>
+        </p:txBody>
+      </p:sp>
+      <p:sp>
+        <p:nvSpPr>
+          <p:cNvPr id="10" name="Oval 9"/>
+          <p:cNvSpPr/>
+          <p:nvPr/>
+        </p:nvSpPr>
+        <p:spPr>
+          <a:xfrm>
+            <a:off x="731520" y="2459736"/>
+            <a:ext cx="384048" cy="384048"/>
+          </a:xfrm>
+          <a:prstGeom prst="ellipse">
+            <a:avLst/>
+          </a:prstGeom>
+          <a:solidFill>
+            <a:srgbClr val="FFB81C"/>
+          </a:solidFill>
+          <a:ln>
+            <a:noFill/>
+          </a:ln>
+          <a:effectLst/>
+        </p:spPr>
+        <p:style>
+          <a:lnRef idx="1">
+            <a:schemeClr val="accent1"/>
+          </a:lnRef>
+          <a:fillRef idx="3">
+            <a:schemeClr val="accent1"/>
+          </a:fillRef>
+          <a:effectRef idx="2">
+            <a:schemeClr val="accent1"/>
+          </a:effectRef>
+          <a:fontRef idx="minor">
+            <a:schemeClr val="lt1"/>
+          </a:fontRef>
+        </p:style>
+        <p:txBody>
+          <a:bodyPr rtlCol="0" anchor="ctr" lIns="0" rIns="0" tIns="0" bIns="0"/>
+          <a:lstStyle/>
+          <a:p>
+            <a:pPr algn="ctr"/>
+            <a:r>
+              <a:rPr sz="1400" b="1">
+                <a:solidFill>
+                  <a:srgbClr val="101010"/>
+                </a:solidFill>
+                <a:latin typeface="Calibri"/>
+              </a:rPr>
+              <a:t>3</a:t>
+            </a:r>
+          </a:p>
+        </p:txBody>
+      </p:sp>
+      <p:sp>
+        <p:nvSpPr>
+          <p:cNvPr id="11" name="TextBox 10"/>
+          <p:cNvSpPr txBox="1"/>
+          <p:nvPr/>
+        </p:nvSpPr>
+        <p:spPr>
+          <a:xfrm>
+            <a:off x="1325880" y="2496312"/>
+            <a:ext cx="10241280" cy="457200"/>
+          </a:xfrm>
+          <a:prstGeom prst="rect">
+            <a:avLst/>
+          </a:prstGeom>
+          <a:noFill/>
+        </p:spPr>
+        <p:txBody>
+          <a:bodyPr wrap="square" anchor="t" lIns="0" rIns="0" tIns="0" bIns="0">
+            <a:spAutoFit/>
+          </a:bodyPr>
+          <a:lstStyle/>
+          <a:p>
+            <a:pPr algn="l"/>
+            <a:r>
+              <a:rPr sz="1300" b="0">
+                <a:solidFill>
+                  <a:srgbClr val="2A2A2A"/>
+                </a:solidFill>
+                <a:latin typeface="微軟正黑體"/>
+              </a:rPr>
+              <a:t>存續 FCN 部位盤點：半導體單一股 vintage 清單 + 各筆距 KI 緩衝計算</a:t>
+            </a:r>
+          </a:p>
+        </p:txBody>
+      </p:sp>
+      <p:sp>
+        <p:nvSpPr>
+          <p:cNvPr id="12" name="Oval 11"/>
+          <p:cNvSpPr/>
+          <p:nvPr/>
+        </p:nvSpPr>
+        <p:spPr>
+          <a:xfrm>
+            <a:off x="731520" y="3026664"/>
+            <a:ext cx="384048" cy="384048"/>
+          </a:xfrm>
+          <a:prstGeom prst="ellipse">
+            <a:avLst/>
+          </a:prstGeom>
+          <a:solidFill>
+            <a:srgbClr val="FFB81C"/>
+          </a:solidFill>
+          <a:ln>
+            <a:noFill/>
+          </a:ln>
+          <a:effectLst/>
+        </p:spPr>
+        <p:style>
+          <a:lnRef idx="1">
+            <a:schemeClr val="accent1"/>
+          </a:lnRef>
+          <a:fillRef idx="3">
+            <a:schemeClr val="accent1"/>
+          </a:fillRef>
+          <a:effectRef idx="2">
+            <a:schemeClr val="accent1"/>
+          </a:effectRef>
+          <a:fontRef idx="minor">
+            <a:schemeClr val="lt1"/>
+          </a:fontRef>
+        </p:style>
+        <p:txBody>
+          <a:bodyPr rtlCol="0" anchor="ctr" lIns="0" rIns="0" tIns="0" bIns="0"/>
+          <a:lstStyle/>
+          <a:p>
+            <a:pPr algn="ctr"/>
+            <a:r>
+              <a:rPr sz="1400" b="1">
+                <a:solidFill>
+                  <a:srgbClr val="101010"/>
+                </a:solidFill>
+                <a:latin typeface="Calibri"/>
+              </a:rPr>
+              <a:t>4</a:t>
+            </a:r>
+          </a:p>
+        </p:txBody>
+      </p:sp>
+      <p:sp>
+        <p:nvSpPr>
+          <p:cNvPr id="13" name="TextBox 12"/>
+          <p:cNvSpPr txBox="1"/>
+          <p:nvPr/>
+        </p:nvSpPr>
+        <p:spPr>
+          <a:xfrm>
+            <a:off x="1325880" y="3063240"/>
+            <a:ext cx="10241280" cy="457200"/>
+          </a:xfrm>
+          <a:prstGeom prst="rect">
+            <a:avLst/>
+          </a:prstGeom>
+          <a:noFill/>
+        </p:spPr>
+        <p:txBody>
+          <a:bodyPr wrap="square" anchor="t" lIns="0" rIns="0" tIns="0" bIns="0">
+            <a:spAutoFit/>
+          </a:bodyPr>
+          <a:lstStyle/>
+          <a:p>
+            <a:pPr algn="l"/>
+            <a:r>
+              <a:rPr sz="1300" b="0">
+                <a:solidFill>
+                  <a:srgbClr val="2A2A2A"/>
+                </a:solidFill>
+                <a:latin typeface="微軟正黑體"/>
+              </a:rPr>
+              <a:t>向交易台索取 NVDA/MU/TSLA/TSM 6M ATM IV 與 indicative coupon，替換示意值</a:t>
+            </a:r>
+          </a:p>
+        </p:txBody>
+      </p:sp>
+      <p:sp>
+        <p:nvSpPr>
+          <p:cNvPr id="14" name="Oval 13"/>
+          <p:cNvSpPr/>
+          <p:nvPr/>
+        </p:nvSpPr>
+        <p:spPr>
+          <a:xfrm>
+            <a:off x="731520" y="3593592"/>
+            <a:ext cx="384048" cy="384048"/>
+          </a:xfrm>
+          <a:prstGeom prst="ellipse">
+            <a:avLst/>
+          </a:prstGeom>
+          <a:solidFill>
+            <a:srgbClr val="FFB81C"/>
+          </a:solidFill>
+          <a:ln>
+            <a:noFill/>
+          </a:ln>
+          <a:effectLst/>
+        </p:spPr>
+        <p:style>
+          <a:lnRef idx="1">
+            <a:schemeClr val="accent1"/>
+          </a:lnRef>
+          <a:fillRef idx="3">
+            <a:schemeClr val="accent1"/>
+          </a:fillRef>
+          <a:effectRef idx="2">
+            <a:schemeClr val="accent1"/>
+          </a:effectRef>
+          <a:fontRef idx="minor">
+            <a:schemeClr val="lt1"/>
+          </a:fontRef>
+        </p:style>
+        <p:txBody>
+          <a:bodyPr rtlCol="0" anchor="ctr" lIns="0" rIns="0" tIns="0" bIns="0"/>
+          <a:lstStyle/>
+          <a:p>
+            <a:pPr algn="ctr"/>
+            <a:r>
+              <a:rPr sz="1400" b="1">
+                <a:solidFill>
+                  <a:srgbClr val="101010"/>
+                </a:solidFill>
+                <a:latin typeface="Calibri"/>
+              </a:rPr>
+              <a:t>5</a:t>
+            </a:r>
+          </a:p>
+        </p:txBody>
+      </p:sp>
+      <p:sp>
+        <p:nvSpPr>
+          <p:cNvPr id="15" name="TextBox 14"/>
+          <p:cNvSpPr txBox="1"/>
+          <p:nvPr/>
+        </p:nvSpPr>
+        <p:spPr>
+          <a:xfrm>
+            <a:off x="1325880" y="3630168"/>
+            <a:ext cx="10241280" cy="457200"/>
+          </a:xfrm>
+          <a:prstGeom prst="rect">
+            <a:avLst/>
+          </a:prstGeom>
+          <a:noFill/>
+        </p:spPr>
+        <p:txBody>
+          <a:bodyPr wrap="square" anchor="t" lIns="0" rIns="0" tIns="0" bIns="0">
+            <a:spAutoFit/>
+          </a:bodyPr>
+          <a:lstStyle/>
+          <a:p>
+            <a:pPr algn="l"/>
+            <a:r>
+              <a:rPr sz="1300" b="0">
+                <a:solidFill>
+                  <a:srgbClr val="2A2A2A"/>
+                </a:solidFill>
+                <a:latin typeface="微軟正黑體"/>
+              </a:rPr>
+              <a:t>NLM saturation Round 1+ 加 Codex Gate 3 平行驗證</a:t>
+            </a:r>
+          </a:p>
+        </p:txBody>
+      </p:sp>
+      <p:sp>
+        <p:nvSpPr>
+          <p:cNvPr id="16" name="Oval 15"/>
+          <p:cNvSpPr/>
+          <p:nvPr/>
+        </p:nvSpPr>
+        <p:spPr>
+          <a:xfrm>
+            <a:off x="731520" y="4160520"/>
+            <a:ext cx="384048" cy="384048"/>
+          </a:xfrm>
+          <a:prstGeom prst="ellipse">
+            <a:avLst/>
+          </a:prstGeom>
+          <a:solidFill>
+            <a:srgbClr val="FFB81C"/>
+          </a:solidFill>
+          <a:ln>
+            <a:noFill/>
+          </a:ln>
+          <a:effectLst/>
+        </p:spPr>
+        <p:style>
+          <a:lnRef idx="1">
+            <a:schemeClr val="accent1"/>
+          </a:lnRef>
+          <a:fillRef idx="3">
+            <a:schemeClr val="accent1"/>
+          </a:fillRef>
+          <a:effectRef idx="2">
+            <a:schemeClr val="accent1"/>
+          </a:effectRef>
+          <a:fontRef idx="minor">
+            <a:schemeClr val="lt1"/>
+          </a:fontRef>
+        </p:style>
+        <p:txBody>
+          <a:bodyPr rtlCol="0" anchor="ctr" lIns="0" rIns="0" tIns="0" bIns="0"/>
+          <a:lstStyle/>
+          <a:p>
+            <a:pPr algn="ctr"/>
+            <a:r>
+              <a:rPr sz="1400" b="1">
+                <a:solidFill>
+                  <a:srgbClr val="101010"/>
+                </a:solidFill>
+                <a:latin typeface="Calibri"/>
+              </a:rPr>
+              <a:t>6</a:t>
+            </a:r>
+          </a:p>
+        </p:txBody>
+      </p:sp>
+      <p:sp>
+        <p:nvSpPr>
+          <p:cNvPr id="17" name="TextBox 16"/>
+          <p:cNvSpPr txBox="1"/>
+          <p:nvPr/>
+        </p:nvSpPr>
+        <p:spPr>
+          <a:xfrm>
+            <a:off x="1325880" y="4197096"/>
+            <a:ext cx="10241280" cy="457200"/>
+          </a:xfrm>
+          <a:prstGeom prst="rect">
+            <a:avLst/>
+          </a:prstGeom>
+          <a:noFill/>
+        </p:spPr>
+        <p:txBody>
+          <a:bodyPr wrap="square" anchor="t" lIns="0" rIns="0" tIns="0" bIns="0">
+            <a:spAutoFit/>
+          </a:bodyPr>
+          <a:lstStyle/>
+          <a:p>
+            <a:pPr algn="l"/>
+            <a:r>
+              <a:rPr sz="1300" b="0">
+                <a:solidFill>
+                  <a:srgbClr val="2A2A2A"/>
+                </a:solidFill>
+                <a:latin typeface="微軟正黑體"/>
+              </a:rPr>
+              <a:t>寫 reading_map.md + 底稿.md（UWS 12 章節）</a:t>
+            </a:r>
+          </a:p>
+        </p:txBody>
+      </p:sp>
+      <p:sp>
+        <p:nvSpPr>
+          <p:cNvPr id="18" name="Oval 17"/>
+          <p:cNvSpPr/>
+          <p:nvPr/>
+        </p:nvSpPr>
+        <p:spPr>
+          <a:xfrm>
+            <a:off x="731520" y="4727448"/>
+            <a:ext cx="384048" cy="384048"/>
+          </a:xfrm>
+          <a:prstGeom prst="ellipse">
+            <a:avLst/>
+          </a:prstGeom>
+          <a:solidFill>
+            <a:srgbClr val="FFB81C"/>
+          </a:solidFill>
+          <a:ln>
+            <a:noFill/>
+          </a:ln>
+          <a:effectLst/>
+        </p:spPr>
+        <p:style>
+          <a:lnRef idx="1">
+            <a:schemeClr val="accent1"/>
+          </a:lnRef>
+          <a:fillRef idx="3">
+            <a:schemeClr val="accent1"/>
+          </a:fillRef>
+          <a:effectRef idx="2">
+            <a:schemeClr val="accent1"/>
+          </a:effectRef>
+          <a:fontRef idx="minor">
+            <a:schemeClr val="lt1"/>
+          </a:fontRef>
+        </p:style>
+        <p:txBody>
+          <a:bodyPr rtlCol="0" anchor="ctr" lIns="0" rIns="0" tIns="0" bIns="0"/>
+          <a:lstStyle/>
+          <a:p>
+            <a:pPr algn="ctr"/>
+            <a:r>
+              <a:rPr sz="1400" b="1">
+                <a:solidFill>
+                  <a:srgbClr val="101010"/>
+                </a:solidFill>
+                <a:latin typeface="Calibri"/>
+              </a:rPr>
+              <a:t>7</a:t>
+            </a:r>
+          </a:p>
+        </p:txBody>
+      </p:sp>
+      <p:sp>
+        <p:nvSpPr>
+          <p:cNvPr id="19" name="TextBox 18"/>
+          <p:cNvSpPr txBox="1"/>
+          <p:nvPr/>
+        </p:nvSpPr>
+        <p:spPr>
+          <a:xfrm>
+            <a:off x="1325880" y="4764024"/>
+            <a:ext cx="10241280" cy="457200"/>
+          </a:xfrm>
+          <a:prstGeom prst="rect">
+            <a:avLst/>
+          </a:prstGeom>
+          <a:noFill/>
+        </p:spPr>
+        <p:txBody>
+          <a:bodyPr wrap="square" anchor="t" lIns="0" rIns="0" tIns="0" bIns="0">
+            <a:spAutoFit/>
+          </a:bodyPr>
+          <a:lstStyle/>
+          <a:p>
+            <a:pPr algn="l"/>
+            <a:r>
+              <a:rPr sz="1300" b="0">
+                <a:solidFill>
+                  <a:srgbClr val="2A2A2A"/>
+                </a:solidFill>
+                <a:latin typeface="微軟正黑體"/>
+              </a:rPr>
+              <a:t>build pptx/docx + lint_ryan_feedback 12 規則</a:t>
+            </a:r>
+          </a:p>
+        </p:txBody>
+      </p:sp>
+      <p:sp>
+        <p:nvSpPr>
+          <p:cNvPr id="20" name="Oval 19"/>
+          <p:cNvSpPr/>
+          <p:nvPr/>
+        </p:nvSpPr>
+        <p:spPr>
+          <a:xfrm>
+            <a:off x="731520" y="5294376"/>
+            <a:ext cx="384048" cy="384048"/>
+          </a:xfrm>
+          <a:prstGeom prst="ellipse">
+            <a:avLst/>
+          </a:prstGeom>
+          <a:solidFill>
+            <a:srgbClr val="FFB81C"/>
+          </a:solidFill>
+          <a:ln>
+            <a:noFill/>
+          </a:ln>
+          <a:effectLst/>
+        </p:spPr>
+        <p:style>
+          <a:lnRef idx="1">
+            <a:schemeClr val="accent1"/>
+          </a:lnRef>
+          <a:fillRef idx="3">
+            <a:schemeClr val="accent1"/>
+          </a:fillRef>
+          <a:effectRef idx="2">
+            <a:schemeClr val="accent1"/>
+          </a:effectRef>
+          <a:fontRef idx="minor">
+            <a:schemeClr val="lt1"/>
+          </a:fontRef>
+        </p:style>
+        <p:txBody>
+          <a:bodyPr rtlCol="0" anchor="ctr" lIns="0" rIns="0" tIns="0" bIns="0"/>
+          <a:lstStyle/>
+          <a:p>
+            <a:pPr algn="ctr"/>
+            <a:r>
+              <a:rPr sz="1400" b="1">
+                <a:solidFill>
+                  <a:srgbClr val="101010"/>
+                </a:solidFill>
+                <a:latin typeface="Calibri"/>
+              </a:rPr>
+              <a:t>8</a:t>
+            </a:r>
+          </a:p>
+        </p:txBody>
+      </p:sp>
+      <p:sp>
+        <p:nvSpPr>
+          <p:cNvPr id="21" name="TextBox 20"/>
+          <p:cNvSpPr txBox="1"/>
+          <p:nvPr/>
+        </p:nvSpPr>
+        <p:spPr>
+          <a:xfrm>
+            <a:off x="1325880" y="5330952"/>
+            <a:ext cx="10241280" cy="457200"/>
+          </a:xfrm>
+          <a:prstGeom prst="rect">
+            <a:avLst/>
+          </a:prstGeom>
+          <a:noFill/>
+        </p:spPr>
+        <p:txBody>
+          <a:bodyPr wrap="square" anchor="t" lIns="0" rIns="0" tIns="0" bIns="0">
+            <a:spAutoFit/>
+          </a:bodyPr>
+          <a:lstStyle/>
+          <a:p>
+            <a:pPr algn="l"/>
+            <a:r>
+              <a:rPr sz="1300" b="0">
+                <a:solidFill>
+                  <a:srgbClr val="2A2A2A"/>
+                </a:solidFill>
+                <a:latin typeface="微軟正黑體"/>
+              </a:rPr>
+              <a:t>Codex audit + persona pre-screen（法人機構讀者視角）＋ quality_report A++ 簽核</a:t>
+            </a:r>
+          </a:p>
+        </p:txBody>
+      </p:sp>
+      <p:sp>
+        <p:nvSpPr>
+          <p:cNvPr id="22" name="TextBox 21"/>
+          <p:cNvSpPr txBox="1"/>
+          <p:nvPr/>
+        </p:nvSpPr>
+        <p:spPr>
+          <a:xfrm>
+            <a:off x="640080" y="6309360"/>
+            <a:ext cx="10972800" cy="320040"/>
+          </a:xfrm>
+          <a:prstGeom prst="rect">
+            <a:avLst/>
+          </a:prstGeom>
+          <a:noFill/>
+        </p:spPr>
+        <p:txBody>
+          <a:bodyPr wrap="square" anchor="t" lIns="0" rIns="0" tIns="0" bIns="0">
+            <a:spAutoFit/>
+          </a:bodyPr>
+          <a:lstStyle/>
+          <a:p>
+            <a:pPr algn="l"/>
+            <a:r>
+              <a:rPr sz="1050" b="0">
+                <a:solidFill>
+                  <a:srgbClr val="555555"/>
+                </a:solidFill>
+                <a:latin typeface="微軟正黑體"/>
+              </a:rPr>
+              <a:t>Generated 2026-07-03 | 國泰證券法人債券業務部 · 法人業務二處</a:t>
             </a:r>
           </a:p>
         </p:txBody>

</xml_diff>